<commit_message>
Some work on third controller for use as calibration tool. Some other related controller work as well.
</commit_message>
<xml_diff>
--- a/docs/Controller Mappings & Paths.pptx
+++ b/docs/Controller Mappings & Paths.pptx
@@ -265,7 +265,7 @@
           <a:p>
             <a:fld id="{B6000E93-69C7-4C90-931E-A5484B820028}" type="datetimeFigureOut">
               <a:rPr lang="en-US" smtClean="0"/>
-              <a:t>2/16/2026</a:t>
+              <a:t>2/23/2026</a:t>
             </a:fld>
             <a:endParaRPr lang="en-US"/>
           </a:p>
@@ -463,7 +463,7 @@
           <a:p>
             <a:fld id="{B6000E93-69C7-4C90-931E-A5484B820028}" type="datetimeFigureOut">
               <a:rPr lang="en-US" smtClean="0"/>
-              <a:t>2/16/2026</a:t>
+              <a:t>2/23/2026</a:t>
             </a:fld>
             <a:endParaRPr lang="en-US"/>
           </a:p>
@@ -671,7 +671,7 @@
           <a:p>
             <a:fld id="{B6000E93-69C7-4C90-931E-A5484B820028}" type="datetimeFigureOut">
               <a:rPr lang="en-US" smtClean="0"/>
-              <a:t>2/16/2026</a:t>
+              <a:t>2/23/2026</a:t>
             </a:fld>
             <a:endParaRPr lang="en-US"/>
           </a:p>
@@ -869,7 +869,7 @@
           <a:p>
             <a:fld id="{B6000E93-69C7-4C90-931E-A5484B820028}" type="datetimeFigureOut">
               <a:rPr lang="en-US" smtClean="0"/>
-              <a:t>2/16/2026</a:t>
+              <a:t>2/23/2026</a:t>
             </a:fld>
             <a:endParaRPr lang="en-US"/>
           </a:p>
@@ -1144,7 +1144,7 @@
           <a:p>
             <a:fld id="{B6000E93-69C7-4C90-931E-A5484B820028}" type="datetimeFigureOut">
               <a:rPr lang="en-US" smtClean="0"/>
-              <a:t>2/16/2026</a:t>
+              <a:t>2/23/2026</a:t>
             </a:fld>
             <a:endParaRPr lang="en-US"/>
           </a:p>
@@ -1409,7 +1409,7 @@
           <a:p>
             <a:fld id="{B6000E93-69C7-4C90-931E-A5484B820028}" type="datetimeFigureOut">
               <a:rPr lang="en-US" smtClean="0"/>
-              <a:t>2/16/2026</a:t>
+              <a:t>2/23/2026</a:t>
             </a:fld>
             <a:endParaRPr lang="en-US"/>
           </a:p>
@@ -1821,7 +1821,7 @@
           <a:p>
             <a:fld id="{B6000E93-69C7-4C90-931E-A5484B820028}" type="datetimeFigureOut">
               <a:rPr lang="en-US" smtClean="0"/>
-              <a:t>2/16/2026</a:t>
+              <a:t>2/23/2026</a:t>
             </a:fld>
             <a:endParaRPr lang="en-US"/>
           </a:p>
@@ -1962,7 +1962,7 @@
           <a:p>
             <a:fld id="{B6000E93-69C7-4C90-931E-A5484B820028}" type="datetimeFigureOut">
               <a:rPr lang="en-US" smtClean="0"/>
-              <a:t>2/16/2026</a:t>
+              <a:t>2/23/2026</a:t>
             </a:fld>
             <a:endParaRPr lang="en-US"/>
           </a:p>
@@ -2075,7 +2075,7 @@
           <a:p>
             <a:fld id="{B6000E93-69C7-4C90-931E-A5484B820028}" type="datetimeFigureOut">
               <a:rPr lang="en-US" smtClean="0"/>
-              <a:t>2/16/2026</a:t>
+              <a:t>2/23/2026</a:t>
             </a:fld>
             <a:endParaRPr lang="en-US"/>
           </a:p>
@@ -2386,7 +2386,7 @@
           <a:p>
             <a:fld id="{B6000E93-69C7-4C90-931E-A5484B820028}" type="datetimeFigureOut">
               <a:rPr lang="en-US" smtClean="0"/>
-              <a:t>2/16/2026</a:t>
+              <a:t>2/23/2026</a:t>
             </a:fld>
             <a:endParaRPr lang="en-US"/>
           </a:p>
@@ -2674,7 +2674,7 @@
           <a:p>
             <a:fld id="{B6000E93-69C7-4C90-931E-A5484B820028}" type="datetimeFigureOut">
               <a:rPr lang="en-US" smtClean="0"/>
-              <a:t>2/16/2026</a:t>
+              <a:t>2/23/2026</a:t>
             </a:fld>
             <a:endParaRPr lang="en-US"/>
           </a:p>
@@ -2915,7 +2915,7 @@
           <a:p>
             <a:fld id="{B6000E93-69C7-4C90-931E-A5484B820028}" type="datetimeFigureOut">
               <a:rPr lang="en-US" smtClean="0"/>
-              <a:t>2/16/2026</a:t>
+              <a:t>2/23/2026</a:t>
             </a:fld>
             <a:endParaRPr lang="en-US"/>
           </a:p>
@@ -5317,6 +5317,92 @@
           </p:txBody>
         </p:sp>
       </p:grpSp>
+      <p:sp>
+        <p:nvSpPr>
+          <p:cNvPr id="23" name="TextBox 22">
+            <a:extLst>
+              <a:ext uri="{FF2B5EF4-FFF2-40B4-BE49-F238E27FC236}">
+                <a16:creationId xmlns:a16="http://schemas.microsoft.com/office/drawing/2014/main" id="{C91A3CDA-940D-348D-BCAF-490642C36BE9}"/>
+              </a:ext>
+            </a:extLst>
+          </p:cNvPr>
+          <p:cNvSpPr txBox="1"/>
+          <p:nvPr/>
+        </p:nvSpPr>
+        <p:spPr>
+          <a:xfrm rot="5400000">
+            <a:off x="6374581" y="3926180"/>
+            <a:ext cx="276999" cy="306301"/>
+          </a:xfrm>
+          <a:prstGeom prst="rect">
+            <a:avLst/>
+          </a:prstGeom>
+          <a:noFill/>
+        </p:spPr>
+        <p:txBody>
+          <a:bodyPr vert="vert270" wrap="none" lIns="0" tIns="0" rIns="91440" bIns="0" rtlCol="0">
+            <a:spAutoFit/>
+          </a:bodyPr>
+          <a:lstStyle/>
+          <a:p>
+            <a:pPr algn="ctr"/>
+            <a:r>
+              <a:rPr lang="en-US" sz="1200" dirty="0">
+                <a:solidFill>
+                  <a:schemeClr val="accent2">
+                    <a:lumMod val="60000"/>
+                    <a:lumOff val="40000"/>
+                  </a:schemeClr>
+                </a:solidFill>
+              </a:rPr>
+              <a:t>start</a:t>
+            </a:r>
+          </a:p>
+        </p:txBody>
+      </p:sp>
+      <p:sp>
+        <p:nvSpPr>
+          <p:cNvPr id="37" name="TextBox 36">
+            <a:extLst>
+              <a:ext uri="{FF2B5EF4-FFF2-40B4-BE49-F238E27FC236}">
+                <a16:creationId xmlns:a16="http://schemas.microsoft.com/office/drawing/2014/main" id="{D8B36C15-FF92-3AEC-5434-F1B9809B8308}"/>
+              </a:ext>
+            </a:extLst>
+          </p:cNvPr>
+          <p:cNvSpPr txBox="1"/>
+          <p:nvPr/>
+        </p:nvSpPr>
+        <p:spPr>
+          <a:xfrm rot="5400000">
+            <a:off x="5583361" y="3917427"/>
+            <a:ext cx="276999" cy="323808"/>
+          </a:xfrm>
+          <a:prstGeom prst="rect">
+            <a:avLst/>
+          </a:prstGeom>
+          <a:noFill/>
+        </p:spPr>
+        <p:txBody>
+          <a:bodyPr vert="vert270" wrap="none" lIns="0" tIns="0" rIns="91440" bIns="0" rtlCol="0">
+            <a:spAutoFit/>
+          </a:bodyPr>
+          <a:lstStyle/>
+          <a:p>
+            <a:pPr algn="ctr"/>
+            <a:r>
+              <a:rPr lang="en-US" sz="1200" dirty="0">
+                <a:solidFill>
+                  <a:schemeClr val="accent2">
+                    <a:lumMod val="60000"/>
+                    <a:lumOff val="40000"/>
+                  </a:schemeClr>
+                </a:solidFill>
+              </a:rPr>
+              <a:t>back</a:t>
+            </a:r>
+          </a:p>
+        </p:txBody>
+      </p:sp>
     </p:spTree>
     <p:extLst>
       <p:ext uri="{BB962C8B-B14F-4D97-AF65-F5344CB8AC3E}">
@@ -7307,6 +7393,92 @@
                 </a:solidFill>
               </a:rPr>
               <a:t>Trigger</a:t>
+            </a:r>
+          </a:p>
+        </p:txBody>
+      </p:sp>
+      <p:sp>
+        <p:nvSpPr>
+          <p:cNvPr id="30" name="TextBox 29">
+            <a:extLst>
+              <a:ext uri="{FF2B5EF4-FFF2-40B4-BE49-F238E27FC236}">
+                <a16:creationId xmlns:a16="http://schemas.microsoft.com/office/drawing/2014/main" id="{4DD483E6-0944-EC88-9A25-F3839E12ED50}"/>
+              </a:ext>
+            </a:extLst>
+          </p:cNvPr>
+          <p:cNvSpPr txBox="1"/>
+          <p:nvPr/>
+        </p:nvSpPr>
+        <p:spPr>
+          <a:xfrm rot="5400000">
+            <a:off x="6456089" y="3957501"/>
+            <a:ext cx="276999" cy="306301"/>
+          </a:xfrm>
+          <a:prstGeom prst="rect">
+            <a:avLst/>
+          </a:prstGeom>
+          <a:noFill/>
+        </p:spPr>
+        <p:txBody>
+          <a:bodyPr vert="vert270" wrap="none" lIns="0" tIns="0" rIns="91440" bIns="0" rtlCol="0">
+            <a:spAutoFit/>
+          </a:bodyPr>
+          <a:lstStyle/>
+          <a:p>
+            <a:pPr algn="ctr"/>
+            <a:r>
+              <a:rPr lang="en-US" sz="1200" dirty="0">
+                <a:solidFill>
+                  <a:schemeClr val="accent2">
+                    <a:lumMod val="60000"/>
+                    <a:lumOff val="40000"/>
+                  </a:schemeClr>
+                </a:solidFill>
+              </a:rPr>
+              <a:t>start</a:t>
+            </a:r>
+          </a:p>
+        </p:txBody>
+      </p:sp>
+      <p:sp>
+        <p:nvSpPr>
+          <p:cNvPr id="31" name="TextBox 30">
+            <a:extLst>
+              <a:ext uri="{FF2B5EF4-FFF2-40B4-BE49-F238E27FC236}">
+                <a16:creationId xmlns:a16="http://schemas.microsoft.com/office/drawing/2014/main" id="{2E389938-BC74-9774-0C0E-5E96467866AF}"/>
+              </a:ext>
+            </a:extLst>
+          </p:cNvPr>
+          <p:cNvSpPr txBox="1"/>
+          <p:nvPr/>
+        </p:nvSpPr>
+        <p:spPr>
+          <a:xfrm rot="5400000">
+            <a:off x="5515841" y="3970089"/>
+            <a:ext cx="276999" cy="323808"/>
+          </a:xfrm>
+          <a:prstGeom prst="rect">
+            <a:avLst/>
+          </a:prstGeom>
+          <a:noFill/>
+        </p:spPr>
+        <p:txBody>
+          <a:bodyPr vert="vert270" wrap="none" lIns="0" tIns="0" rIns="91440" bIns="0" rtlCol="0">
+            <a:spAutoFit/>
+          </a:bodyPr>
+          <a:lstStyle/>
+          <a:p>
+            <a:pPr algn="ctr"/>
+            <a:r>
+              <a:rPr lang="en-US" sz="1200" dirty="0">
+                <a:solidFill>
+                  <a:schemeClr val="accent2">
+                    <a:lumMod val="60000"/>
+                    <a:lumOff val="40000"/>
+                  </a:schemeClr>
+                </a:solidFill>
+              </a:rPr>
+              <a:t>back</a:t>
             </a:r>
           </a:p>
         </p:txBody>

</xml_diff>

<commit_message>
Initial commit for Intake roller and indexer mechanisms
</commit_message>
<xml_diff>
--- a/docs/Controller Mappings & Paths.pptx
+++ b/docs/Controller Mappings & Paths.pptx
@@ -407,7 +407,7 @@
           <a:p>
             <a:fld id="{B6000E93-69C7-4C90-931E-A5484B820028}" type="datetimeFigureOut">
               <a:rPr lang="en-US" smtClean="0"/>
-              <a:t>3/23/2026</a:t>
+              <a:t>3/25/2026</a:t>
             </a:fld>
             <a:endParaRPr lang="en-US"/>
           </a:p>
@@ -605,7 +605,7 @@
           <a:p>
             <a:fld id="{B6000E93-69C7-4C90-931E-A5484B820028}" type="datetimeFigureOut">
               <a:rPr lang="en-US" smtClean="0"/>
-              <a:t>3/23/2026</a:t>
+              <a:t>3/25/2026</a:t>
             </a:fld>
             <a:endParaRPr lang="en-US"/>
           </a:p>
@@ -813,7 +813,7 @@
           <a:p>
             <a:fld id="{B6000E93-69C7-4C90-931E-A5484B820028}" type="datetimeFigureOut">
               <a:rPr lang="en-US" smtClean="0"/>
-              <a:t>3/23/2026</a:t>
+              <a:t>3/25/2026</a:t>
             </a:fld>
             <a:endParaRPr lang="en-US"/>
           </a:p>
@@ -1011,7 +1011,7 @@
           <a:p>
             <a:fld id="{B6000E93-69C7-4C90-931E-A5484B820028}" type="datetimeFigureOut">
               <a:rPr lang="en-US" smtClean="0"/>
-              <a:t>3/23/2026</a:t>
+              <a:t>3/25/2026</a:t>
             </a:fld>
             <a:endParaRPr lang="en-US"/>
           </a:p>
@@ -1286,7 +1286,7 @@
           <a:p>
             <a:fld id="{B6000E93-69C7-4C90-931E-A5484B820028}" type="datetimeFigureOut">
               <a:rPr lang="en-US" smtClean="0"/>
-              <a:t>3/23/2026</a:t>
+              <a:t>3/25/2026</a:t>
             </a:fld>
             <a:endParaRPr lang="en-US"/>
           </a:p>
@@ -1551,7 +1551,7 @@
           <a:p>
             <a:fld id="{B6000E93-69C7-4C90-931E-A5484B820028}" type="datetimeFigureOut">
               <a:rPr lang="en-US" smtClean="0"/>
-              <a:t>3/23/2026</a:t>
+              <a:t>3/25/2026</a:t>
             </a:fld>
             <a:endParaRPr lang="en-US"/>
           </a:p>
@@ -1963,7 +1963,7 @@
           <a:p>
             <a:fld id="{B6000E93-69C7-4C90-931E-A5484B820028}" type="datetimeFigureOut">
               <a:rPr lang="en-US" smtClean="0"/>
-              <a:t>3/23/2026</a:t>
+              <a:t>3/25/2026</a:t>
             </a:fld>
             <a:endParaRPr lang="en-US"/>
           </a:p>
@@ -2104,7 +2104,7 @@
           <a:p>
             <a:fld id="{B6000E93-69C7-4C90-931E-A5484B820028}" type="datetimeFigureOut">
               <a:rPr lang="en-US" smtClean="0"/>
-              <a:t>3/23/2026</a:t>
+              <a:t>3/25/2026</a:t>
             </a:fld>
             <a:endParaRPr lang="en-US"/>
           </a:p>
@@ -2217,7 +2217,7 @@
           <a:p>
             <a:fld id="{B6000E93-69C7-4C90-931E-A5484B820028}" type="datetimeFigureOut">
               <a:rPr lang="en-US" smtClean="0"/>
-              <a:t>3/23/2026</a:t>
+              <a:t>3/25/2026</a:t>
             </a:fld>
             <a:endParaRPr lang="en-US"/>
           </a:p>
@@ -2528,7 +2528,7 @@
           <a:p>
             <a:fld id="{B6000E93-69C7-4C90-931E-A5484B820028}" type="datetimeFigureOut">
               <a:rPr lang="en-US" smtClean="0"/>
-              <a:t>3/23/2026</a:t>
+              <a:t>3/25/2026</a:t>
             </a:fld>
             <a:endParaRPr lang="en-US"/>
           </a:p>
@@ -2816,7 +2816,7 @@
           <a:p>
             <a:fld id="{B6000E93-69C7-4C90-931E-A5484B820028}" type="datetimeFigureOut">
               <a:rPr lang="en-US" smtClean="0"/>
-              <a:t>3/23/2026</a:t>
+              <a:t>3/25/2026</a:t>
             </a:fld>
             <a:endParaRPr lang="en-US"/>
           </a:p>
@@ -3057,7 +3057,7 @@
           <a:p>
             <a:fld id="{B6000E93-69C7-4C90-931E-A5484B820028}" type="datetimeFigureOut">
               <a:rPr lang="en-US" smtClean="0"/>
-              <a:t>3/23/2026</a:t>
+              <a:t>3/25/2026</a:t>
             </a:fld>
             <a:endParaRPr lang="en-US"/>
           </a:p>
@@ -3523,7 +3523,7 @@
         </p:nvSpPr>
         <p:spPr>
           <a:xfrm>
-            <a:off x="9703304" y="3150217"/>
+            <a:off x="7744473" y="6423404"/>
             <a:ext cx="1595535" cy="317241"/>
           </a:xfrm>
           <a:prstGeom prst="rect">
@@ -3590,7 +3590,7 @@
         </p:nvSpPr>
         <p:spPr>
           <a:xfrm>
-            <a:off x="3307337" y="603434"/>
+            <a:off x="245146" y="987219"/>
             <a:ext cx="1926144" cy="317241"/>
           </a:xfrm>
           <a:prstGeom prst="rect">
@@ -3657,7 +3657,7 @@
         </p:nvSpPr>
         <p:spPr>
           <a:xfrm>
-            <a:off x="8664034" y="603435"/>
+            <a:off x="9139825" y="2632710"/>
             <a:ext cx="2078544" cy="317241"/>
           </a:xfrm>
           <a:prstGeom prst="rect">
@@ -3724,7 +3724,7 @@
         </p:nvSpPr>
         <p:spPr>
           <a:xfrm>
-            <a:off x="5616035" y="603436"/>
+            <a:off x="1257530" y="2743827"/>
             <a:ext cx="2078544" cy="317241"/>
           </a:xfrm>
           <a:prstGeom prst="rect">
@@ -3791,8 +3791,8 @@
         </p:nvSpPr>
         <p:spPr>
           <a:xfrm>
-            <a:off x="9756775" y="5602431"/>
-            <a:ext cx="1595535" cy="317241"/>
+            <a:off x="8735624" y="4779053"/>
+            <a:ext cx="1595535" cy="449156"/>
           </a:xfrm>
           <a:prstGeom prst="rect">
             <a:avLst/>
@@ -3839,17 +3839,33 @@
                   <a:schemeClr val="tx2"/>
                 </a:solidFill>
               </a:rPr>
-              <a:t>Rotation</a:t>
-            </a:r>
-          </a:p>
-        </p:txBody>
-      </p:sp>
-      <p:sp>
-        <p:nvSpPr>
-          <p:cNvPr id="9" name="Rectangle 8">
-            <a:extLst>
-              <a:ext uri="{FF2B5EF4-FFF2-40B4-BE49-F238E27FC236}">
-                <a16:creationId xmlns:a16="http://schemas.microsoft.com/office/drawing/2014/main" id="{68BB9A10-267B-FE78-C476-8D2507C5A16A}"/>
+              <a:t>Rotation </a:t>
+            </a:r>
+          </a:p>
+          <a:p>
+            <a:pPr algn="ctr"/>
+            <a:r>
+              <a:rPr lang="en-US" sz="1100" dirty="0">
+                <a:solidFill>
+                  <a:schemeClr val="tx2"/>
+                </a:solidFill>
+              </a:rPr>
+              <a:t>(L-CCW, R-CW)</a:t>
+            </a:r>
+            <a:endParaRPr lang="en-US" dirty="0">
+              <a:solidFill>
+                <a:schemeClr val="tx2"/>
+              </a:solidFill>
+            </a:endParaRPr>
+          </a:p>
+        </p:txBody>
+      </p:sp>
+      <p:sp>
+        <p:nvSpPr>
+          <p:cNvPr id="10" name="Rectangle 9">
+            <a:extLst>
+              <a:ext uri="{FF2B5EF4-FFF2-40B4-BE49-F238E27FC236}">
+                <a16:creationId xmlns:a16="http://schemas.microsoft.com/office/drawing/2014/main" id="{55110AC5-3805-9140-9F6E-0AD3E1D52544}"/>
               </a:ext>
             </a:extLst>
           </p:cNvPr>
@@ -3858,8 +3874,8 @@
         </p:nvSpPr>
         <p:spPr>
           <a:xfrm>
-            <a:off x="332791" y="4152149"/>
-            <a:ext cx="1595535" cy="317241"/>
+            <a:off x="363632" y="1405289"/>
+            <a:ext cx="1807658" cy="317241"/>
           </a:xfrm>
           <a:prstGeom prst="rect">
             <a:avLst/>
@@ -3901,22 +3917,22 @@
           <a:p>
             <a:pPr algn="ctr"/>
             <a:r>
-              <a:rPr lang="en-US" dirty="0">
+              <a:rPr lang="en-US" sz="1600" dirty="0">
                 <a:solidFill>
                   <a:schemeClr val="tx2"/>
                 </a:solidFill>
               </a:rPr>
-              <a:t>Field Position</a:t>
-            </a:r>
-          </a:p>
-        </p:txBody>
-      </p:sp>
-      <p:sp>
-        <p:nvSpPr>
-          <p:cNvPr id="10" name="Rectangle 9">
-            <a:extLst>
-              <a:ext uri="{FF2B5EF4-FFF2-40B4-BE49-F238E27FC236}">
-                <a16:creationId xmlns:a16="http://schemas.microsoft.com/office/drawing/2014/main" id="{55110AC5-3805-9140-9F6E-0AD3E1D52544}"/>
+              <a:t>Approach Outpost</a:t>
+            </a:r>
+          </a:p>
+        </p:txBody>
+      </p:sp>
+      <p:sp>
+        <p:nvSpPr>
+          <p:cNvPr id="12" name="Rectangle 11">
+            <a:extLst>
+              <a:ext uri="{FF2B5EF4-FFF2-40B4-BE49-F238E27FC236}">
+                <a16:creationId xmlns:a16="http://schemas.microsoft.com/office/drawing/2014/main" id="{7E8685A9-97F2-E16B-0A3B-1D1D73FA3A0C}"/>
               </a:ext>
             </a:extLst>
           </p:cNvPr>
@@ -3925,8 +3941,8 @@
         </p:nvSpPr>
         <p:spPr>
           <a:xfrm>
-            <a:off x="3425823" y="1021504"/>
-            <a:ext cx="1807658" cy="317241"/>
+            <a:off x="2094029" y="5745829"/>
+            <a:ext cx="1595535" cy="317241"/>
           </a:xfrm>
           <a:prstGeom prst="rect">
             <a:avLst/>
@@ -3968,22 +3984,22 @@
           <a:p>
             <a:pPr algn="ctr"/>
             <a:r>
-              <a:rPr lang="en-US" sz="1600" dirty="0">
+              <a:rPr lang="en-US" dirty="0">
                 <a:solidFill>
                   <a:schemeClr val="tx2"/>
                 </a:solidFill>
               </a:rPr>
-              <a:t>Approach Outpost</a:t>
-            </a:r>
-          </a:p>
-        </p:txBody>
-      </p:sp>
-      <p:sp>
-        <p:nvSpPr>
-          <p:cNvPr id="11" name="Rectangle 10">
-            <a:extLst>
-              <a:ext uri="{FF2B5EF4-FFF2-40B4-BE49-F238E27FC236}">
-                <a16:creationId xmlns:a16="http://schemas.microsoft.com/office/drawing/2014/main" id="{9A026A4D-7363-5130-A509-061B8B56255E}"/>
+              <a:t>Goto Ladder</a:t>
+            </a:r>
+          </a:p>
+        </p:txBody>
+      </p:sp>
+      <p:sp>
+        <p:nvSpPr>
+          <p:cNvPr id="14" name="Rectangle 13">
+            <a:extLst>
+              <a:ext uri="{FF2B5EF4-FFF2-40B4-BE49-F238E27FC236}">
+                <a16:creationId xmlns:a16="http://schemas.microsoft.com/office/drawing/2014/main" id="{53A5126C-3CC9-34EA-C4A7-B54817482BDB}"/>
               </a:ext>
             </a:extLst>
           </p:cNvPr>
@@ -3992,7 +4008,7 @@
         </p:nvSpPr>
         <p:spPr>
           <a:xfrm>
-            <a:off x="4635229" y="1477373"/>
+            <a:off x="8869311" y="4079189"/>
             <a:ext cx="1595535" cy="317241"/>
           </a:xfrm>
           <a:prstGeom prst="rect">
@@ -4040,17 +4056,17 @@
                   <a:schemeClr val="tx2"/>
                 </a:solidFill>
               </a:rPr>
-              <a:t>Empty Fuel</a:t>
-            </a:r>
-          </a:p>
-        </p:txBody>
-      </p:sp>
-      <p:sp>
-        <p:nvSpPr>
-          <p:cNvPr id="12" name="Rectangle 11">
-            <a:extLst>
-              <a:ext uri="{FF2B5EF4-FFF2-40B4-BE49-F238E27FC236}">
-                <a16:creationId xmlns:a16="http://schemas.microsoft.com/office/drawing/2014/main" id="{7E8685A9-97F2-E16B-0A3B-1D1D73FA3A0C}"/>
+              <a:t>Brake</a:t>
+            </a:r>
+          </a:p>
+        </p:txBody>
+      </p:sp>
+      <p:sp>
+        <p:nvSpPr>
+          <p:cNvPr id="15" name="Rectangle 14">
+            <a:extLst>
+              <a:ext uri="{FF2B5EF4-FFF2-40B4-BE49-F238E27FC236}">
+                <a16:creationId xmlns:a16="http://schemas.microsoft.com/office/drawing/2014/main" id="{41C4C912-598C-BBCF-680E-57B389A7F861}"/>
               </a:ext>
             </a:extLst>
           </p:cNvPr>
@@ -4059,7 +4075,7 @@
         </p:nvSpPr>
         <p:spPr>
           <a:xfrm>
-            <a:off x="6663158" y="1139840"/>
+            <a:off x="169277" y="6287530"/>
             <a:ext cx="1595535" cy="317241"/>
           </a:xfrm>
           <a:prstGeom prst="rect">
@@ -4107,17 +4123,17 @@
                   <a:schemeClr val="tx2"/>
                 </a:solidFill>
               </a:rPr>
-              <a:t>Goto Climb</a:t>
-            </a:r>
-          </a:p>
-        </p:txBody>
-      </p:sp>
-      <p:sp>
-        <p:nvSpPr>
-          <p:cNvPr id="13" name="Rectangle 12">
-            <a:extLst>
-              <a:ext uri="{FF2B5EF4-FFF2-40B4-BE49-F238E27FC236}">
-                <a16:creationId xmlns:a16="http://schemas.microsoft.com/office/drawing/2014/main" id="{D73A1792-0975-06F2-DCDC-60A6DB1EF1B9}"/>
+              <a:t>Auto Climb</a:t>
+            </a:r>
+          </a:p>
+        </p:txBody>
+      </p:sp>
+      <p:sp>
+        <p:nvSpPr>
+          <p:cNvPr id="18" name="Rectangle 17">
+            <a:extLst>
+              <a:ext uri="{FF2B5EF4-FFF2-40B4-BE49-F238E27FC236}">
+                <a16:creationId xmlns:a16="http://schemas.microsoft.com/office/drawing/2014/main" id="{81898AE3-D9F1-A18D-B71E-C2D427EB2E75}"/>
               </a:ext>
             </a:extLst>
           </p:cNvPr>
@@ -4126,7 +4142,7 @@
         </p:nvSpPr>
         <p:spPr>
           <a:xfrm>
-            <a:off x="9703305" y="2348722"/>
+            <a:off x="193593" y="5713018"/>
             <a:ext cx="1595535" cy="317241"/>
           </a:xfrm>
           <a:prstGeom prst="rect">
@@ -4174,17 +4190,17 @@
                   <a:schemeClr val="tx2"/>
                 </a:solidFill>
               </a:rPr>
-              <a:t>Aim &amp; Shoot</a:t>
-            </a:r>
-          </a:p>
-        </p:txBody>
-      </p:sp>
-      <p:sp>
-        <p:nvSpPr>
-          <p:cNvPr id="14" name="Rectangle 13">
-            <a:extLst>
-              <a:ext uri="{FF2B5EF4-FFF2-40B4-BE49-F238E27FC236}">
-                <a16:creationId xmlns:a16="http://schemas.microsoft.com/office/drawing/2014/main" id="{53A5126C-3CC9-34EA-C4A7-B54817482BDB}"/>
+              <a:t>Get Off Fuel</a:t>
+            </a:r>
+          </a:p>
+        </p:txBody>
+      </p:sp>
+      <p:sp>
+        <p:nvSpPr>
+          <p:cNvPr id="19" name="Rectangle 18">
+            <a:extLst>
+              <a:ext uri="{FF2B5EF4-FFF2-40B4-BE49-F238E27FC236}">
+                <a16:creationId xmlns:a16="http://schemas.microsoft.com/office/drawing/2014/main" id="{B58506C8-F57E-39F8-A34E-828E8C47B467}"/>
               </a:ext>
             </a:extLst>
           </p:cNvPr>
@@ -4193,7 +4209,7 @@
         </p:nvSpPr>
         <p:spPr>
           <a:xfrm>
-            <a:off x="9703306" y="1477374"/>
+            <a:off x="9855703" y="444813"/>
             <a:ext cx="1595535" cy="317241"/>
           </a:xfrm>
           <a:prstGeom prst="rect">
@@ -4241,17 +4257,17 @@
                   <a:schemeClr val="tx2"/>
                 </a:solidFill>
               </a:rPr>
-              <a:t>Brake</a:t>
-            </a:r>
-          </a:p>
-        </p:txBody>
-      </p:sp>
-      <p:sp>
-        <p:nvSpPr>
-          <p:cNvPr id="15" name="Rectangle 14">
-            <a:extLst>
-              <a:ext uri="{FF2B5EF4-FFF2-40B4-BE49-F238E27FC236}">
-                <a16:creationId xmlns:a16="http://schemas.microsoft.com/office/drawing/2014/main" id="{41C4C912-598C-BBCF-680E-57B389A7F861}"/>
+              <a:t>Reset Position</a:t>
+            </a:r>
+          </a:p>
+        </p:txBody>
+      </p:sp>
+      <p:sp>
+        <p:nvSpPr>
+          <p:cNvPr id="26" name="Rectangle 25">
+            <a:extLst>
+              <a:ext uri="{FF2B5EF4-FFF2-40B4-BE49-F238E27FC236}">
+                <a16:creationId xmlns:a16="http://schemas.microsoft.com/office/drawing/2014/main" id="{34FDAC78-85A1-8FDA-45E0-4D17AD3E3FE7}"/>
               </a:ext>
             </a:extLst>
           </p:cNvPr>
@@ -4260,7 +4276,7 @@
         </p:nvSpPr>
         <p:spPr>
           <a:xfrm>
-            <a:off x="1830288" y="3676252"/>
+            <a:off x="3747765" y="1051247"/>
             <a:ext cx="1595535" cy="317241"/>
           </a:xfrm>
           <a:prstGeom prst="rect">
@@ -4308,17 +4324,17 @@
                   <a:schemeClr val="tx2"/>
                 </a:solidFill>
               </a:rPr>
-              <a:t>Auto Climb</a:t>
-            </a:r>
-          </a:p>
-        </p:txBody>
-      </p:sp>
-      <p:sp>
-        <p:nvSpPr>
-          <p:cNvPr id="16" name="Rectangle 15">
-            <a:extLst>
-              <a:ext uri="{FF2B5EF4-FFF2-40B4-BE49-F238E27FC236}">
-                <a16:creationId xmlns:a16="http://schemas.microsoft.com/office/drawing/2014/main" id="{1A62A4B6-A9C2-7AE0-777A-C5D06132EC4B}"/>
+              <a:t>Field-Relative</a:t>
+            </a:r>
+          </a:p>
+        </p:txBody>
+      </p:sp>
+      <p:sp>
+        <p:nvSpPr>
+          <p:cNvPr id="27" name="Rectangle 26">
+            <a:extLst>
+              <a:ext uri="{FF2B5EF4-FFF2-40B4-BE49-F238E27FC236}">
+                <a16:creationId xmlns:a16="http://schemas.microsoft.com/office/drawing/2014/main" id="{8ED871D7-CC1B-4507-C256-0656B10AA032}"/>
               </a:ext>
             </a:extLst>
           </p:cNvPr>
@@ -4327,7 +4343,7 @@
         </p:nvSpPr>
         <p:spPr>
           <a:xfrm>
-            <a:off x="2134344" y="2991597"/>
+            <a:off x="9756775" y="6030259"/>
             <a:ext cx="1595535" cy="317241"/>
           </a:xfrm>
           <a:prstGeom prst="rect">
@@ -4369,23 +4385,20 @@
           <a:lstStyle/>
           <a:p>
             <a:pPr algn="ctr"/>
-            <a:r>
-              <a:rPr lang="en-US" dirty="0">
-                <a:solidFill>
-                  <a:schemeClr val="tx2"/>
-                </a:solidFill>
-              </a:rPr>
-              <a:t>Override</a:t>
-            </a:r>
-          </a:p>
-        </p:txBody>
-      </p:sp>
-      <p:sp>
-        <p:nvSpPr>
-          <p:cNvPr id="17" name="Rectangle 16">
-            <a:extLst>
-              <a:ext uri="{FF2B5EF4-FFF2-40B4-BE49-F238E27FC236}">
-                <a16:creationId xmlns:a16="http://schemas.microsoft.com/office/drawing/2014/main" id="{D37E4E06-F17E-D198-EA49-12FD3963EB64}"/>
+            <a:endParaRPr lang="en-US" dirty="0">
+              <a:solidFill>
+                <a:schemeClr val="tx2"/>
+              </a:solidFill>
+            </a:endParaRPr>
+          </a:p>
+        </p:txBody>
+      </p:sp>
+      <p:sp>
+        <p:nvSpPr>
+          <p:cNvPr id="28" name="Rectangle 27">
+            <a:extLst>
+              <a:ext uri="{FF2B5EF4-FFF2-40B4-BE49-F238E27FC236}">
+                <a16:creationId xmlns:a16="http://schemas.microsoft.com/office/drawing/2014/main" id="{4995BC81-9903-6C07-5912-D3957C575183}"/>
               </a:ext>
             </a:extLst>
           </p:cNvPr>
@@ -4394,7 +4407,7 @@
         </p:nvSpPr>
         <p:spPr>
           <a:xfrm>
-            <a:off x="5432996" y="2738408"/>
+            <a:off x="9909175" y="6182659"/>
             <a:ext cx="1595535" cy="317241"/>
           </a:xfrm>
           <a:prstGeom prst="rect">
@@ -4436,23 +4449,20 @@
           <a:lstStyle/>
           <a:p>
             <a:pPr algn="ctr"/>
-            <a:r>
-              <a:rPr lang="en-US" dirty="0">
-                <a:solidFill>
-                  <a:schemeClr val="tx2"/>
-                </a:solidFill>
-              </a:rPr>
-              <a:t>Intake Fuel</a:t>
-            </a:r>
-          </a:p>
-        </p:txBody>
-      </p:sp>
-      <p:sp>
-        <p:nvSpPr>
-          <p:cNvPr id="18" name="Rectangle 17">
-            <a:extLst>
-              <a:ext uri="{FF2B5EF4-FFF2-40B4-BE49-F238E27FC236}">
-                <a16:creationId xmlns:a16="http://schemas.microsoft.com/office/drawing/2014/main" id="{81898AE3-D9F1-A18D-B71E-C2D427EB2E75}"/>
+            <a:endParaRPr lang="en-US" dirty="0">
+              <a:solidFill>
+                <a:schemeClr val="tx2"/>
+              </a:solidFill>
+            </a:endParaRPr>
+          </a:p>
+        </p:txBody>
+      </p:sp>
+      <p:sp>
+        <p:nvSpPr>
+          <p:cNvPr id="29" name="Rectangle 28">
+            <a:extLst>
+              <a:ext uri="{FF2B5EF4-FFF2-40B4-BE49-F238E27FC236}">
+                <a16:creationId xmlns:a16="http://schemas.microsoft.com/office/drawing/2014/main" id="{3D7A8DB9-C713-AA15-2812-CCC07794A7F1}"/>
               </a:ext>
             </a:extLst>
           </p:cNvPr>
@@ -4461,7 +4471,7 @@
         </p:nvSpPr>
         <p:spPr>
           <a:xfrm>
-            <a:off x="3837461" y="2250483"/>
+            <a:off x="10061575" y="6335059"/>
             <a:ext cx="1595535" cy="317241"/>
           </a:xfrm>
           <a:prstGeom prst="rect">
@@ -4503,23 +4513,20 @@
           <a:lstStyle/>
           <a:p>
             <a:pPr algn="ctr"/>
-            <a:r>
-              <a:rPr lang="en-US" dirty="0">
-                <a:solidFill>
-                  <a:schemeClr val="tx2"/>
-                </a:solidFill>
-              </a:rPr>
-              <a:t>Get Off Fuel</a:t>
-            </a:r>
-          </a:p>
-        </p:txBody>
-      </p:sp>
-      <p:sp>
-        <p:nvSpPr>
-          <p:cNvPr id="19" name="Rectangle 18">
-            <a:extLst>
-              <a:ext uri="{FF2B5EF4-FFF2-40B4-BE49-F238E27FC236}">
-                <a16:creationId xmlns:a16="http://schemas.microsoft.com/office/drawing/2014/main" id="{B58506C8-F57E-39F8-A34E-828E8C47B467}"/>
+            <a:endParaRPr lang="en-US" dirty="0">
+              <a:solidFill>
+                <a:schemeClr val="tx2"/>
+              </a:solidFill>
+            </a:endParaRPr>
+          </a:p>
+        </p:txBody>
+      </p:sp>
+      <p:sp>
+        <p:nvSpPr>
+          <p:cNvPr id="30" name="Rectangle 29">
+            <a:extLst>
+              <a:ext uri="{FF2B5EF4-FFF2-40B4-BE49-F238E27FC236}">
+                <a16:creationId xmlns:a16="http://schemas.microsoft.com/office/drawing/2014/main" id="{0F02DB40-516B-747B-A443-F6075F2E3035}"/>
               </a:ext>
             </a:extLst>
           </p:cNvPr>
@@ -4528,7 +4535,7 @@
         </p:nvSpPr>
         <p:spPr>
           <a:xfrm>
-            <a:off x="6468827" y="2038210"/>
+            <a:off x="1740539" y="3300259"/>
             <a:ext cx="1595535" cy="317241"/>
           </a:xfrm>
           <a:prstGeom prst="rect">
@@ -4576,663 +4583,8 @@
                   <a:schemeClr val="tx2"/>
                 </a:solidFill>
               </a:rPr>
-              <a:t>Reset Position</a:t>
-            </a:r>
-          </a:p>
-        </p:txBody>
-      </p:sp>
-      <p:sp>
-        <p:nvSpPr>
-          <p:cNvPr id="20" name="Rectangle 19">
-            <a:extLst>
-              <a:ext uri="{FF2B5EF4-FFF2-40B4-BE49-F238E27FC236}">
-                <a16:creationId xmlns:a16="http://schemas.microsoft.com/office/drawing/2014/main" id="{A0F0E149-60C3-3DE4-8C7B-AC39623BE23D}"/>
-              </a:ext>
-            </a:extLst>
-          </p:cNvPr>
-          <p:cNvSpPr/>
-          <p:nvPr/>
-        </p:nvSpPr>
-        <p:spPr>
-          <a:xfrm>
-            <a:off x="2093066" y="2525630"/>
-            <a:ext cx="1595535" cy="317241"/>
-          </a:xfrm>
-          <a:prstGeom prst="rect">
-            <a:avLst/>
-          </a:prstGeom>
-          <a:solidFill>
-            <a:schemeClr val="accent6">
-              <a:lumMod val="20000"/>
-              <a:lumOff val="80000"/>
-            </a:schemeClr>
-          </a:solidFill>
-          <a:ln>
-            <a:solidFill>
-              <a:schemeClr val="accent2">
-                <a:lumMod val="20000"/>
-                <a:lumOff val="80000"/>
-              </a:schemeClr>
-            </a:solidFill>
-          </a:ln>
-        </p:spPr>
-        <p:style>
-          <a:lnRef idx="2">
-            <a:schemeClr val="accent1">
-              <a:shade val="15000"/>
-            </a:schemeClr>
-          </a:lnRef>
-          <a:fillRef idx="1">
-            <a:schemeClr val="accent1"/>
-          </a:fillRef>
-          <a:effectRef idx="0">
-            <a:schemeClr val="accent1"/>
-          </a:effectRef>
-          <a:fontRef idx="minor">
-            <a:schemeClr val="lt1"/>
-          </a:fontRef>
-        </p:style>
-        <p:txBody>
-          <a:bodyPr rtlCol="0" anchor="ctr"/>
-          <a:lstStyle/>
-          <a:p>
-            <a:pPr algn="ctr"/>
-            <a:r>
-              <a:rPr lang="en-US" dirty="0">
-                <a:solidFill>
-                  <a:schemeClr val="tx2"/>
-                </a:solidFill>
-              </a:rPr>
-              <a:t>Just Shoot</a:t>
-            </a:r>
-          </a:p>
-        </p:txBody>
-      </p:sp>
-      <p:sp>
-        <p:nvSpPr>
-          <p:cNvPr id="21" name="Rectangle 20">
-            <a:extLst>
-              <a:ext uri="{FF2B5EF4-FFF2-40B4-BE49-F238E27FC236}">
-                <a16:creationId xmlns:a16="http://schemas.microsoft.com/office/drawing/2014/main" id="{9E799CFC-74FE-CB6D-7889-D1DA0A1C77BD}"/>
-              </a:ext>
-            </a:extLst>
-          </p:cNvPr>
-          <p:cNvSpPr/>
-          <p:nvPr/>
-        </p:nvSpPr>
-        <p:spPr>
-          <a:xfrm>
-            <a:off x="1316879" y="4668219"/>
-            <a:ext cx="1933508" cy="317241"/>
-          </a:xfrm>
-          <a:prstGeom prst="rect">
-            <a:avLst/>
-          </a:prstGeom>
-          <a:solidFill>
-            <a:schemeClr val="accent6">
-              <a:lumMod val="20000"/>
-              <a:lumOff val="80000"/>
-            </a:schemeClr>
-          </a:solidFill>
-          <a:ln>
-            <a:solidFill>
-              <a:schemeClr val="accent2">
-                <a:lumMod val="20000"/>
-                <a:lumOff val="80000"/>
-              </a:schemeClr>
-            </a:solidFill>
-          </a:ln>
-        </p:spPr>
-        <p:style>
-          <a:lnRef idx="2">
-            <a:schemeClr val="accent1">
-              <a:shade val="15000"/>
-            </a:schemeClr>
-          </a:lnRef>
-          <a:fillRef idx="1">
-            <a:schemeClr val="accent1"/>
-          </a:fillRef>
-          <a:effectRef idx="0">
-            <a:schemeClr val="accent1"/>
-          </a:effectRef>
-          <a:fontRef idx="minor">
-            <a:schemeClr val="lt1"/>
-          </a:fontRef>
-        </p:style>
-        <p:txBody>
-          <a:bodyPr rtlCol="0" anchor="ctr"/>
-          <a:lstStyle/>
-          <a:p>
-            <a:pPr algn="ctr"/>
-            <a:r>
-              <a:rPr lang="en-US" dirty="0">
-                <a:solidFill>
-                  <a:schemeClr val="tx2"/>
-                </a:solidFill>
-              </a:rPr>
-              <a:t>Straif Hub R -&gt; L</a:t>
-            </a:r>
-          </a:p>
-        </p:txBody>
-      </p:sp>
-      <p:sp>
-        <p:nvSpPr>
-          <p:cNvPr id="22" name="Rectangle 21">
-            <a:extLst>
-              <a:ext uri="{FF2B5EF4-FFF2-40B4-BE49-F238E27FC236}">
-                <a16:creationId xmlns:a16="http://schemas.microsoft.com/office/drawing/2014/main" id="{DCDB3440-602E-C7AF-02A4-01662A421BA1}"/>
-              </a:ext>
-            </a:extLst>
-          </p:cNvPr>
-          <p:cNvSpPr/>
-          <p:nvPr/>
-        </p:nvSpPr>
-        <p:spPr>
-          <a:xfrm>
-            <a:off x="738356" y="5228226"/>
-            <a:ext cx="1933508" cy="317241"/>
-          </a:xfrm>
-          <a:prstGeom prst="rect">
-            <a:avLst/>
-          </a:prstGeom>
-          <a:solidFill>
-            <a:schemeClr val="accent6">
-              <a:lumMod val="20000"/>
-              <a:lumOff val="80000"/>
-            </a:schemeClr>
-          </a:solidFill>
-          <a:ln>
-            <a:solidFill>
-              <a:schemeClr val="accent2">
-                <a:lumMod val="20000"/>
-                <a:lumOff val="80000"/>
-              </a:schemeClr>
-            </a:solidFill>
-          </a:ln>
-        </p:spPr>
-        <p:style>
-          <a:lnRef idx="2">
-            <a:schemeClr val="accent1">
-              <a:shade val="15000"/>
-            </a:schemeClr>
-          </a:lnRef>
-          <a:fillRef idx="1">
-            <a:schemeClr val="accent1"/>
-          </a:fillRef>
-          <a:effectRef idx="0">
-            <a:schemeClr val="accent1"/>
-          </a:effectRef>
-          <a:fontRef idx="minor">
-            <a:schemeClr val="lt1"/>
-          </a:fontRef>
-        </p:style>
-        <p:txBody>
-          <a:bodyPr rtlCol="0" anchor="ctr"/>
-          <a:lstStyle/>
-          <a:p>
-            <a:pPr algn="ctr"/>
-            <a:r>
-              <a:rPr lang="en-US" dirty="0">
-                <a:solidFill>
-                  <a:schemeClr val="tx2"/>
-                </a:solidFill>
-              </a:rPr>
-              <a:t>Straif Hub L-&gt;R</a:t>
-            </a:r>
-          </a:p>
-        </p:txBody>
-      </p:sp>
-      <p:sp>
-        <p:nvSpPr>
-          <p:cNvPr id="24" name="Rectangle 23">
-            <a:extLst>
-              <a:ext uri="{FF2B5EF4-FFF2-40B4-BE49-F238E27FC236}">
-                <a16:creationId xmlns:a16="http://schemas.microsoft.com/office/drawing/2014/main" id="{039706C2-21F2-96CA-4FF0-6CDC8E02EAF1}"/>
-              </a:ext>
-            </a:extLst>
-          </p:cNvPr>
-          <p:cNvSpPr/>
-          <p:nvPr/>
-        </p:nvSpPr>
-        <p:spPr>
-          <a:xfrm>
-            <a:off x="395447" y="1477373"/>
-            <a:ext cx="1776927" cy="317241"/>
-          </a:xfrm>
-          <a:prstGeom prst="rect">
-            <a:avLst/>
-          </a:prstGeom>
-          <a:solidFill>
-            <a:schemeClr val="accent6">
-              <a:lumMod val="20000"/>
-              <a:lumOff val="80000"/>
-            </a:schemeClr>
-          </a:solidFill>
-          <a:ln>
-            <a:solidFill>
-              <a:schemeClr val="accent2">
-                <a:lumMod val="20000"/>
-                <a:lumOff val="80000"/>
-              </a:schemeClr>
-            </a:solidFill>
-          </a:ln>
-        </p:spPr>
-        <p:style>
-          <a:lnRef idx="2">
-            <a:schemeClr val="accent1">
-              <a:shade val="15000"/>
-            </a:schemeClr>
-          </a:lnRef>
-          <a:fillRef idx="1">
-            <a:schemeClr val="accent1"/>
-          </a:fillRef>
-          <a:effectRef idx="0">
-            <a:schemeClr val="accent1"/>
-          </a:effectRef>
-          <a:fontRef idx="minor">
-            <a:schemeClr val="lt1"/>
-          </a:fontRef>
-        </p:style>
-        <p:txBody>
-          <a:bodyPr rtlCol="0" anchor="ctr"/>
-          <a:lstStyle/>
-          <a:p>
-            <a:pPr algn="ctr"/>
-            <a:r>
-              <a:rPr lang="en-US" dirty="0">
-                <a:solidFill>
-                  <a:schemeClr val="tx2"/>
-                </a:solidFill>
-              </a:rPr>
-              <a:t>Retract Climber</a:t>
-            </a:r>
-          </a:p>
-        </p:txBody>
-      </p:sp>
-      <p:sp>
-        <p:nvSpPr>
-          <p:cNvPr id="25" name="Rectangle 24">
-            <a:extLst>
-              <a:ext uri="{FF2B5EF4-FFF2-40B4-BE49-F238E27FC236}">
-                <a16:creationId xmlns:a16="http://schemas.microsoft.com/office/drawing/2014/main" id="{671EFF2D-521C-B3E4-0E30-0791FD9741D6}"/>
-              </a:ext>
-            </a:extLst>
-          </p:cNvPr>
-          <p:cNvSpPr/>
-          <p:nvPr/>
-        </p:nvSpPr>
-        <p:spPr>
-          <a:xfrm>
-            <a:off x="393959" y="1934506"/>
-            <a:ext cx="1776927" cy="317241"/>
-          </a:xfrm>
-          <a:prstGeom prst="rect">
-            <a:avLst/>
-          </a:prstGeom>
-          <a:solidFill>
-            <a:schemeClr val="accent6">
-              <a:lumMod val="20000"/>
-              <a:lumOff val="80000"/>
-            </a:schemeClr>
-          </a:solidFill>
-          <a:ln>
-            <a:solidFill>
-              <a:schemeClr val="accent2">
-                <a:lumMod val="20000"/>
-                <a:lumOff val="80000"/>
-              </a:schemeClr>
-            </a:solidFill>
-          </a:ln>
-        </p:spPr>
-        <p:style>
-          <a:lnRef idx="2">
-            <a:schemeClr val="accent1">
-              <a:shade val="15000"/>
-            </a:schemeClr>
-          </a:lnRef>
-          <a:fillRef idx="1">
-            <a:schemeClr val="accent1"/>
-          </a:fillRef>
-          <a:effectRef idx="0">
-            <a:schemeClr val="accent1"/>
-          </a:effectRef>
-          <a:fontRef idx="minor">
-            <a:schemeClr val="lt1"/>
-          </a:fontRef>
-        </p:style>
-        <p:txBody>
-          <a:bodyPr rtlCol="0" anchor="ctr"/>
-          <a:lstStyle/>
-          <a:p>
-            <a:pPr algn="ctr"/>
-            <a:r>
-              <a:rPr lang="en-US" dirty="0">
-                <a:solidFill>
-                  <a:schemeClr val="tx2"/>
-                </a:solidFill>
-              </a:rPr>
-              <a:t>Extend Climber</a:t>
-            </a:r>
-          </a:p>
-        </p:txBody>
-      </p:sp>
-      <p:sp>
-        <p:nvSpPr>
-          <p:cNvPr id="26" name="Rectangle 25">
-            <a:extLst>
-              <a:ext uri="{FF2B5EF4-FFF2-40B4-BE49-F238E27FC236}">
-                <a16:creationId xmlns:a16="http://schemas.microsoft.com/office/drawing/2014/main" id="{34FDAC78-85A1-8FDA-45E0-4D17AD3E3FE7}"/>
-              </a:ext>
-            </a:extLst>
-          </p:cNvPr>
-          <p:cNvSpPr/>
-          <p:nvPr/>
-        </p:nvSpPr>
-        <p:spPr>
-          <a:xfrm>
-            <a:off x="8905536" y="3874797"/>
-            <a:ext cx="1595535" cy="317241"/>
-          </a:xfrm>
-          <a:prstGeom prst="rect">
-            <a:avLst/>
-          </a:prstGeom>
-          <a:solidFill>
-            <a:schemeClr val="accent6">
-              <a:lumMod val="20000"/>
-              <a:lumOff val="80000"/>
-            </a:schemeClr>
-          </a:solidFill>
-          <a:ln>
-            <a:solidFill>
-              <a:schemeClr val="accent2">
-                <a:lumMod val="20000"/>
-                <a:lumOff val="80000"/>
-              </a:schemeClr>
-            </a:solidFill>
-          </a:ln>
-        </p:spPr>
-        <p:style>
-          <a:lnRef idx="2">
-            <a:schemeClr val="accent1">
-              <a:shade val="15000"/>
-            </a:schemeClr>
-          </a:lnRef>
-          <a:fillRef idx="1">
-            <a:schemeClr val="accent1"/>
-          </a:fillRef>
-          <a:effectRef idx="0">
-            <a:schemeClr val="accent1"/>
-          </a:effectRef>
-          <a:fontRef idx="minor">
-            <a:schemeClr val="lt1"/>
-          </a:fontRef>
-        </p:style>
-        <p:txBody>
-          <a:bodyPr rtlCol="0" anchor="ctr"/>
-          <a:lstStyle/>
-          <a:p>
-            <a:pPr algn="ctr"/>
-            <a:endParaRPr lang="en-US" dirty="0">
-              <a:solidFill>
-                <a:schemeClr val="tx2"/>
-              </a:solidFill>
-            </a:endParaRPr>
-          </a:p>
-        </p:txBody>
-      </p:sp>
-      <p:sp>
-        <p:nvSpPr>
-          <p:cNvPr id="27" name="Rectangle 26">
-            <a:extLst>
-              <a:ext uri="{FF2B5EF4-FFF2-40B4-BE49-F238E27FC236}">
-                <a16:creationId xmlns:a16="http://schemas.microsoft.com/office/drawing/2014/main" id="{8ED871D7-CC1B-4507-C256-0656B10AA032}"/>
-              </a:ext>
-            </a:extLst>
-          </p:cNvPr>
-          <p:cNvSpPr/>
-          <p:nvPr/>
-        </p:nvSpPr>
-        <p:spPr>
-          <a:xfrm>
-            <a:off x="9057936" y="4027197"/>
-            <a:ext cx="1595535" cy="317241"/>
-          </a:xfrm>
-          <a:prstGeom prst="rect">
-            <a:avLst/>
-          </a:prstGeom>
-          <a:solidFill>
-            <a:schemeClr val="accent6">
-              <a:lumMod val="20000"/>
-              <a:lumOff val="80000"/>
-            </a:schemeClr>
-          </a:solidFill>
-          <a:ln>
-            <a:solidFill>
-              <a:schemeClr val="accent2">
-                <a:lumMod val="20000"/>
-                <a:lumOff val="80000"/>
-              </a:schemeClr>
-            </a:solidFill>
-          </a:ln>
-        </p:spPr>
-        <p:style>
-          <a:lnRef idx="2">
-            <a:schemeClr val="accent1">
-              <a:shade val="15000"/>
-            </a:schemeClr>
-          </a:lnRef>
-          <a:fillRef idx="1">
-            <a:schemeClr val="accent1"/>
-          </a:fillRef>
-          <a:effectRef idx="0">
-            <a:schemeClr val="accent1"/>
-          </a:effectRef>
-          <a:fontRef idx="minor">
-            <a:schemeClr val="lt1"/>
-          </a:fontRef>
-        </p:style>
-        <p:txBody>
-          <a:bodyPr rtlCol="0" anchor="ctr"/>
-          <a:lstStyle/>
-          <a:p>
-            <a:pPr algn="ctr"/>
-            <a:endParaRPr lang="en-US" dirty="0">
-              <a:solidFill>
-                <a:schemeClr val="tx2"/>
-              </a:solidFill>
-            </a:endParaRPr>
-          </a:p>
-        </p:txBody>
-      </p:sp>
-      <p:sp>
-        <p:nvSpPr>
-          <p:cNvPr id="28" name="Rectangle 27">
-            <a:extLst>
-              <a:ext uri="{FF2B5EF4-FFF2-40B4-BE49-F238E27FC236}">
-                <a16:creationId xmlns:a16="http://schemas.microsoft.com/office/drawing/2014/main" id="{4995BC81-9903-6C07-5912-D3957C575183}"/>
-              </a:ext>
-            </a:extLst>
-          </p:cNvPr>
-          <p:cNvSpPr/>
-          <p:nvPr/>
-        </p:nvSpPr>
-        <p:spPr>
-          <a:xfrm>
-            <a:off x="9210336" y="4179597"/>
-            <a:ext cx="1595535" cy="317241"/>
-          </a:xfrm>
-          <a:prstGeom prst="rect">
-            <a:avLst/>
-          </a:prstGeom>
-          <a:solidFill>
-            <a:schemeClr val="accent6">
-              <a:lumMod val="20000"/>
-              <a:lumOff val="80000"/>
-            </a:schemeClr>
-          </a:solidFill>
-          <a:ln>
-            <a:solidFill>
-              <a:schemeClr val="accent2">
-                <a:lumMod val="20000"/>
-                <a:lumOff val="80000"/>
-              </a:schemeClr>
-            </a:solidFill>
-          </a:ln>
-        </p:spPr>
-        <p:style>
-          <a:lnRef idx="2">
-            <a:schemeClr val="accent1">
-              <a:shade val="15000"/>
-            </a:schemeClr>
-          </a:lnRef>
-          <a:fillRef idx="1">
-            <a:schemeClr val="accent1"/>
-          </a:fillRef>
-          <a:effectRef idx="0">
-            <a:schemeClr val="accent1"/>
-          </a:effectRef>
-          <a:fontRef idx="minor">
-            <a:schemeClr val="lt1"/>
-          </a:fontRef>
-        </p:style>
-        <p:txBody>
-          <a:bodyPr rtlCol="0" anchor="ctr"/>
-          <a:lstStyle/>
-          <a:p>
-            <a:pPr algn="ctr"/>
-            <a:endParaRPr lang="en-US" dirty="0">
-              <a:solidFill>
-                <a:schemeClr val="tx2"/>
-              </a:solidFill>
-            </a:endParaRPr>
-          </a:p>
-        </p:txBody>
-      </p:sp>
-      <p:sp>
-        <p:nvSpPr>
-          <p:cNvPr id="29" name="Rectangle 28">
-            <a:extLst>
-              <a:ext uri="{FF2B5EF4-FFF2-40B4-BE49-F238E27FC236}">
-                <a16:creationId xmlns:a16="http://schemas.microsoft.com/office/drawing/2014/main" id="{3D7A8DB9-C713-AA15-2812-CCC07794A7F1}"/>
-              </a:ext>
-            </a:extLst>
-          </p:cNvPr>
-          <p:cNvSpPr/>
-          <p:nvPr/>
-        </p:nvSpPr>
-        <p:spPr>
-          <a:xfrm>
-            <a:off x="9362736" y="4331997"/>
-            <a:ext cx="1595535" cy="317241"/>
-          </a:xfrm>
-          <a:prstGeom prst="rect">
-            <a:avLst/>
-          </a:prstGeom>
-          <a:solidFill>
-            <a:schemeClr val="accent6">
-              <a:lumMod val="20000"/>
-              <a:lumOff val="80000"/>
-            </a:schemeClr>
-          </a:solidFill>
-          <a:ln>
-            <a:solidFill>
-              <a:schemeClr val="accent2">
-                <a:lumMod val="20000"/>
-                <a:lumOff val="80000"/>
-              </a:schemeClr>
-            </a:solidFill>
-          </a:ln>
-        </p:spPr>
-        <p:style>
-          <a:lnRef idx="2">
-            <a:schemeClr val="accent1">
-              <a:shade val="15000"/>
-            </a:schemeClr>
-          </a:lnRef>
-          <a:fillRef idx="1">
-            <a:schemeClr val="accent1"/>
-          </a:fillRef>
-          <a:effectRef idx="0">
-            <a:schemeClr val="accent1"/>
-          </a:effectRef>
-          <a:fontRef idx="minor">
-            <a:schemeClr val="lt1"/>
-          </a:fontRef>
-        </p:style>
-        <p:txBody>
-          <a:bodyPr rtlCol="0" anchor="ctr"/>
-          <a:lstStyle/>
-          <a:p>
-            <a:pPr algn="ctr"/>
-            <a:endParaRPr lang="en-US" dirty="0">
-              <a:solidFill>
-                <a:schemeClr val="tx2"/>
-              </a:solidFill>
-            </a:endParaRPr>
-          </a:p>
-        </p:txBody>
-      </p:sp>
-      <p:sp>
-        <p:nvSpPr>
-          <p:cNvPr id="30" name="Rectangle 29">
-            <a:extLst>
-              <a:ext uri="{FF2B5EF4-FFF2-40B4-BE49-F238E27FC236}">
-                <a16:creationId xmlns:a16="http://schemas.microsoft.com/office/drawing/2014/main" id="{0F02DB40-516B-747B-A443-F6075F2E3035}"/>
-              </a:ext>
-            </a:extLst>
-          </p:cNvPr>
-          <p:cNvSpPr/>
-          <p:nvPr/>
-        </p:nvSpPr>
-        <p:spPr>
-          <a:xfrm>
-            <a:off x="9515136" y="4484397"/>
-            <a:ext cx="1595535" cy="317241"/>
-          </a:xfrm>
-          <a:prstGeom prst="rect">
-            <a:avLst/>
-          </a:prstGeom>
-          <a:solidFill>
-            <a:schemeClr val="accent6">
-              <a:lumMod val="20000"/>
-              <a:lumOff val="80000"/>
-            </a:schemeClr>
-          </a:solidFill>
-          <a:ln>
-            <a:solidFill>
-              <a:schemeClr val="accent2">
-                <a:lumMod val="20000"/>
-                <a:lumOff val="80000"/>
-              </a:schemeClr>
-            </a:solidFill>
-          </a:ln>
-        </p:spPr>
-        <p:style>
-          <a:lnRef idx="2">
-            <a:schemeClr val="accent1">
-              <a:shade val="15000"/>
-            </a:schemeClr>
-          </a:lnRef>
-          <a:fillRef idx="1">
-            <a:schemeClr val="accent1"/>
-          </a:fillRef>
-          <a:effectRef idx="0">
-            <a:schemeClr val="accent1"/>
-          </a:effectRef>
-          <a:fontRef idx="minor">
-            <a:schemeClr val="lt1"/>
-          </a:fontRef>
-        </p:style>
-        <p:txBody>
-          <a:bodyPr rtlCol="0" anchor="ctr"/>
-          <a:lstStyle/>
-          <a:p>
-            <a:pPr algn="ctr"/>
-            <a:endParaRPr lang="en-US" dirty="0">
-              <a:solidFill>
-                <a:schemeClr val="tx2"/>
-              </a:solidFill>
-            </a:endParaRPr>
+              <a:t>Drive</a:t>
+            </a:r>
           </a:p>
         </p:txBody>
       </p:sp>
@@ -5250,7 +4602,7 @@
         </p:nvGrpSpPr>
         <p:grpSpPr>
           <a:xfrm>
-            <a:off x="3674884" y="3283043"/>
+            <a:off x="3660904" y="2133543"/>
             <a:ext cx="4842232" cy="3404835"/>
             <a:chOff x="3674884" y="3283043"/>
             <a:chExt cx="4842232" cy="3404835"/>
@@ -5473,7 +4825,7 @@
         </p:nvSpPr>
         <p:spPr>
           <a:xfrm rot="5400000">
-            <a:off x="6374581" y="3926180"/>
+            <a:off x="6360601" y="2776680"/>
             <a:ext cx="276999" cy="306301"/>
           </a:xfrm>
           <a:prstGeom prst="rect">
@@ -5516,7 +4868,7 @@
         </p:nvSpPr>
         <p:spPr>
           <a:xfrm rot="5400000">
-            <a:off x="5583361" y="3917427"/>
+            <a:off x="5569381" y="2767927"/>
             <a:ext cx="276999" cy="323808"/>
           </a:xfrm>
           <a:prstGeom prst="rect">
@@ -5541,6 +4893,797 @@
                 </a:solidFill>
               </a:rPr>
               <a:t>back</a:t>
+            </a:r>
+          </a:p>
+        </p:txBody>
+      </p:sp>
+      <p:sp>
+        <p:nvSpPr>
+          <p:cNvPr id="36" name="Rectangle 35">
+            <a:extLst>
+              <a:ext uri="{FF2B5EF4-FFF2-40B4-BE49-F238E27FC236}">
+                <a16:creationId xmlns:a16="http://schemas.microsoft.com/office/drawing/2014/main" id="{98F4DC77-14B4-D867-E954-1B234E4EDBD0}"/>
+              </a:ext>
+            </a:extLst>
+          </p:cNvPr>
+          <p:cNvSpPr/>
+          <p:nvPr/>
+        </p:nvSpPr>
+        <p:spPr>
+          <a:xfrm>
+            <a:off x="6722878" y="1020293"/>
+            <a:ext cx="1687181" cy="317241"/>
+          </a:xfrm>
+          <a:prstGeom prst="rect">
+            <a:avLst/>
+          </a:prstGeom>
+          <a:solidFill>
+            <a:schemeClr val="accent6">
+              <a:lumMod val="20000"/>
+              <a:lumOff val="80000"/>
+            </a:schemeClr>
+          </a:solidFill>
+          <a:ln>
+            <a:solidFill>
+              <a:schemeClr val="accent2">
+                <a:lumMod val="20000"/>
+                <a:lumOff val="80000"/>
+              </a:schemeClr>
+            </a:solidFill>
+          </a:ln>
+        </p:spPr>
+        <p:style>
+          <a:lnRef idx="2">
+            <a:schemeClr val="accent1">
+              <a:shade val="15000"/>
+            </a:schemeClr>
+          </a:lnRef>
+          <a:fillRef idx="1">
+            <a:schemeClr val="accent1"/>
+          </a:fillRef>
+          <a:effectRef idx="0">
+            <a:schemeClr val="accent1"/>
+          </a:effectRef>
+          <a:fontRef idx="minor">
+            <a:schemeClr val="lt1"/>
+          </a:fontRef>
+        </p:style>
+        <p:txBody>
+          <a:bodyPr rtlCol="0" anchor="ctr"/>
+          <a:lstStyle/>
+          <a:p>
+            <a:pPr algn="ctr"/>
+            <a:r>
+              <a:rPr lang="en-US" dirty="0">
+                <a:solidFill>
+                  <a:schemeClr val="tx2"/>
+                </a:solidFill>
+              </a:rPr>
+              <a:t>Robot-Relative</a:t>
+            </a:r>
+          </a:p>
+        </p:txBody>
+      </p:sp>
+      <p:cxnSp>
+        <p:nvCxnSpPr>
+          <p:cNvPr id="39" name="Straight Arrow Connector 38">
+            <a:extLst>
+              <a:ext uri="{FF2B5EF4-FFF2-40B4-BE49-F238E27FC236}">
+                <a16:creationId xmlns:a16="http://schemas.microsoft.com/office/drawing/2014/main" id="{56F97E1E-75C5-461E-E6EC-03B9075E6AEA}"/>
+              </a:ext>
+            </a:extLst>
+          </p:cNvPr>
+          <p:cNvCxnSpPr>
+            <a:stCxn id="26" idx="2"/>
+          </p:cNvCxnSpPr>
+          <p:nvPr/>
+        </p:nvCxnSpPr>
+        <p:spPr>
+          <a:xfrm>
+            <a:off x="4545533" y="1368488"/>
+            <a:ext cx="400178" cy="829107"/>
+          </a:xfrm>
+          <a:prstGeom prst="straightConnector1">
+            <a:avLst/>
+          </a:prstGeom>
+          <a:ln>
+            <a:solidFill>
+              <a:srgbClr val="FF0000"/>
+            </a:solidFill>
+            <a:tailEnd type="triangle"/>
+          </a:ln>
+        </p:spPr>
+        <p:style>
+          <a:lnRef idx="2">
+            <a:schemeClr val="accent1"/>
+          </a:lnRef>
+          <a:fillRef idx="0">
+            <a:schemeClr val="accent1"/>
+          </a:fillRef>
+          <a:effectRef idx="1">
+            <a:schemeClr val="accent1"/>
+          </a:effectRef>
+          <a:fontRef idx="minor">
+            <a:schemeClr val="tx1"/>
+          </a:fontRef>
+        </p:style>
+      </p:cxnSp>
+      <p:cxnSp>
+        <p:nvCxnSpPr>
+          <p:cNvPr id="40" name="Straight Arrow Connector 39">
+            <a:extLst>
+              <a:ext uri="{FF2B5EF4-FFF2-40B4-BE49-F238E27FC236}">
+                <a16:creationId xmlns:a16="http://schemas.microsoft.com/office/drawing/2014/main" id="{C0E1B74C-561A-F049-5C9B-2C423E2B5572}"/>
+              </a:ext>
+            </a:extLst>
+          </p:cNvPr>
+          <p:cNvCxnSpPr/>
+          <p:nvPr/>
+        </p:nvCxnSpPr>
+        <p:spPr>
+          <a:xfrm>
+            <a:off x="5087469" y="5037559"/>
+            <a:ext cx="400178" cy="829107"/>
+          </a:xfrm>
+          <a:prstGeom prst="straightConnector1">
+            <a:avLst/>
+          </a:prstGeom>
+          <a:ln>
+            <a:solidFill>
+              <a:srgbClr val="FF0000"/>
+            </a:solidFill>
+            <a:tailEnd type="triangle"/>
+          </a:ln>
+        </p:spPr>
+        <p:style>
+          <a:lnRef idx="2">
+            <a:schemeClr val="accent1"/>
+          </a:lnRef>
+          <a:fillRef idx="0">
+            <a:schemeClr val="accent1"/>
+          </a:fillRef>
+          <a:effectRef idx="1">
+            <a:schemeClr val="accent1"/>
+          </a:effectRef>
+          <a:fontRef idx="minor">
+            <a:schemeClr val="tx1"/>
+          </a:fontRef>
+        </p:style>
+      </p:cxnSp>
+      <p:cxnSp>
+        <p:nvCxnSpPr>
+          <p:cNvPr id="43" name="Straight Arrow Connector 42">
+            <a:extLst>
+              <a:ext uri="{FF2B5EF4-FFF2-40B4-BE49-F238E27FC236}">
+                <a16:creationId xmlns:a16="http://schemas.microsoft.com/office/drawing/2014/main" id="{CE701173-F431-F91A-034A-F66624167200}"/>
+              </a:ext>
+            </a:extLst>
+          </p:cNvPr>
+          <p:cNvCxnSpPr/>
+          <p:nvPr/>
+        </p:nvCxnSpPr>
+        <p:spPr>
+          <a:xfrm>
+            <a:off x="5239869" y="5189959"/>
+            <a:ext cx="400178" cy="829107"/>
+          </a:xfrm>
+          <a:prstGeom prst="straightConnector1">
+            <a:avLst/>
+          </a:prstGeom>
+          <a:ln>
+            <a:solidFill>
+              <a:srgbClr val="FF0000"/>
+            </a:solidFill>
+            <a:tailEnd type="triangle"/>
+          </a:ln>
+        </p:spPr>
+        <p:style>
+          <a:lnRef idx="2">
+            <a:schemeClr val="accent1"/>
+          </a:lnRef>
+          <a:fillRef idx="0">
+            <a:schemeClr val="accent1"/>
+          </a:fillRef>
+          <a:effectRef idx="1">
+            <a:schemeClr val="accent1"/>
+          </a:effectRef>
+          <a:fontRef idx="minor">
+            <a:schemeClr val="tx1"/>
+          </a:fontRef>
+        </p:style>
+      </p:cxnSp>
+      <p:cxnSp>
+        <p:nvCxnSpPr>
+          <p:cNvPr id="44" name="Straight Arrow Connector 43">
+            <a:extLst>
+              <a:ext uri="{FF2B5EF4-FFF2-40B4-BE49-F238E27FC236}">
+                <a16:creationId xmlns:a16="http://schemas.microsoft.com/office/drawing/2014/main" id="{F4133359-D0CF-C887-FCE3-414E34E8221D}"/>
+              </a:ext>
+            </a:extLst>
+          </p:cNvPr>
+          <p:cNvCxnSpPr/>
+          <p:nvPr/>
+        </p:nvCxnSpPr>
+        <p:spPr>
+          <a:xfrm>
+            <a:off x="5392269" y="5342359"/>
+            <a:ext cx="400178" cy="829107"/>
+          </a:xfrm>
+          <a:prstGeom prst="straightConnector1">
+            <a:avLst/>
+          </a:prstGeom>
+          <a:ln>
+            <a:solidFill>
+              <a:srgbClr val="FF0000"/>
+            </a:solidFill>
+            <a:tailEnd type="triangle"/>
+          </a:ln>
+        </p:spPr>
+        <p:style>
+          <a:lnRef idx="2">
+            <a:schemeClr val="accent1"/>
+          </a:lnRef>
+          <a:fillRef idx="0">
+            <a:schemeClr val="accent1"/>
+          </a:fillRef>
+          <a:effectRef idx="1">
+            <a:schemeClr val="accent1"/>
+          </a:effectRef>
+          <a:fontRef idx="minor">
+            <a:schemeClr val="tx1"/>
+          </a:fontRef>
+        </p:style>
+      </p:cxnSp>
+      <p:cxnSp>
+        <p:nvCxnSpPr>
+          <p:cNvPr id="45" name="Straight Arrow Connector 44">
+            <a:extLst>
+              <a:ext uri="{FF2B5EF4-FFF2-40B4-BE49-F238E27FC236}">
+                <a16:creationId xmlns:a16="http://schemas.microsoft.com/office/drawing/2014/main" id="{C4E2AB78-90A6-7B1C-1664-FEA004EE1F36}"/>
+              </a:ext>
+            </a:extLst>
+          </p:cNvPr>
+          <p:cNvCxnSpPr/>
+          <p:nvPr/>
+        </p:nvCxnSpPr>
+        <p:spPr>
+          <a:xfrm>
+            <a:off x="5544669" y="5494759"/>
+            <a:ext cx="400178" cy="829107"/>
+          </a:xfrm>
+          <a:prstGeom prst="straightConnector1">
+            <a:avLst/>
+          </a:prstGeom>
+          <a:ln>
+            <a:solidFill>
+              <a:srgbClr val="FF0000"/>
+            </a:solidFill>
+            <a:tailEnd type="triangle"/>
+          </a:ln>
+        </p:spPr>
+        <p:style>
+          <a:lnRef idx="2">
+            <a:schemeClr val="accent1"/>
+          </a:lnRef>
+          <a:fillRef idx="0">
+            <a:schemeClr val="accent1"/>
+          </a:fillRef>
+          <a:effectRef idx="1">
+            <a:schemeClr val="accent1"/>
+          </a:effectRef>
+          <a:fontRef idx="minor">
+            <a:schemeClr val="tx1"/>
+          </a:fontRef>
+        </p:style>
+      </p:cxnSp>
+      <p:cxnSp>
+        <p:nvCxnSpPr>
+          <p:cNvPr id="46" name="Straight Arrow Connector 45">
+            <a:extLst>
+              <a:ext uri="{FF2B5EF4-FFF2-40B4-BE49-F238E27FC236}">
+                <a16:creationId xmlns:a16="http://schemas.microsoft.com/office/drawing/2014/main" id="{FAD30A46-DDCC-DBA8-9929-59497E804170}"/>
+              </a:ext>
+            </a:extLst>
+          </p:cNvPr>
+          <p:cNvCxnSpPr/>
+          <p:nvPr/>
+        </p:nvCxnSpPr>
+        <p:spPr>
+          <a:xfrm>
+            <a:off x="5697069" y="5647159"/>
+            <a:ext cx="400178" cy="829107"/>
+          </a:xfrm>
+          <a:prstGeom prst="straightConnector1">
+            <a:avLst/>
+          </a:prstGeom>
+          <a:ln>
+            <a:solidFill>
+              <a:srgbClr val="FF0000"/>
+            </a:solidFill>
+            <a:tailEnd type="triangle"/>
+          </a:ln>
+        </p:spPr>
+        <p:style>
+          <a:lnRef idx="2">
+            <a:schemeClr val="accent1"/>
+          </a:lnRef>
+          <a:fillRef idx="0">
+            <a:schemeClr val="accent1"/>
+          </a:fillRef>
+          <a:effectRef idx="1">
+            <a:schemeClr val="accent1"/>
+          </a:effectRef>
+          <a:fontRef idx="minor">
+            <a:schemeClr val="tx1"/>
+          </a:fontRef>
+        </p:style>
+      </p:cxnSp>
+      <p:cxnSp>
+        <p:nvCxnSpPr>
+          <p:cNvPr id="47" name="Straight Arrow Connector 46">
+            <a:extLst>
+              <a:ext uri="{FF2B5EF4-FFF2-40B4-BE49-F238E27FC236}">
+                <a16:creationId xmlns:a16="http://schemas.microsoft.com/office/drawing/2014/main" id="{900CB038-4AFE-976E-CF09-7D6B0F3F9207}"/>
+              </a:ext>
+            </a:extLst>
+          </p:cNvPr>
+          <p:cNvCxnSpPr/>
+          <p:nvPr/>
+        </p:nvCxnSpPr>
+        <p:spPr>
+          <a:xfrm>
+            <a:off x="5849469" y="5799559"/>
+            <a:ext cx="400178" cy="829107"/>
+          </a:xfrm>
+          <a:prstGeom prst="straightConnector1">
+            <a:avLst/>
+          </a:prstGeom>
+          <a:ln>
+            <a:solidFill>
+              <a:srgbClr val="FF0000"/>
+            </a:solidFill>
+            <a:tailEnd type="triangle"/>
+          </a:ln>
+        </p:spPr>
+        <p:style>
+          <a:lnRef idx="2">
+            <a:schemeClr val="accent1"/>
+          </a:lnRef>
+          <a:fillRef idx="0">
+            <a:schemeClr val="accent1"/>
+          </a:fillRef>
+          <a:effectRef idx="1">
+            <a:schemeClr val="accent1"/>
+          </a:effectRef>
+          <a:fontRef idx="minor">
+            <a:schemeClr val="tx1"/>
+          </a:fontRef>
+        </p:style>
+      </p:cxnSp>
+      <p:cxnSp>
+        <p:nvCxnSpPr>
+          <p:cNvPr id="48" name="Straight Arrow Connector 47">
+            <a:extLst>
+              <a:ext uri="{FF2B5EF4-FFF2-40B4-BE49-F238E27FC236}">
+                <a16:creationId xmlns:a16="http://schemas.microsoft.com/office/drawing/2014/main" id="{8384D7B3-2AEB-1EEF-C9DB-0AB1BF7730A0}"/>
+              </a:ext>
+            </a:extLst>
+          </p:cNvPr>
+          <p:cNvCxnSpPr/>
+          <p:nvPr/>
+        </p:nvCxnSpPr>
+        <p:spPr>
+          <a:xfrm>
+            <a:off x="6001869" y="5951959"/>
+            <a:ext cx="400178" cy="829107"/>
+          </a:xfrm>
+          <a:prstGeom prst="straightConnector1">
+            <a:avLst/>
+          </a:prstGeom>
+          <a:ln>
+            <a:solidFill>
+              <a:srgbClr val="FF0000"/>
+            </a:solidFill>
+            <a:tailEnd type="triangle"/>
+          </a:ln>
+        </p:spPr>
+        <p:style>
+          <a:lnRef idx="2">
+            <a:schemeClr val="accent1"/>
+          </a:lnRef>
+          <a:fillRef idx="0">
+            <a:schemeClr val="accent1"/>
+          </a:fillRef>
+          <a:effectRef idx="1">
+            <a:schemeClr val="accent1"/>
+          </a:effectRef>
+          <a:fontRef idx="minor">
+            <a:schemeClr val="tx1"/>
+          </a:fontRef>
+        </p:style>
+      </p:cxnSp>
+      <p:cxnSp>
+        <p:nvCxnSpPr>
+          <p:cNvPr id="49" name="Straight Arrow Connector 48">
+            <a:extLst>
+              <a:ext uri="{FF2B5EF4-FFF2-40B4-BE49-F238E27FC236}">
+                <a16:creationId xmlns:a16="http://schemas.microsoft.com/office/drawing/2014/main" id="{F426EFED-26EA-B86B-DC9B-D49764E3D7A2}"/>
+              </a:ext>
+            </a:extLst>
+          </p:cNvPr>
+          <p:cNvCxnSpPr>
+            <a:cxnSpLocks/>
+            <a:stCxn id="74" idx="2"/>
+            <a:endCxn id="37" idx="1"/>
+          </p:cNvCxnSpPr>
+          <p:nvPr/>
+        </p:nvCxnSpPr>
+        <p:spPr>
+          <a:xfrm flipH="1">
+            <a:off x="5707881" y="745588"/>
+            <a:ext cx="382255" cy="2045744"/>
+          </a:xfrm>
+          <a:prstGeom prst="straightConnector1">
+            <a:avLst/>
+          </a:prstGeom>
+          <a:ln>
+            <a:solidFill>
+              <a:srgbClr val="FF0000"/>
+            </a:solidFill>
+            <a:tailEnd type="triangle"/>
+          </a:ln>
+        </p:spPr>
+        <p:style>
+          <a:lnRef idx="2">
+            <a:schemeClr val="accent1"/>
+          </a:lnRef>
+          <a:fillRef idx="0">
+            <a:schemeClr val="accent1"/>
+          </a:fillRef>
+          <a:effectRef idx="1">
+            <a:schemeClr val="accent1"/>
+          </a:effectRef>
+          <a:fontRef idx="minor">
+            <a:schemeClr val="tx1"/>
+          </a:fontRef>
+        </p:style>
+      </p:cxnSp>
+      <p:cxnSp>
+        <p:nvCxnSpPr>
+          <p:cNvPr id="50" name="Straight Arrow Connector 49">
+            <a:extLst>
+              <a:ext uri="{FF2B5EF4-FFF2-40B4-BE49-F238E27FC236}">
+                <a16:creationId xmlns:a16="http://schemas.microsoft.com/office/drawing/2014/main" id="{0E3AE080-0BC1-7CB6-6FFA-5AC659E91337}"/>
+              </a:ext>
+            </a:extLst>
+          </p:cNvPr>
+          <p:cNvCxnSpPr>
+            <a:cxnSpLocks/>
+            <a:stCxn id="30" idx="3"/>
+          </p:cNvCxnSpPr>
+          <p:nvPr/>
+        </p:nvCxnSpPr>
+        <p:spPr>
+          <a:xfrm flipV="1">
+            <a:off x="3336074" y="3167015"/>
+            <a:ext cx="1528744" cy="291865"/>
+          </a:xfrm>
+          <a:prstGeom prst="straightConnector1">
+            <a:avLst/>
+          </a:prstGeom>
+          <a:ln>
+            <a:solidFill>
+              <a:srgbClr val="FF0000"/>
+            </a:solidFill>
+            <a:tailEnd type="triangle"/>
+          </a:ln>
+        </p:spPr>
+        <p:style>
+          <a:lnRef idx="2">
+            <a:schemeClr val="accent1"/>
+          </a:lnRef>
+          <a:fillRef idx="0">
+            <a:schemeClr val="accent1"/>
+          </a:fillRef>
+          <a:effectRef idx="1">
+            <a:schemeClr val="accent1"/>
+          </a:effectRef>
+          <a:fontRef idx="minor">
+            <a:schemeClr val="tx1"/>
+          </a:fontRef>
+        </p:style>
+      </p:cxnSp>
+      <p:cxnSp>
+        <p:nvCxnSpPr>
+          <p:cNvPr id="51" name="Straight Arrow Connector 50">
+            <a:extLst>
+              <a:ext uri="{FF2B5EF4-FFF2-40B4-BE49-F238E27FC236}">
+                <a16:creationId xmlns:a16="http://schemas.microsoft.com/office/drawing/2014/main" id="{110782EA-555F-7DFF-82BF-1C34DFDA346B}"/>
+              </a:ext>
+            </a:extLst>
+          </p:cNvPr>
+          <p:cNvCxnSpPr>
+            <a:cxnSpLocks/>
+            <a:stCxn id="7" idx="3"/>
+            <a:endCxn id="32" idx="1"/>
+          </p:cNvCxnSpPr>
+          <p:nvPr/>
+        </p:nvCxnSpPr>
+        <p:spPr>
+          <a:xfrm flipV="1">
+            <a:off x="3336074" y="2586215"/>
+            <a:ext cx="499586" cy="316233"/>
+          </a:xfrm>
+          <a:prstGeom prst="straightConnector1">
+            <a:avLst/>
+          </a:prstGeom>
+          <a:ln>
+            <a:solidFill>
+              <a:srgbClr val="FF0000"/>
+            </a:solidFill>
+            <a:tailEnd type="triangle"/>
+          </a:ln>
+        </p:spPr>
+        <p:style>
+          <a:lnRef idx="2">
+            <a:schemeClr val="accent1"/>
+          </a:lnRef>
+          <a:fillRef idx="0">
+            <a:schemeClr val="accent1"/>
+          </a:fillRef>
+          <a:effectRef idx="1">
+            <a:schemeClr val="accent1"/>
+          </a:effectRef>
+          <a:fontRef idx="minor">
+            <a:schemeClr val="tx1"/>
+          </a:fontRef>
+        </p:style>
+      </p:cxnSp>
+      <p:cxnSp>
+        <p:nvCxnSpPr>
+          <p:cNvPr id="52" name="Straight Arrow Connector 51">
+            <a:extLst>
+              <a:ext uri="{FF2B5EF4-FFF2-40B4-BE49-F238E27FC236}">
+                <a16:creationId xmlns:a16="http://schemas.microsoft.com/office/drawing/2014/main" id="{5A588EE6-085E-7BBE-3C24-E081ABD25E3B}"/>
+              </a:ext>
+            </a:extLst>
+          </p:cNvPr>
+          <p:cNvCxnSpPr>
+            <a:cxnSpLocks/>
+            <a:stCxn id="8" idx="1"/>
+          </p:cNvCxnSpPr>
+          <p:nvPr/>
+        </p:nvCxnSpPr>
+        <p:spPr>
+          <a:xfrm flipH="1" flipV="1">
+            <a:off x="6722878" y="3908309"/>
+            <a:ext cx="2012746" cy="1095322"/>
+          </a:xfrm>
+          <a:prstGeom prst="straightConnector1">
+            <a:avLst/>
+          </a:prstGeom>
+          <a:ln>
+            <a:solidFill>
+              <a:srgbClr val="FF0000"/>
+            </a:solidFill>
+            <a:tailEnd type="triangle"/>
+          </a:ln>
+        </p:spPr>
+        <p:style>
+          <a:lnRef idx="2">
+            <a:schemeClr val="accent1"/>
+          </a:lnRef>
+          <a:fillRef idx="0">
+            <a:schemeClr val="accent1"/>
+          </a:fillRef>
+          <a:effectRef idx="1">
+            <a:schemeClr val="accent1"/>
+          </a:effectRef>
+          <a:fontRef idx="minor">
+            <a:schemeClr val="tx1"/>
+          </a:fontRef>
+        </p:style>
+      </p:cxnSp>
+      <p:cxnSp>
+        <p:nvCxnSpPr>
+          <p:cNvPr id="53" name="Straight Arrow Connector 52">
+            <a:extLst>
+              <a:ext uri="{FF2B5EF4-FFF2-40B4-BE49-F238E27FC236}">
+                <a16:creationId xmlns:a16="http://schemas.microsoft.com/office/drawing/2014/main" id="{F1D0DB60-59AB-5C74-B81D-06A828838D36}"/>
+              </a:ext>
+            </a:extLst>
+          </p:cNvPr>
+          <p:cNvCxnSpPr>
+            <a:cxnSpLocks/>
+            <a:stCxn id="6" idx="1"/>
+            <a:endCxn id="31" idx="3"/>
+          </p:cNvCxnSpPr>
+          <p:nvPr/>
+        </p:nvCxnSpPr>
+        <p:spPr>
+          <a:xfrm flipH="1" flipV="1">
+            <a:off x="8410059" y="2601682"/>
+            <a:ext cx="729766" cy="189649"/>
+          </a:xfrm>
+          <a:prstGeom prst="straightConnector1">
+            <a:avLst/>
+          </a:prstGeom>
+          <a:ln>
+            <a:solidFill>
+              <a:srgbClr val="FF0000"/>
+            </a:solidFill>
+            <a:tailEnd type="triangle"/>
+          </a:ln>
+        </p:spPr>
+        <p:style>
+          <a:lnRef idx="2">
+            <a:schemeClr val="accent1"/>
+          </a:lnRef>
+          <a:fillRef idx="0">
+            <a:schemeClr val="accent1"/>
+          </a:fillRef>
+          <a:effectRef idx="1">
+            <a:schemeClr val="accent1"/>
+          </a:effectRef>
+          <a:fontRef idx="minor">
+            <a:schemeClr val="tx1"/>
+          </a:fontRef>
+        </p:style>
+      </p:cxnSp>
+      <p:cxnSp>
+        <p:nvCxnSpPr>
+          <p:cNvPr id="54" name="Straight Arrow Connector 53">
+            <a:extLst>
+              <a:ext uri="{FF2B5EF4-FFF2-40B4-BE49-F238E27FC236}">
+                <a16:creationId xmlns:a16="http://schemas.microsoft.com/office/drawing/2014/main" id="{70D9691E-59F8-E11A-89FE-06B226DE3C1D}"/>
+              </a:ext>
+            </a:extLst>
+          </p:cNvPr>
+          <p:cNvCxnSpPr>
+            <a:cxnSpLocks/>
+            <a:stCxn id="14" idx="1"/>
+          </p:cNvCxnSpPr>
+          <p:nvPr/>
+        </p:nvCxnSpPr>
+        <p:spPr>
+          <a:xfrm flipH="1" flipV="1">
+            <a:off x="7482254" y="3562318"/>
+            <a:ext cx="1387057" cy="675492"/>
+          </a:xfrm>
+          <a:prstGeom prst="straightConnector1">
+            <a:avLst/>
+          </a:prstGeom>
+          <a:ln>
+            <a:solidFill>
+              <a:srgbClr val="FF0000"/>
+            </a:solidFill>
+            <a:tailEnd type="triangle"/>
+          </a:ln>
+        </p:spPr>
+        <p:style>
+          <a:lnRef idx="2">
+            <a:schemeClr val="accent1"/>
+          </a:lnRef>
+          <a:fillRef idx="0">
+            <a:schemeClr val="accent1"/>
+          </a:fillRef>
+          <a:effectRef idx="1">
+            <a:schemeClr val="accent1"/>
+          </a:effectRef>
+          <a:fontRef idx="minor">
+            <a:schemeClr val="tx1"/>
+          </a:fontRef>
+        </p:style>
+      </p:cxnSp>
+      <p:cxnSp>
+        <p:nvCxnSpPr>
+          <p:cNvPr id="55" name="Straight Arrow Connector 54">
+            <a:extLst>
+              <a:ext uri="{FF2B5EF4-FFF2-40B4-BE49-F238E27FC236}">
+                <a16:creationId xmlns:a16="http://schemas.microsoft.com/office/drawing/2014/main" id="{43FEF709-E2F1-26B3-F185-7DF6A2381934}"/>
+              </a:ext>
+            </a:extLst>
+          </p:cNvPr>
+          <p:cNvCxnSpPr>
+            <a:cxnSpLocks/>
+            <a:stCxn id="36" idx="2"/>
+            <a:endCxn id="33" idx="1"/>
+          </p:cNvCxnSpPr>
+          <p:nvPr/>
+        </p:nvCxnSpPr>
+        <p:spPr>
+          <a:xfrm flipH="1">
+            <a:off x="7301235" y="1337534"/>
+            <a:ext cx="265234" cy="860062"/>
+          </a:xfrm>
+          <a:prstGeom prst="straightConnector1">
+            <a:avLst/>
+          </a:prstGeom>
+          <a:ln>
+            <a:solidFill>
+              <a:srgbClr val="FF0000"/>
+            </a:solidFill>
+            <a:tailEnd type="triangle"/>
+          </a:ln>
+        </p:spPr>
+        <p:style>
+          <a:lnRef idx="2">
+            <a:schemeClr val="accent1"/>
+          </a:lnRef>
+          <a:fillRef idx="0">
+            <a:schemeClr val="accent1"/>
+          </a:fillRef>
+          <a:effectRef idx="1">
+            <a:schemeClr val="accent1"/>
+          </a:effectRef>
+          <a:fontRef idx="minor">
+            <a:schemeClr val="tx1"/>
+          </a:fontRef>
+        </p:style>
+      </p:cxnSp>
+      <p:sp>
+        <p:nvSpPr>
+          <p:cNvPr id="74" name="Rectangle 73">
+            <a:extLst>
+              <a:ext uri="{FF2B5EF4-FFF2-40B4-BE49-F238E27FC236}">
+                <a16:creationId xmlns:a16="http://schemas.microsoft.com/office/drawing/2014/main" id="{A7A1E1CB-F062-0156-02CE-6B56496102B7}"/>
+              </a:ext>
+            </a:extLst>
+          </p:cNvPr>
+          <p:cNvSpPr/>
+          <p:nvPr/>
+        </p:nvSpPr>
+        <p:spPr>
+          <a:xfrm>
+            <a:off x="5261047" y="283923"/>
+            <a:ext cx="1658178" cy="461665"/>
+          </a:xfrm>
+          <a:prstGeom prst="rect">
+            <a:avLst/>
+          </a:prstGeom>
+          <a:solidFill>
+            <a:schemeClr val="accent6">
+              <a:lumMod val="20000"/>
+              <a:lumOff val="80000"/>
+            </a:schemeClr>
+          </a:solidFill>
+          <a:ln>
+            <a:solidFill>
+              <a:schemeClr val="accent2">
+                <a:lumMod val="20000"/>
+                <a:lumOff val="80000"/>
+              </a:schemeClr>
+            </a:solidFill>
+          </a:ln>
+        </p:spPr>
+        <p:style>
+          <a:lnRef idx="2">
+            <a:schemeClr val="accent1">
+              <a:shade val="15000"/>
+            </a:schemeClr>
+          </a:lnRef>
+          <a:fillRef idx="1">
+            <a:schemeClr val="accent1"/>
+          </a:fillRef>
+          <a:effectRef idx="0">
+            <a:schemeClr val="accent1"/>
+          </a:effectRef>
+          <a:fontRef idx="minor">
+            <a:schemeClr val="lt1"/>
+          </a:fontRef>
+        </p:style>
+        <p:txBody>
+          <a:bodyPr rtlCol="0" anchor="ctr"/>
+          <a:lstStyle/>
+          <a:p>
+            <a:pPr algn="ctr"/>
+            <a:r>
+              <a:rPr lang="en-US" sz="1600" dirty="0">
+                <a:solidFill>
+                  <a:schemeClr val="tx2"/>
+                </a:solidFill>
+              </a:rPr>
+              <a:t>Override some commands</a:t>
             </a:r>
           </a:p>
         </p:txBody>
@@ -5603,7 +5746,7 @@
         </p:blipFill>
         <p:spPr>
           <a:xfrm>
-            <a:off x="3545728" y="3255682"/>
+            <a:off x="3500312" y="1477474"/>
             <a:ext cx="5100544" cy="3602318"/>
           </a:xfrm>
           <a:prstGeom prst="rect">
@@ -5660,7 +5803,7 @@
         </p:nvSpPr>
         <p:spPr>
           <a:xfrm>
-            <a:off x="9703304" y="3150217"/>
+            <a:off x="9437998" y="4069318"/>
             <a:ext cx="1595535" cy="317241"/>
           </a:xfrm>
           <a:prstGeom prst="rect">
@@ -5727,7 +5870,7 @@
         </p:nvSpPr>
         <p:spPr>
           <a:xfrm>
-            <a:off x="3307337" y="603434"/>
+            <a:off x="66708" y="5670953"/>
             <a:ext cx="1926144" cy="317241"/>
           </a:xfrm>
           <a:prstGeom prst="rect">
@@ -5782,10 +5925,10 @@
       </p:sp>
       <p:sp>
         <p:nvSpPr>
-          <p:cNvPr id="5" name="Rectangle 4">
-            <a:extLst>
-              <a:ext uri="{FF2B5EF4-FFF2-40B4-BE49-F238E27FC236}">
-                <a16:creationId xmlns:a16="http://schemas.microsoft.com/office/drawing/2014/main" id="{AB91D089-99E6-4C80-CEDD-42DC02C41662}"/>
+          <p:cNvPr id="10" name="Rectangle 9">
+            <a:extLst>
+              <a:ext uri="{FF2B5EF4-FFF2-40B4-BE49-F238E27FC236}">
+                <a16:creationId xmlns:a16="http://schemas.microsoft.com/office/drawing/2014/main" id="{6526CD50-9017-5B4D-4931-DC8A76551DCD}"/>
               </a:ext>
             </a:extLst>
           </p:cNvPr>
@@ -5794,8 +5937,8 @@
         </p:nvSpPr>
         <p:spPr>
           <a:xfrm>
-            <a:off x="8664034" y="603435"/>
-            <a:ext cx="2078544" cy="317241"/>
+            <a:off x="185194" y="6089023"/>
+            <a:ext cx="1807658" cy="317241"/>
           </a:xfrm>
           <a:prstGeom prst="rect">
             <a:avLst/>
@@ -5837,22 +5980,22 @@
           <a:p>
             <a:pPr algn="ctr"/>
             <a:r>
-              <a:rPr lang="en-US" dirty="0">
+              <a:rPr lang="en-US" sz="1600" dirty="0">
                 <a:solidFill>
                   <a:schemeClr val="tx2"/>
                 </a:solidFill>
               </a:rPr>
-              <a:t>Right Bump Drive</a:t>
-            </a:r>
-          </a:p>
-        </p:txBody>
-      </p:sp>
-      <p:sp>
-        <p:nvSpPr>
-          <p:cNvPr id="6" name="Rectangle 5">
-            <a:extLst>
-              <a:ext uri="{FF2B5EF4-FFF2-40B4-BE49-F238E27FC236}">
-                <a16:creationId xmlns:a16="http://schemas.microsoft.com/office/drawing/2014/main" id="{A6C29E48-BE65-CBBC-E66E-A7B03C987EF2}"/>
+              <a:t>Approach Outpost</a:t>
+            </a:r>
+          </a:p>
+        </p:txBody>
+      </p:sp>
+      <p:sp>
+        <p:nvSpPr>
+          <p:cNvPr id="11" name="Rectangle 10">
+            <a:extLst>
+              <a:ext uri="{FF2B5EF4-FFF2-40B4-BE49-F238E27FC236}">
+                <a16:creationId xmlns:a16="http://schemas.microsoft.com/office/drawing/2014/main" id="{9CBDD6F5-47EB-E31A-2443-482B3C29A23F}"/>
               </a:ext>
             </a:extLst>
           </p:cNvPr>
@@ -5861,8 +6004,8 @@
         </p:nvSpPr>
         <p:spPr>
           <a:xfrm>
-            <a:off x="5616035" y="603436"/>
-            <a:ext cx="2078544" cy="317241"/>
+            <a:off x="1480739" y="2324249"/>
+            <a:ext cx="1595535" cy="492798"/>
           </a:xfrm>
           <a:prstGeom prst="rect">
             <a:avLst/>
@@ -5909,17 +6052,28 @@
                   <a:schemeClr val="tx2"/>
                 </a:solidFill>
               </a:rPr>
-              <a:t>Left Bump Drive</a:t>
-            </a:r>
-          </a:p>
-        </p:txBody>
-      </p:sp>
-      <p:sp>
-        <p:nvSpPr>
-          <p:cNvPr id="7" name="Rectangle 6">
-            <a:extLst>
-              <a:ext uri="{FF2B5EF4-FFF2-40B4-BE49-F238E27FC236}">
-                <a16:creationId xmlns:a16="http://schemas.microsoft.com/office/drawing/2014/main" id="{44ECC727-D0C1-834D-267E-C1B975329CC9}"/>
+              <a:t>Empty Fuel</a:t>
+            </a:r>
+          </a:p>
+          <a:p>
+            <a:pPr algn="ctr"/>
+            <a:r>
+              <a:rPr lang="en-US" sz="1200" dirty="0">
+                <a:solidFill>
+                  <a:schemeClr val="tx2"/>
+                </a:solidFill>
+              </a:rPr>
+              <a:t>(back pressed)</a:t>
+            </a:r>
+          </a:p>
+        </p:txBody>
+      </p:sp>
+      <p:sp>
+        <p:nvSpPr>
+          <p:cNvPr id="12" name="Rectangle 11">
+            <a:extLst>
+              <a:ext uri="{FF2B5EF4-FFF2-40B4-BE49-F238E27FC236}">
+                <a16:creationId xmlns:a16="http://schemas.microsoft.com/office/drawing/2014/main" id="{C02DC017-BF61-5880-3824-D65FA1623FD7}"/>
               </a:ext>
             </a:extLst>
           </p:cNvPr>
@@ -5928,7 +6082,7 @@
         </p:nvSpPr>
         <p:spPr>
           <a:xfrm>
-            <a:off x="9756775" y="5602431"/>
+            <a:off x="9855703" y="5501336"/>
             <a:ext cx="1595535" cy="317241"/>
           </a:xfrm>
           <a:prstGeom prst="rect">
@@ -5976,17 +6130,17 @@
                   <a:schemeClr val="tx2"/>
                 </a:solidFill>
               </a:rPr>
-              <a:t>Rotation</a:t>
-            </a:r>
-          </a:p>
-        </p:txBody>
-      </p:sp>
-      <p:sp>
-        <p:nvSpPr>
-          <p:cNvPr id="8" name="Rectangle 7">
-            <a:extLst>
-              <a:ext uri="{FF2B5EF4-FFF2-40B4-BE49-F238E27FC236}">
-                <a16:creationId xmlns:a16="http://schemas.microsoft.com/office/drawing/2014/main" id="{FCFEEF3F-66DA-06E9-853D-91A7DA5105F0}"/>
+              <a:t>Goto Climb</a:t>
+            </a:r>
+          </a:p>
+        </p:txBody>
+      </p:sp>
+      <p:sp>
+        <p:nvSpPr>
+          <p:cNvPr id="13" name="Rectangle 12">
+            <a:extLst>
+              <a:ext uri="{FF2B5EF4-FFF2-40B4-BE49-F238E27FC236}">
+                <a16:creationId xmlns:a16="http://schemas.microsoft.com/office/drawing/2014/main" id="{438E3938-169E-DBC2-8D39-5A597345AB0B}"/>
               </a:ext>
             </a:extLst>
           </p:cNvPr>
@@ -5995,7 +6149,7 @@
         </p:nvSpPr>
         <p:spPr>
           <a:xfrm>
-            <a:off x="332791" y="4152149"/>
+            <a:off x="9071415" y="1465331"/>
             <a:ext cx="1595535" cy="317241"/>
           </a:xfrm>
           <a:prstGeom prst="rect">
@@ -6043,17 +6197,17 @@
                   <a:schemeClr val="tx2"/>
                 </a:solidFill>
               </a:rPr>
-              <a:t>Field Position</a:t>
-            </a:r>
-          </a:p>
-        </p:txBody>
-      </p:sp>
-      <p:sp>
-        <p:nvSpPr>
-          <p:cNvPr id="10" name="Rectangle 9">
-            <a:extLst>
-              <a:ext uri="{FF2B5EF4-FFF2-40B4-BE49-F238E27FC236}">
-                <a16:creationId xmlns:a16="http://schemas.microsoft.com/office/drawing/2014/main" id="{6526CD50-9017-5B4D-4931-DC8A76551DCD}"/>
+              <a:t>Aim &amp; Shoot</a:t>
+            </a:r>
+          </a:p>
+        </p:txBody>
+      </p:sp>
+      <p:sp>
+        <p:nvSpPr>
+          <p:cNvPr id="14" name="Rectangle 13">
+            <a:extLst>
+              <a:ext uri="{FF2B5EF4-FFF2-40B4-BE49-F238E27FC236}">
+                <a16:creationId xmlns:a16="http://schemas.microsoft.com/office/drawing/2014/main" id="{CE6234B4-0847-FA69-7472-3D7D0AE90631}"/>
               </a:ext>
             </a:extLst>
           </p:cNvPr>
@@ -6062,8 +6216,8 @@
         </p:nvSpPr>
         <p:spPr>
           <a:xfrm>
-            <a:off x="3425823" y="1021504"/>
-            <a:ext cx="1807658" cy="317241"/>
+            <a:off x="9131026" y="3350062"/>
+            <a:ext cx="1595535" cy="317241"/>
           </a:xfrm>
           <a:prstGeom prst="rect">
             <a:avLst/>
@@ -6105,22 +6259,22 @@
           <a:p>
             <a:pPr algn="ctr"/>
             <a:r>
-              <a:rPr lang="en-US" sz="1600" dirty="0">
+              <a:rPr lang="en-US" dirty="0">
                 <a:solidFill>
                   <a:schemeClr val="tx2"/>
                 </a:solidFill>
               </a:rPr>
-              <a:t>Approach Outpost</a:t>
-            </a:r>
-          </a:p>
-        </p:txBody>
-      </p:sp>
-      <p:sp>
-        <p:nvSpPr>
-          <p:cNvPr id="11" name="Rectangle 10">
-            <a:extLst>
-              <a:ext uri="{FF2B5EF4-FFF2-40B4-BE49-F238E27FC236}">
-                <a16:creationId xmlns:a16="http://schemas.microsoft.com/office/drawing/2014/main" id="{9CBDD6F5-47EB-E31A-2443-482B3C29A23F}"/>
+              <a:t>Brake</a:t>
+            </a:r>
+          </a:p>
+        </p:txBody>
+      </p:sp>
+      <p:sp>
+        <p:nvSpPr>
+          <p:cNvPr id="15" name="Rectangle 14">
+            <a:extLst>
+              <a:ext uri="{FF2B5EF4-FFF2-40B4-BE49-F238E27FC236}">
+                <a16:creationId xmlns:a16="http://schemas.microsoft.com/office/drawing/2014/main" id="{4263266B-6E03-53D4-97FE-499955BC35DA}"/>
               </a:ext>
             </a:extLst>
           </p:cNvPr>
@@ -6129,7 +6283,7 @@
         </p:nvSpPr>
         <p:spPr>
           <a:xfrm>
-            <a:off x="4635229" y="1477373"/>
+            <a:off x="50877" y="5186557"/>
             <a:ext cx="1595535" cy="317241"/>
           </a:xfrm>
           <a:prstGeom prst="rect">
@@ -6177,17 +6331,17 @@
                   <a:schemeClr val="tx2"/>
                 </a:solidFill>
               </a:rPr>
-              <a:t>Empty Fuel</a:t>
-            </a:r>
-          </a:p>
-        </p:txBody>
-      </p:sp>
-      <p:sp>
-        <p:nvSpPr>
-          <p:cNvPr id="12" name="Rectangle 11">
-            <a:extLst>
-              <a:ext uri="{FF2B5EF4-FFF2-40B4-BE49-F238E27FC236}">
-                <a16:creationId xmlns:a16="http://schemas.microsoft.com/office/drawing/2014/main" id="{C02DC017-BF61-5880-3824-D65FA1623FD7}"/>
+              <a:t>Auto Climb</a:t>
+            </a:r>
+          </a:p>
+        </p:txBody>
+      </p:sp>
+      <p:sp>
+        <p:nvSpPr>
+          <p:cNvPr id="16" name="Rectangle 15">
+            <a:extLst>
+              <a:ext uri="{FF2B5EF4-FFF2-40B4-BE49-F238E27FC236}">
+                <a16:creationId xmlns:a16="http://schemas.microsoft.com/office/drawing/2014/main" id="{F54D5F66-778A-A89F-468A-3E6C9511C581}"/>
               </a:ext>
             </a:extLst>
           </p:cNvPr>
@@ -6196,8 +6350,8 @@
         </p:nvSpPr>
         <p:spPr>
           <a:xfrm>
-            <a:off x="6770384" y="1489643"/>
-            <a:ext cx="1595535" cy="317241"/>
+            <a:off x="5177206" y="238595"/>
+            <a:ext cx="1658178" cy="461665"/>
           </a:xfrm>
           <a:prstGeom prst="rect">
             <a:avLst/>
@@ -6239,22 +6393,22 @@
           <a:p>
             <a:pPr algn="ctr"/>
             <a:r>
-              <a:rPr lang="en-US" dirty="0">
+              <a:rPr lang="en-US" sz="1600" dirty="0">
                 <a:solidFill>
                   <a:schemeClr val="tx2"/>
                 </a:solidFill>
               </a:rPr>
-              <a:t>Goto Climb</a:t>
-            </a:r>
-          </a:p>
-        </p:txBody>
-      </p:sp>
-      <p:sp>
-        <p:nvSpPr>
-          <p:cNvPr id="13" name="Rectangle 12">
-            <a:extLst>
-              <a:ext uri="{FF2B5EF4-FFF2-40B4-BE49-F238E27FC236}">
-                <a16:creationId xmlns:a16="http://schemas.microsoft.com/office/drawing/2014/main" id="{438E3938-169E-DBC2-8D39-5A597345AB0B}"/>
+              <a:t>Override some commands</a:t>
+            </a:r>
+          </a:p>
+        </p:txBody>
+      </p:sp>
+      <p:sp>
+        <p:nvSpPr>
+          <p:cNvPr id="17" name="Rectangle 16">
+            <a:extLst>
+              <a:ext uri="{FF2B5EF4-FFF2-40B4-BE49-F238E27FC236}">
+                <a16:creationId xmlns:a16="http://schemas.microsoft.com/office/drawing/2014/main" id="{D169B6A3-0DA2-9D96-0351-4045F2E2F1E1}"/>
               </a:ext>
             </a:extLst>
           </p:cNvPr>
@@ -6263,7 +6417,7 @@
         </p:nvSpPr>
         <p:spPr>
           <a:xfrm>
-            <a:off x="9703305" y="2348722"/>
+            <a:off x="1449753" y="1612910"/>
             <a:ext cx="1595535" cy="317241"/>
           </a:xfrm>
           <a:prstGeom prst="rect">
@@ -6311,17 +6465,17 @@
                   <a:schemeClr val="tx2"/>
                 </a:solidFill>
               </a:rPr>
-              <a:t>Aim &amp; Shoot</a:t>
-            </a:r>
-          </a:p>
-        </p:txBody>
-      </p:sp>
-      <p:sp>
-        <p:nvSpPr>
-          <p:cNvPr id="14" name="Rectangle 13">
-            <a:extLst>
-              <a:ext uri="{FF2B5EF4-FFF2-40B4-BE49-F238E27FC236}">
-                <a16:creationId xmlns:a16="http://schemas.microsoft.com/office/drawing/2014/main" id="{CE6234B4-0847-FA69-7472-3D7D0AE90631}"/>
+              <a:t>Intake Fuel</a:t>
+            </a:r>
+          </a:p>
+        </p:txBody>
+      </p:sp>
+      <p:sp>
+        <p:nvSpPr>
+          <p:cNvPr id="18" name="Rectangle 17">
+            <a:extLst>
+              <a:ext uri="{FF2B5EF4-FFF2-40B4-BE49-F238E27FC236}">
+                <a16:creationId xmlns:a16="http://schemas.microsoft.com/office/drawing/2014/main" id="{B0136852-C263-58AE-B3A2-82BE180C50B1}"/>
               </a:ext>
             </a:extLst>
           </p:cNvPr>
@@ -6330,7 +6484,7 @@
         </p:nvSpPr>
         <p:spPr>
           <a:xfrm>
-            <a:off x="9703306" y="1477374"/>
+            <a:off x="9057935" y="6503461"/>
             <a:ext cx="1595535" cy="317241"/>
           </a:xfrm>
           <a:prstGeom prst="rect">
@@ -6378,17 +6532,17 @@
                   <a:schemeClr val="tx2"/>
                 </a:solidFill>
               </a:rPr>
-              <a:t>Brake</a:t>
-            </a:r>
-          </a:p>
-        </p:txBody>
-      </p:sp>
-      <p:sp>
-        <p:nvSpPr>
-          <p:cNvPr id="15" name="Rectangle 14">
-            <a:extLst>
-              <a:ext uri="{FF2B5EF4-FFF2-40B4-BE49-F238E27FC236}">
-                <a16:creationId xmlns:a16="http://schemas.microsoft.com/office/drawing/2014/main" id="{4263266B-6E03-53D4-97FE-499955BC35DA}"/>
+              <a:t>Get Off Fuel</a:t>
+            </a:r>
+          </a:p>
+        </p:txBody>
+      </p:sp>
+      <p:sp>
+        <p:nvSpPr>
+          <p:cNvPr id="19" name="Rectangle 18">
+            <a:extLst>
+              <a:ext uri="{FF2B5EF4-FFF2-40B4-BE49-F238E27FC236}">
+                <a16:creationId xmlns:a16="http://schemas.microsoft.com/office/drawing/2014/main" id="{5887B5D4-8008-9128-F533-C1E35FE5B92C}"/>
               </a:ext>
             </a:extLst>
           </p:cNvPr>
@@ -6397,7 +6551,7 @@
         </p:nvSpPr>
         <p:spPr>
           <a:xfrm>
-            <a:off x="1830288" y="3676252"/>
+            <a:off x="9554146" y="6049903"/>
             <a:ext cx="1595535" cy="317241"/>
           </a:xfrm>
           <a:prstGeom prst="rect">
@@ -6445,17 +6599,17 @@
                   <a:schemeClr val="tx2"/>
                 </a:solidFill>
               </a:rPr>
-              <a:t>Auto Climb</a:t>
-            </a:r>
-          </a:p>
-        </p:txBody>
-      </p:sp>
-      <p:sp>
-        <p:nvSpPr>
-          <p:cNvPr id="16" name="Rectangle 15">
-            <a:extLst>
-              <a:ext uri="{FF2B5EF4-FFF2-40B4-BE49-F238E27FC236}">
-                <a16:creationId xmlns:a16="http://schemas.microsoft.com/office/drawing/2014/main" id="{F54D5F66-778A-A89F-468A-3E6C9511C581}"/>
+              <a:t>Reset Position</a:t>
+            </a:r>
+          </a:p>
+        </p:txBody>
+      </p:sp>
+      <p:sp>
+        <p:nvSpPr>
+          <p:cNvPr id="20" name="Rectangle 19">
+            <a:extLst>
+              <a:ext uri="{FF2B5EF4-FFF2-40B4-BE49-F238E27FC236}">
+                <a16:creationId xmlns:a16="http://schemas.microsoft.com/office/drawing/2014/main" id="{310EA12B-9AD3-C372-4AAA-ACD138FBBC4C}"/>
               </a:ext>
             </a:extLst>
           </p:cNvPr>
@@ -6464,8 +6618,8 @@
         </p:nvSpPr>
         <p:spPr>
           <a:xfrm>
-            <a:off x="2134344" y="2991597"/>
-            <a:ext cx="1595535" cy="317241"/>
+            <a:off x="9100369" y="1963707"/>
+            <a:ext cx="1595535" cy="445758"/>
           </a:xfrm>
           <a:prstGeom prst="rect">
             <a:avLst/>
@@ -6512,17 +6666,33 @@
                   <a:schemeClr val="tx2"/>
                 </a:solidFill>
               </a:rPr>
-              <a:t>Override</a:t>
-            </a:r>
-          </a:p>
-        </p:txBody>
-      </p:sp>
-      <p:sp>
-        <p:nvSpPr>
-          <p:cNvPr id="17" name="Rectangle 16">
-            <a:extLst>
-              <a:ext uri="{FF2B5EF4-FFF2-40B4-BE49-F238E27FC236}">
-                <a16:creationId xmlns:a16="http://schemas.microsoft.com/office/drawing/2014/main" id="{D169B6A3-0DA2-9D96-0351-4045F2E2F1E1}"/>
+              <a:t>Just Shoot</a:t>
+            </a:r>
+          </a:p>
+          <a:p>
+            <a:pPr algn="ctr"/>
+            <a:r>
+              <a:rPr lang="en-US" sz="1200" dirty="0">
+                <a:solidFill>
+                  <a:schemeClr val="tx2"/>
+                </a:solidFill>
+              </a:rPr>
+              <a:t>(back pressed)</a:t>
+            </a:r>
+            <a:endParaRPr lang="en-US" dirty="0">
+              <a:solidFill>
+                <a:schemeClr val="tx2"/>
+              </a:solidFill>
+            </a:endParaRPr>
+          </a:p>
+        </p:txBody>
+      </p:sp>
+      <p:sp>
+        <p:nvSpPr>
+          <p:cNvPr id="23" name="Rectangle 22">
+            <a:extLst>
+              <a:ext uri="{FF2B5EF4-FFF2-40B4-BE49-F238E27FC236}">
+                <a16:creationId xmlns:a16="http://schemas.microsoft.com/office/drawing/2014/main" id="{6FB3F50A-FFA8-E4EA-EA5C-F47592E5A084}"/>
               </a:ext>
             </a:extLst>
           </p:cNvPr>
@@ -6531,8 +6701,8 @@
         </p:nvSpPr>
         <p:spPr>
           <a:xfrm>
-            <a:off x="5432996" y="2738408"/>
-            <a:ext cx="1595535" cy="317241"/>
+            <a:off x="2276769" y="3904199"/>
+            <a:ext cx="1776927" cy="317241"/>
           </a:xfrm>
           <a:prstGeom prst="rect">
             <a:avLst/>
@@ -6579,17 +6749,17 @@
                   <a:schemeClr val="tx2"/>
                 </a:solidFill>
               </a:rPr>
-              <a:t>Intake Fuel</a:t>
-            </a:r>
-          </a:p>
-        </p:txBody>
-      </p:sp>
-      <p:sp>
-        <p:nvSpPr>
-          <p:cNvPr id="18" name="Rectangle 17">
-            <a:extLst>
-              <a:ext uri="{FF2B5EF4-FFF2-40B4-BE49-F238E27FC236}">
-                <a16:creationId xmlns:a16="http://schemas.microsoft.com/office/drawing/2014/main" id="{B0136852-C263-58AE-B3A2-82BE180C50B1}"/>
+              <a:t>Retract Climber</a:t>
+            </a:r>
+          </a:p>
+        </p:txBody>
+      </p:sp>
+      <p:sp>
+        <p:nvSpPr>
+          <p:cNvPr id="24" name="Rectangle 23">
+            <a:extLst>
+              <a:ext uri="{FF2B5EF4-FFF2-40B4-BE49-F238E27FC236}">
+                <a16:creationId xmlns:a16="http://schemas.microsoft.com/office/drawing/2014/main" id="{9FC38623-D4B1-E2FF-6BA6-B423FA6F1473}"/>
               </a:ext>
             </a:extLst>
           </p:cNvPr>
@@ -6598,8 +6768,8 @@
         </p:nvSpPr>
         <p:spPr>
           <a:xfrm>
-            <a:off x="3837461" y="2250483"/>
-            <a:ext cx="1595535" cy="317241"/>
+            <a:off x="2276769" y="3429000"/>
+            <a:ext cx="1776927" cy="317241"/>
           </a:xfrm>
           <a:prstGeom prst="rect">
             <a:avLst/>
@@ -6646,17 +6816,17 @@
                   <a:schemeClr val="tx2"/>
                 </a:solidFill>
               </a:rPr>
-              <a:t>Get Off Fuel</a:t>
-            </a:r>
-          </a:p>
-        </p:txBody>
-      </p:sp>
-      <p:sp>
-        <p:nvSpPr>
-          <p:cNvPr id="19" name="Rectangle 18">
-            <a:extLst>
-              <a:ext uri="{FF2B5EF4-FFF2-40B4-BE49-F238E27FC236}">
-                <a16:creationId xmlns:a16="http://schemas.microsoft.com/office/drawing/2014/main" id="{5887B5D4-8008-9128-F533-C1E35FE5B92C}"/>
+              <a:t>Extend Climber</a:t>
+            </a:r>
+          </a:p>
+        </p:txBody>
+      </p:sp>
+      <p:sp>
+        <p:nvSpPr>
+          <p:cNvPr id="26" name="Rectangle 25">
+            <a:extLst>
+              <a:ext uri="{FF2B5EF4-FFF2-40B4-BE49-F238E27FC236}">
+                <a16:creationId xmlns:a16="http://schemas.microsoft.com/office/drawing/2014/main" id="{6B6E82EA-1AE1-CFB3-BE12-C33072D8CBE7}"/>
               </a:ext>
             </a:extLst>
           </p:cNvPr>
@@ -6665,7 +6835,7 @@
         </p:nvSpPr>
         <p:spPr>
           <a:xfrm>
-            <a:off x="6468827" y="2038210"/>
+            <a:off x="2771474" y="5914229"/>
             <a:ext cx="1595535" cy="317241"/>
           </a:xfrm>
           <a:prstGeom prst="rect">
@@ -6707,23 +6877,20 @@
           <a:lstStyle/>
           <a:p>
             <a:pPr algn="ctr"/>
-            <a:r>
-              <a:rPr lang="en-US" dirty="0">
-                <a:solidFill>
-                  <a:schemeClr val="tx2"/>
-                </a:solidFill>
-              </a:rPr>
-              <a:t>Reset Position</a:t>
-            </a:r>
-          </a:p>
-        </p:txBody>
-      </p:sp>
-      <p:sp>
-        <p:nvSpPr>
-          <p:cNvPr id="20" name="Rectangle 19">
-            <a:extLst>
-              <a:ext uri="{FF2B5EF4-FFF2-40B4-BE49-F238E27FC236}">
-                <a16:creationId xmlns:a16="http://schemas.microsoft.com/office/drawing/2014/main" id="{310EA12B-9AD3-C372-4AAA-ACD138FBBC4C}"/>
+            <a:endParaRPr lang="en-US" dirty="0">
+              <a:solidFill>
+                <a:schemeClr val="tx2"/>
+              </a:solidFill>
+            </a:endParaRPr>
+          </a:p>
+        </p:txBody>
+      </p:sp>
+      <p:sp>
+        <p:nvSpPr>
+          <p:cNvPr id="27" name="Rectangle 26">
+            <a:extLst>
+              <a:ext uri="{FF2B5EF4-FFF2-40B4-BE49-F238E27FC236}">
+                <a16:creationId xmlns:a16="http://schemas.microsoft.com/office/drawing/2014/main" id="{536CB937-8976-AE7B-7FE7-929F24F3C592}"/>
               </a:ext>
             </a:extLst>
           </p:cNvPr>
@@ -6732,7 +6899,7 @@
         </p:nvSpPr>
         <p:spPr>
           <a:xfrm>
-            <a:off x="2093066" y="2525630"/>
+            <a:off x="2923874" y="6066629"/>
             <a:ext cx="1595535" cy="317241"/>
           </a:xfrm>
           <a:prstGeom prst="rect">
@@ -6774,23 +6941,20 @@
           <a:lstStyle/>
           <a:p>
             <a:pPr algn="ctr"/>
-            <a:r>
-              <a:rPr lang="en-US" dirty="0">
-                <a:solidFill>
-                  <a:schemeClr val="tx2"/>
-                </a:solidFill>
-              </a:rPr>
-              <a:t>Just Shoot</a:t>
-            </a:r>
-          </a:p>
-        </p:txBody>
-      </p:sp>
-      <p:sp>
-        <p:nvSpPr>
-          <p:cNvPr id="21" name="Rectangle 20">
-            <a:extLst>
-              <a:ext uri="{FF2B5EF4-FFF2-40B4-BE49-F238E27FC236}">
-                <a16:creationId xmlns:a16="http://schemas.microsoft.com/office/drawing/2014/main" id="{C2D4B113-BD39-01A3-8819-0D80F850C080}"/>
+            <a:endParaRPr lang="en-US" dirty="0">
+              <a:solidFill>
+                <a:schemeClr val="tx2"/>
+              </a:solidFill>
+            </a:endParaRPr>
+          </a:p>
+        </p:txBody>
+      </p:sp>
+      <p:sp>
+        <p:nvSpPr>
+          <p:cNvPr id="28" name="Rectangle 27">
+            <a:extLst>
+              <a:ext uri="{FF2B5EF4-FFF2-40B4-BE49-F238E27FC236}">
+                <a16:creationId xmlns:a16="http://schemas.microsoft.com/office/drawing/2014/main" id="{2313DCAD-124D-5850-AD89-3AB6441F9862}"/>
               </a:ext>
             </a:extLst>
           </p:cNvPr>
@@ -6799,8 +6963,8 @@
         </p:nvSpPr>
         <p:spPr>
           <a:xfrm>
-            <a:off x="1316879" y="4668219"/>
-            <a:ext cx="1933508" cy="317241"/>
+            <a:off x="3076274" y="6219029"/>
+            <a:ext cx="1595535" cy="317241"/>
           </a:xfrm>
           <a:prstGeom prst="rect">
             <a:avLst/>
@@ -6841,23 +7005,20 @@
           <a:lstStyle/>
           <a:p>
             <a:pPr algn="ctr"/>
-            <a:r>
-              <a:rPr lang="en-US" dirty="0">
-                <a:solidFill>
-                  <a:schemeClr val="tx2"/>
-                </a:solidFill>
-              </a:rPr>
-              <a:t>Straif Hub R -&gt; L</a:t>
-            </a:r>
-          </a:p>
-        </p:txBody>
-      </p:sp>
-      <p:sp>
-        <p:nvSpPr>
-          <p:cNvPr id="22" name="Rectangle 21">
-            <a:extLst>
-              <a:ext uri="{FF2B5EF4-FFF2-40B4-BE49-F238E27FC236}">
-                <a16:creationId xmlns:a16="http://schemas.microsoft.com/office/drawing/2014/main" id="{5C75FC37-3304-3838-2E62-DFA6B8BCE1F4}"/>
+            <a:endParaRPr lang="en-US" dirty="0">
+              <a:solidFill>
+                <a:schemeClr val="tx2"/>
+              </a:solidFill>
+            </a:endParaRPr>
+          </a:p>
+        </p:txBody>
+      </p:sp>
+      <p:sp>
+        <p:nvSpPr>
+          <p:cNvPr id="29" name="Rectangle 28">
+            <a:extLst>
+              <a:ext uri="{FF2B5EF4-FFF2-40B4-BE49-F238E27FC236}">
+                <a16:creationId xmlns:a16="http://schemas.microsoft.com/office/drawing/2014/main" id="{530B3026-3929-68C0-D9CA-51C0578C6396}"/>
               </a:ext>
             </a:extLst>
           </p:cNvPr>
@@ -6866,8 +7027,8 @@
         </p:nvSpPr>
         <p:spPr>
           <a:xfrm>
-            <a:off x="738356" y="5228226"/>
-            <a:ext cx="1933508" cy="317241"/>
+            <a:off x="3076274" y="5268629"/>
+            <a:ext cx="1595535" cy="490853"/>
           </a:xfrm>
           <a:prstGeom prst="rect">
             <a:avLst/>
@@ -6914,17 +7075,771 @@
                   <a:schemeClr val="tx2"/>
                 </a:solidFill>
               </a:rPr>
-              <a:t>Straif Hub L-&gt;R</a:t>
-            </a:r>
-          </a:p>
-        </p:txBody>
-      </p:sp>
-      <p:sp>
-        <p:nvSpPr>
-          <p:cNvPr id="23" name="Rectangle 22">
-            <a:extLst>
-              <a:ext uri="{FF2B5EF4-FFF2-40B4-BE49-F238E27FC236}">
-                <a16:creationId xmlns:a16="http://schemas.microsoft.com/office/drawing/2014/main" id="{6FB3F50A-FFA8-E4EA-EA5C-F47592E5A084}"/>
+              <a:t>Retract Intake </a:t>
+            </a:r>
+            <a:r>
+              <a:rPr lang="en-US" sz="1200" dirty="0">
+                <a:solidFill>
+                  <a:schemeClr val="tx2"/>
+                </a:solidFill>
+              </a:rPr>
+              <a:t>(up)</a:t>
+            </a:r>
+            <a:endParaRPr lang="en-US" dirty="0">
+              <a:solidFill>
+                <a:schemeClr val="tx2"/>
+              </a:solidFill>
+            </a:endParaRPr>
+          </a:p>
+        </p:txBody>
+      </p:sp>
+      <p:sp>
+        <p:nvSpPr>
+          <p:cNvPr id="37" name="TextBox 36">
+            <a:extLst>
+              <a:ext uri="{FF2B5EF4-FFF2-40B4-BE49-F238E27FC236}">
+                <a16:creationId xmlns:a16="http://schemas.microsoft.com/office/drawing/2014/main" id="{DB13644A-9285-9111-3BBE-6AB488C981FF}"/>
+              </a:ext>
+            </a:extLst>
+          </p:cNvPr>
+          <p:cNvSpPr txBox="1"/>
+          <p:nvPr/>
+        </p:nvSpPr>
+        <p:spPr>
+          <a:xfrm>
+            <a:off x="4410360" y="1516588"/>
+            <a:ext cx="977220" cy="369332"/>
+          </a:xfrm>
+          <a:prstGeom prst="rect">
+            <a:avLst/>
+          </a:prstGeom>
+          <a:noFill/>
+        </p:spPr>
+        <p:txBody>
+          <a:bodyPr wrap="square">
+            <a:spAutoFit/>
+          </a:bodyPr>
+          <a:lstStyle/>
+          <a:p>
+            <a:pPr algn="ctr"/>
+            <a:r>
+              <a:rPr lang="en-US" sz="1800" dirty="0">
+                <a:solidFill>
+                  <a:schemeClr val="accent2">
+                    <a:lumMod val="60000"/>
+                    <a:lumOff val="40000"/>
+                  </a:schemeClr>
+                </a:solidFill>
+              </a:rPr>
+              <a:t>Bumper</a:t>
+            </a:r>
+          </a:p>
+        </p:txBody>
+      </p:sp>
+      <p:sp>
+        <p:nvSpPr>
+          <p:cNvPr id="38" name="TextBox 37">
+            <a:extLst>
+              <a:ext uri="{FF2B5EF4-FFF2-40B4-BE49-F238E27FC236}">
+                <a16:creationId xmlns:a16="http://schemas.microsoft.com/office/drawing/2014/main" id="{663C2E0C-F6E9-C73C-F7F2-26D2724A3EC5}"/>
+              </a:ext>
+            </a:extLst>
+          </p:cNvPr>
+          <p:cNvSpPr txBox="1"/>
+          <p:nvPr/>
+        </p:nvSpPr>
+        <p:spPr>
+          <a:xfrm>
+            <a:off x="6879240" y="1504584"/>
+            <a:ext cx="977220" cy="369332"/>
+          </a:xfrm>
+          <a:prstGeom prst="rect">
+            <a:avLst/>
+          </a:prstGeom>
+          <a:noFill/>
+        </p:spPr>
+        <p:txBody>
+          <a:bodyPr wrap="square">
+            <a:spAutoFit/>
+          </a:bodyPr>
+          <a:lstStyle/>
+          <a:p>
+            <a:pPr algn="ctr"/>
+            <a:r>
+              <a:rPr lang="en-US" sz="1800" dirty="0">
+                <a:solidFill>
+                  <a:schemeClr val="accent2">
+                    <a:lumMod val="60000"/>
+                    <a:lumOff val="40000"/>
+                  </a:schemeClr>
+                </a:solidFill>
+              </a:rPr>
+              <a:t>Bumper</a:t>
+            </a:r>
+          </a:p>
+        </p:txBody>
+      </p:sp>
+      <p:sp>
+        <p:nvSpPr>
+          <p:cNvPr id="40" name="TextBox 39">
+            <a:extLst>
+              <a:ext uri="{FF2B5EF4-FFF2-40B4-BE49-F238E27FC236}">
+                <a16:creationId xmlns:a16="http://schemas.microsoft.com/office/drawing/2014/main" id="{5FC26886-D16D-E4C3-22DA-B6459CC232DD}"/>
+              </a:ext>
+            </a:extLst>
+          </p:cNvPr>
+          <p:cNvSpPr txBox="1"/>
+          <p:nvPr/>
+        </p:nvSpPr>
+        <p:spPr>
+          <a:xfrm>
+            <a:off x="3743261" y="1667107"/>
+            <a:ext cx="338554" cy="580800"/>
+          </a:xfrm>
+          <a:prstGeom prst="rect">
+            <a:avLst/>
+          </a:prstGeom>
+          <a:noFill/>
+        </p:spPr>
+        <p:txBody>
+          <a:bodyPr vert="vert270" wrap="none" lIns="0" tIns="0" rIns="91440" bIns="0" rtlCol="0">
+            <a:spAutoFit/>
+          </a:bodyPr>
+          <a:lstStyle/>
+          <a:p>
+            <a:pPr algn="ctr"/>
+            <a:r>
+              <a:rPr lang="en-US" sz="1600" dirty="0">
+                <a:solidFill>
+                  <a:schemeClr val="bg2"/>
+                </a:solidFill>
+              </a:rPr>
+              <a:t>Trigger</a:t>
+            </a:r>
+          </a:p>
+        </p:txBody>
+      </p:sp>
+      <p:sp>
+        <p:nvSpPr>
+          <p:cNvPr id="41" name="TextBox 40">
+            <a:extLst>
+              <a:ext uri="{FF2B5EF4-FFF2-40B4-BE49-F238E27FC236}">
+                <a16:creationId xmlns:a16="http://schemas.microsoft.com/office/drawing/2014/main" id="{4AAA1677-C84E-01A0-4838-DEC253AEDD33}"/>
+              </a:ext>
+            </a:extLst>
+          </p:cNvPr>
+          <p:cNvSpPr txBox="1"/>
+          <p:nvPr/>
+        </p:nvSpPr>
+        <p:spPr>
+          <a:xfrm>
+            <a:off x="8169225" y="1650792"/>
+            <a:ext cx="338554" cy="580800"/>
+          </a:xfrm>
+          <a:prstGeom prst="rect">
+            <a:avLst/>
+          </a:prstGeom>
+          <a:noFill/>
+        </p:spPr>
+        <p:txBody>
+          <a:bodyPr vert="vert270" wrap="none" lIns="0" tIns="0" rIns="91440" bIns="0" rtlCol="0">
+            <a:spAutoFit/>
+          </a:bodyPr>
+          <a:lstStyle/>
+          <a:p>
+            <a:pPr algn="ctr"/>
+            <a:r>
+              <a:rPr lang="en-US" sz="1600" dirty="0">
+                <a:solidFill>
+                  <a:schemeClr val="bg2"/>
+                </a:solidFill>
+              </a:rPr>
+              <a:t>Trigger</a:t>
+            </a:r>
+          </a:p>
+        </p:txBody>
+      </p:sp>
+      <p:sp>
+        <p:nvSpPr>
+          <p:cNvPr id="30" name="TextBox 29">
+            <a:extLst>
+              <a:ext uri="{FF2B5EF4-FFF2-40B4-BE49-F238E27FC236}">
+                <a16:creationId xmlns:a16="http://schemas.microsoft.com/office/drawing/2014/main" id="{4DD483E6-0944-EC88-9A25-F3839E12ED50}"/>
+              </a:ext>
+            </a:extLst>
+          </p:cNvPr>
+          <p:cNvSpPr txBox="1"/>
+          <p:nvPr/>
+        </p:nvSpPr>
+        <p:spPr>
+          <a:xfrm rot="5400000">
+            <a:off x="6410673" y="2179293"/>
+            <a:ext cx="276999" cy="306301"/>
+          </a:xfrm>
+          <a:prstGeom prst="rect">
+            <a:avLst/>
+          </a:prstGeom>
+          <a:noFill/>
+        </p:spPr>
+        <p:txBody>
+          <a:bodyPr vert="vert270" wrap="none" lIns="0" tIns="0" rIns="91440" bIns="0" rtlCol="0">
+            <a:spAutoFit/>
+          </a:bodyPr>
+          <a:lstStyle/>
+          <a:p>
+            <a:pPr algn="ctr"/>
+            <a:r>
+              <a:rPr lang="en-US" sz="1200" dirty="0">
+                <a:solidFill>
+                  <a:schemeClr val="accent2">
+                    <a:lumMod val="60000"/>
+                    <a:lumOff val="40000"/>
+                  </a:schemeClr>
+                </a:solidFill>
+              </a:rPr>
+              <a:t>start</a:t>
+            </a:r>
+          </a:p>
+        </p:txBody>
+      </p:sp>
+      <p:sp>
+        <p:nvSpPr>
+          <p:cNvPr id="31" name="TextBox 30">
+            <a:extLst>
+              <a:ext uri="{FF2B5EF4-FFF2-40B4-BE49-F238E27FC236}">
+                <a16:creationId xmlns:a16="http://schemas.microsoft.com/office/drawing/2014/main" id="{2E389938-BC74-9774-0C0E-5E96467866AF}"/>
+              </a:ext>
+            </a:extLst>
+          </p:cNvPr>
+          <p:cNvSpPr txBox="1"/>
+          <p:nvPr/>
+        </p:nvSpPr>
+        <p:spPr>
+          <a:xfrm rot="5400000">
+            <a:off x="5470425" y="2191881"/>
+            <a:ext cx="276999" cy="323808"/>
+          </a:xfrm>
+          <a:prstGeom prst="rect">
+            <a:avLst/>
+          </a:prstGeom>
+          <a:noFill/>
+        </p:spPr>
+        <p:txBody>
+          <a:bodyPr vert="vert270" wrap="none" lIns="0" tIns="0" rIns="91440" bIns="0" rtlCol="0">
+            <a:spAutoFit/>
+          </a:bodyPr>
+          <a:lstStyle/>
+          <a:p>
+            <a:pPr algn="ctr"/>
+            <a:r>
+              <a:rPr lang="en-US" sz="1200" dirty="0">
+                <a:solidFill>
+                  <a:schemeClr val="accent2">
+                    <a:lumMod val="60000"/>
+                    <a:lumOff val="40000"/>
+                  </a:schemeClr>
+                </a:solidFill>
+              </a:rPr>
+              <a:t>back</a:t>
+            </a:r>
+          </a:p>
+        </p:txBody>
+      </p:sp>
+      <p:cxnSp>
+        <p:nvCxnSpPr>
+          <p:cNvPr id="32" name="Straight Arrow Connector 31">
+            <a:extLst>
+              <a:ext uri="{FF2B5EF4-FFF2-40B4-BE49-F238E27FC236}">
+                <a16:creationId xmlns:a16="http://schemas.microsoft.com/office/drawing/2014/main" id="{B3C5C913-85F8-2C50-28A3-5D5BB59BBE80}"/>
+              </a:ext>
+            </a:extLst>
+          </p:cNvPr>
+          <p:cNvCxnSpPr>
+            <a:cxnSpLocks/>
+            <a:stCxn id="11" idx="3"/>
+            <a:endCxn id="40" idx="1"/>
+          </p:cNvCxnSpPr>
+          <p:nvPr/>
+        </p:nvCxnSpPr>
+        <p:spPr>
+          <a:xfrm flipV="1">
+            <a:off x="3076274" y="1957507"/>
+            <a:ext cx="666987" cy="613141"/>
+          </a:xfrm>
+          <a:prstGeom prst="straightConnector1">
+            <a:avLst/>
+          </a:prstGeom>
+          <a:ln>
+            <a:solidFill>
+              <a:srgbClr val="FF0000"/>
+            </a:solidFill>
+            <a:tailEnd type="triangle"/>
+          </a:ln>
+        </p:spPr>
+        <p:style>
+          <a:lnRef idx="2">
+            <a:schemeClr val="accent1"/>
+          </a:lnRef>
+          <a:fillRef idx="0">
+            <a:schemeClr val="accent1"/>
+          </a:fillRef>
+          <a:effectRef idx="1">
+            <a:schemeClr val="accent1"/>
+          </a:effectRef>
+          <a:fontRef idx="minor">
+            <a:schemeClr val="tx1"/>
+          </a:fontRef>
+        </p:style>
+      </p:cxnSp>
+      <p:cxnSp>
+        <p:nvCxnSpPr>
+          <p:cNvPr id="33" name="Straight Arrow Connector 32">
+            <a:extLst>
+              <a:ext uri="{FF2B5EF4-FFF2-40B4-BE49-F238E27FC236}">
+                <a16:creationId xmlns:a16="http://schemas.microsoft.com/office/drawing/2014/main" id="{D0DEA290-90F8-28D1-6CBD-C733FE940D32}"/>
+              </a:ext>
+            </a:extLst>
+          </p:cNvPr>
+          <p:cNvCxnSpPr>
+            <a:cxnSpLocks/>
+            <a:stCxn id="16" idx="2"/>
+            <a:endCxn id="31" idx="1"/>
+          </p:cNvCxnSpPr>
+          <p:nvPr/>
+        </p:nvCxnSpPr>
+        <p:spPr>
+          <a:xfrm flipH="1">
+            <a:off x="5608925" y="700260"/>
+            <a:ext cx="397370" cy="1515026"/>
+          </a:xfrm>
+          <a:prstGeom prst="straightConnector1">
+            <a:avLst/>
+          </a:prstGeom>
+          <a:ln>
+            <a:solidFill>
+              <a:srgbClr val="FF0000"/>
+            </a:solidFill>
+            <a:tailEnd type="triangle"/>
+          </a:ln>
+        </p:spPr>
+        <p:style>
+          <a:lnRef idx="2">
+            <a:schemeClr val="accent1"/>
+          </a:lnRef>
+          <a:fillRef idx="0">
+            <a:schemeClr val="accent1"/>
+          </a:fillRef>
+          <a:effectRef idx="1">
+            <a:schemeClr val="accent1"/>
+          </a:effectRef>
+          <a:fontRef idx="minor">
+            <a:schemeClr val="tx1"/>
+          </a:fontRef>
+        </p:style>
+      </p:cxnSp>
+      <p:cxnSp>
+        <p:nvCxnSpPr>
+          <p:cNvPr id="34" name="Straight Arrow Connector 33">
+            <a:extLst>
+              <a:ext uri="{FF2B5EF4-FFF2-40B4-BE49-F238E27FC236}">
+                <a16:creationId xmlns:a16="http://schemas.microsoft.com/office/drawing/2014/main" id="{D4880E23-506E-F8A1-178D-DD14868625AA}"/>
+              </a:ext>
+            </a:extLst>
+          </p:cNvPr>
+          <p:cNvCxnSpPr/>
+          <p:nvPr/>
+        </p:nvCxnSpPr>
+        <p:spPr>
+          <a:xfrm>
+            <a:off x="10021583" y="4194873"/>
+            <a:ext cx="400178" cy="829107"/>
+          </a:xfrm>
+          <a:prstGeom prst="straightConnector1">
+            <a:avLst/>
+          </a:prstGeom>
+          <a:ln>
+            <a:solidFill>
+              <a:srgbClr val="FF0000"/>
+            </a:solidFill>
+            <a:tailEnd type="triangle"/>
+          </a:ln>
+        </p:spPr>
+        <p:style>
+          <a:lnRef idx="2">
+            <a:schemeClr val="accent1"/>
+          </a:lnRef>
+          <a:fillRef idx="0">
+            <a:schemeClr val="accent1"/>
+          </a:fillRef>
+          <a:effectRef idx="1">
+            <a:schemeClr val="accent1"/>
+          </a:effectRef>
+          <a:fontRef idx="minor">
+            <a:schemeClr val="tx1"/>
+          </a:fontRef>
+        </p:style>
+      </p:cxnSp>
+      <p:cxnSp>
+        <p:nvCxnSpPr>
+          <p:cNvPr id="35" name="Straight Arrow Connector 34">
+            <a:extLst>
+              <a:ext uri="{FF2B5EF4-FFF2-40B4-BE49-F238E27FC236}">
+                <a16:creationId xmlns:a16="http://schemas.microsoft.com/office/drawing/2014/main" id="{1CBE9FD5-C548-4E8D-1796-AB52E919A60F}"/>
+              </a:ext>
+            </a:extLst>
+          </p:cNvPr>
+          <p:cNvCxnSpPr/>
+          <p:nvPr/>
+        </p:nvCxnSpPr>
+        <p:spPr>
+          <a:xfrm>
+            <a:off x="10173983" y="4347273"/>
+            <a:ext cx="400178" cy="829107"/>
+          </a:xfrm>
+          <a:prstGeom prst="straightConnector1">
+            <a:avLst/>
+          </a:prstGeom>
+          <a:ln>
+            <a:solidFill>
+              <a:srgbClr val="FF0000"/>
+            </a:solidFill>
+            <a:tailEnd type="triangle"/>
+          </a:ln>
+        </p:spPr>
+        <p:style>
+          <a:lnRef idx="2">
+            <a:schemeClr val="accent1"/>
+          </a:lnRef>
+          <a:fillRef idx="0">
+            <a:schemeClr val="accent1"/>
+          </a:fillRef>
+          <a:effectRef idx="1">
+            <a:schemeClr val="accent1"/>
+          </a:effectRef>
+          <a:fontRef idx="minor">
+            <a:schemeClr val="tx1"/>
+          </a:fontRef>
+        </p:style>
+      </p:cxnSp>
+      <p:cxnSp>
+        <p:nvCxnSpPr>
+          <p:cNvPr id="36" name="Straight Arrow Connector 35">
+            <a:extLst>
+              <a:ext uri="{FF2B5EF4-FFF2-40B4-BE49-F238E27FC236}">
+                <a16:creationId xmlns:a16="http://schemas.microsoft.com/office/drawing/2014/main" id="{9A5A32E0-CA1D-F4D9-E93F-E30902460FBC}"/>
+              </a:ext>
+            </a:extLst>
+          </p:cNvPr>
+          <p:cNvCxnSpPr/>
+          <p:nvPr/>
+        </p:nvCxnSpPr>
+        <p:spPr>
+          <a:xfrm>
+            <a:off x="10326383" y="4499673"/>
+            <a:ext cx="400178" cy="829107"/>
+          </a:xfrm>
+          <a:prstGeom prst="straightConnector1">
+            <a:avLst/>
+          </a:prstGeom>
+          <a:ln>
+            <a:solidFill>
+              <a:srgbClr val="FF0000"/>
+            </a:solidFill>
+            <a:tailEnd type="triangle"/>
+          </a:ln>
+        </p:spPr>
+        <p:style>
+          <a:lnRef idx="2">
+            <a:schemeClr val="accent1"/>
+          </a:lnRef>
+          <a:fillRef idx="0">
+            <a:schemeClr val="accent1"/>
+          </a:fillRef>
+          <a:effectRef idx="1">
+            <a:schemeClr val="accent1"/>
+          </a:effectRef>
+          <a:fontRef idx="minor">
+            <a:schemeClr val="tx1"/>
+          </a:fontRef>
+        </p:style>
+      </p:cxnSp>
+      <p:cxnSp>
+        <p:nvCxnSpPr>
+          <p:cNvPr id="39" name="Straight Arrow Connector 38">
+            <a:extLst>
+              <a:ext uri="{FF2B5EF4-FFF2-40B4-BE49-F238E27FC236}">
+                <a16:creationId xmlns:a16="http://schemas.microsoft.com/office/drawing/2014/main" id="{7CC5CA1E-2771-5D66-2E70-B26BC853E70E}"/>
+              </a:ext>
+            </a:extLst>
+          </p:cNvPr>
+          <p:cNvCxnSpPr>
+            <a:cxnSpLocks/>
+            <a:stCxn id="24" idx="3"/>
+          </p:cNvCxnSpPr>
+          <p:nvPr/>
+        </p:nvCxnSpPr>
+        <p:spPr>
+          <a:xfrm flipV="1">
+            <a:off x="4053696" y="3074498"/>
+            <a:ext cx="1326482" cy="513123"/>
+          </a:xfrm>
+          <a:prstGeom prst="straightConnector1">
+            <a:avLst/>
+          </a:prstGeom>
+          <a:ln>
+            <a:solidFill>
+              <a:srgbClr val="FF0000"/>
+            </a:solidFill>
+            <a:tailEnd type="triangle"/>
+          </a:ln>
+        </p:spPr>
+        <p:style>
+          <a:lnRef idx="2">
+            <a:schemeClr val="accent1"/>
+          </a:lnRef>
+          <a:fillRef idx="0">
+            <a:schemeClr val="accent1"/>
+          </a:fillRef>
+          <a:effectRef idx="1">
+            <a:schemeClr val="accent1"/>
+          </a:effectRef>
+          <a:fontRef idx="minor">
+            <a:schemeClr val="tx1"/>
+          </a:fontRef>
+        </p:style>
+      </p:cxnSp>
+      <p:cxnSp>
+        <p:nvCxnSpPr>
+          <p:cNvPr id="42" name="Straight Arrow Connector 41">
+            <a:extLst>
+              <a:ext uri="{FF2B5EF4-FFF2-40B4-BE49-F238E27FC236}">
+                <a16:creationId xmlns:a16="http://schemas.microsoft.com/office/drawing/2014/main" id="{C523899B-4D9D-5339-9C5E-BFA19B705426}"/>
+              </a:ext>
+            </a:extLst>
+          </p:cNvPr>
+          <p:cNvCxnSpPr>
+            <a:cxnSpLocks/>
+            <a:stCxn id="23" idx="3"/>
+          </p:cNvCxnSpPr>
+          <p:nvPr/>
+        </p:nvCxnSpPr>
+        <p:spPr>
+          <a:xfrm flipV="1">
+            <a:off x="4053696" y="3604556"/>
+            <a:ext cx="1333884" cy="458264"/>
+          </a:xfrm>
+          <a:prstGeom prst="straightConnector1">
+            <a:avLst/>
+          </a:prstGeom>
+          <a:ln>
+            <a:solidFill>
+              <a:srgbClr val="FF0000"/>
+            </a:solidFill>
+            <a:tailEnd type="triangle"/>
+          </a:ln>
+        </p:spPr>
+        <p:style>
+          <a:lnRef idx="2">
+            <a:schemeClr val="accent1"/>
+          </a:lnRef>
+          <a:fillRef idx="0">
+            <a:schemeClr val="accent1"/>
+          </a:fillRef>
+          <a:effectRef idx="1">
+            <a:schemeClr val="accent1"/>
+          </a:effectRef>
+          <a:fontRef idx="minor">
+            <a:schemeClr val="tx1"/>
+          </a:fontRef>
+        </p:style>
+      </p:cxnSp>
+      <p:cxnSp>
+        <p:nvCxnSpPr>
+          <p:cNvPr id="43" name="Straight Arrow Connector 42">
+            <a:extLst>
+              <a:ext uri="{FF2B5EF4-FFF2-40B4-BE49-F238E27FC236}">
+                <a16:creationId xmlns:a16="http://schemas.microsoft.com/office/drawing/2014/main" id="{8BB9347A-1448-9C36-E156-00C8C555592D}"/>
+              </a:ext>
+            </a:extLst>
+          </p:cNvPr>
+          <p:cNvCxnSpPr>
+            <a:cxnSpLocks/>
+            <a:stCxn id="17" idx="3"/>
+            <a:endCxn id="40" idx="1"/>
+          </p:cNvCxnSpPr>
+          <p:nvPr/>
+        </p:nvCxnSpPr>
+        <p:spPr>
+          <a:xfrm>
+            <a:off x="3045288" y="1771531"/>
+            <a:ext cx="697973" cy="185976"/>
+          </a:xfrm>
+          <a:prstGeom prst="straightConnector1">
+            <a:avLst/>
+          </a:prstGeom>
+          <a:ln>
+            <a:solidFill>
+              <a:srgbClr val="FF0000"/>
+            </a:solidFill>
+            <a:tailEnd type="triangle"/>
+          </a:ln>
+        </p:spPr>
+        <p:style>
+          <a:lnRef idx="2">
+            <a:schemeClr val="accent1"/>
+          </a:lnRef>
+          <a:fillRef idx="0">
+            <a:schemeClr val="accent1"/>
+          </a:fillRef>
+          <a:effectRef idx="1">
+            <a:schemeClr val="accent1"/>
+          </a:effectRef>
+          <a:fontRef idx="minor">
+            <a:schemeClr val="tx1"/>
+          </a:fontRef>
+        </p:style>
+      </p:cxnSp>
+      <p:cxnSp>
+        <p:nvCxnSpPr>
+          <p:cNvPr id="44" name="Straight Arrow Connector 43">
+            <a:extLst>
+              <a:ext uri="{FF2B5EF4-FFF2-40B4-BE49-F238E27FC236}">
+                <a16:creationId xmlns:a16="http://schemas.microsoft.com/office/drawing/2014/main" id="{73E7EA0A-B3C2-81CC-41E8-496E73B19E76}"/>
+              </a:ext>
+            </a:extLst>
+          </p:cNvPr>
+          <p:cNvCxnSpPr>
+            <a:cxnSpLocks/>
+            <a:stCxn id="29" idx="0"/>
+          </p:cNvCxnSpPr>
+          <p:nvPr/>
+        </p:nvCxnSpPr>
+        <p:spPr>
+          <a:xfrm flipV="1">
+            <a:off x="3874042" y="3350062"/>
+            <a:ext cx="1303164" cy="1918567"/>
+          </a:xfrm>
+          <a:prstGeom prst="straightConnector1">
+            <a:avLst/>
+          </a:prstGeom>
+          <a:ln>
+            <a:solidFill>
+              <a:srgbClr val="FF0000"/>
+            </a:solidFill>
+            <a:tailEnd type="triangle"/>
+          </a:ln>
+        </p:spPr>
+        <p:style>
+          <a:lnRef idx="2">
+            <a:schemeClr val="accent1"/>
+          </a:lnRef>
+          <a:fillRef idx="0">
+            <a:schemeClr val="accent1"/>
+          </a:fillRef>
+          <a:effectRef idx="1">
+            <a:schemeClr val="accent1"/>
+          </a:effectRef>
+          <a:fontRef idx="minor">
+            <a:schemeClr val="tx1"/>
+          </a:fontRef>
+        </p:style>
+      </p:cxnSp>
+      <p:cxnSp>
+        <p:nvCxnSpPr>
+          <p:cNvPr id="45" name="Straight Arrow Connector 44">
+            <a:extLst>
+              <a:ext uri="{FF2B5EF4-FFF2-40B4-BE49-F238E27FC236}">
+                <a16:creationId xmlns:a16="http://schemas.microsoft.com/office/drawing/2014/main" id="{8DDF0C2D-32E3-CA34-48C3-798CBE854D40}"/>
+              </a:ext>
+            </a:extLst>
+          </p:cNvPr>
+          <p:cNvCxnSpPr>
+            <a:cxnSpLocks/>
+            <a:stCxn id="49" idx="0"/>
+          </p:cNvCxnSpPr>
+          <p:nvPr/>
+        </p:nvCxnSpPr>
+        <p:spPr>
+          <a:xfrm flipH="1" flipV="1">
+            <a:off x="5696657" y="3350062"/>
+            <a:ext cx="6847" cy="1957340"/>
+          </a:xfrm>
+          <a:prstGeom prst="straightConnector1">
+            <a:avLst/>
+          </a:prstGeom>
+          <a:ln>
+            <a:solidFill>
+              <a:srgbClr val="FF0000"/>
+            </a:solidFill>
+            <a:tailEnd type="triangle"/>
+          </a:ln>
+        </p:spPr>
+        <p:style>
+          <a:lnRef idx="2">
+            <a:schemeClr val="accent1"/>
+          </a:lnRef>
+          <a:fillRef idx="0">
+            <a:schemeClr val="accent1"/>
+          </a:fillRef>
+          <a:effectRef idx="1">
+            <a:schemeClr val="accent1"/>
+          </a:effectRef>
+          <a:fontRef idx="minor">
+            <a:schemeClr val="tx1"/>
+          </a:fontRef>
+        </p:style>
+      </p:cxnSp>
+      <p:cxnSp>
+        <p:nvCxnSpPr>
+          <p:cNvPr id="46" name="Straight Arrow Connector 45">
+            <a:extLst>
+              <a:ext uri="{FF2B5EF4-FFF2-40B4-BE49-F238E27FC236}">
+                <a16:creationId xmlns:a16="http://schemas.microsoft.com/office/drawing/2014/main" id="{B2325063-E19B-E3AD-067B-B0DBB5BA31A5}"/>
+              </a:ext>
+            </a:extLst>
+          </p:cNvPr>
+          <p:cNvCxnSpPr>
+            <a:cxnSpLocks/>
+            <a:stCxn id="14" idx="1"/>
+          </p:cNvCxnSpPr>
+          <p:nvPr/>
+        </p:nvCxnSpPr>
+        <p:spPr>
+          <a:xfrm flipH="1" flipV="1">
+            <a:off x="7482254" y="2969062"/>
+            <a:ext cx="1648772" cy="539621"/>
+          </a:xfrm>
+          <a:prstGeom prst="straightConnector1">
+            <a:avLst/>
+          </a:prstGeom>
+          <a:ln>
+            <a:solidFill>
+              <a:srgbClr val="FF0000"/>
+            </a:solidFill>
+            <a:tailEnd type="triangle"/>
+          </a:ln>
+        </p:spPr>
+        <p:style>
+          <a:lnRef idx="2">
+            <a:schemeClr val="accent1"/>
+          </a:lnRef>
+          <a:fillRef idx="0">
+            <a:schemeClr val="accent1"/>
+          </a:fillRef>
+          <a:effectRef idx="1">
+            <a:schemeClr val="accent1"/>
+          </a:effectRef>
+          <a:fontRef idx="minor">
+            <a:schemeClr val="tx1"/>
+          </a:fontRef>
+        </p:style>
+      </p:cxnSp>
+      <p:sp>
+        <p:nvSpPr>
+          <p:cNvPr id="49" name="Rectangle 48">
+            <a:extLst>
+              <a:ext uri="{FF2B5EF4-FFF2-40B4-BE49-F238E27FC236}">
+                <a16:creationId xmlns:a16="http://schemas.microsoft.com/office/drawing/2014/main" id="{0E13D29F-7527-67DC-910F-7C75EBB88EAA}"/>
               </a:ext>
             </a:extLst>
           </p:cNvPr>
@@ -6933,8 +7848,8 @@
         </p:nvSpPr>
         <p:spPr>
           <a:xfrm>
-            <a:off x="395447" y="1477373"/>
-            <a:ext cx="1776927" cy="317241"/>
+            <a:off x="4905736" y="5307402"/>
+            <a:ext cx="1595535" cy="471859"/>
           </a:xfrm>
           <a:prstGeom prst="rect">
             <a:avLst/>
@@ -6981,134 +7896,16 @@
                   <a:schemeClr val="tx2"/>
                 </a:solidFill>
               </a:rPr>
-              <a:t>Retract Climber</a:t>
-            </a:r>
-          </a:p>
-        </p:txBody>
-      </p:sp>
-      <p:sp>
-        <p:nvSpPr>
-          <p:cNvPr id="24" name="Rectangle 23">
-            <a:extLst>
-              <a:ext uri="{FF2B5EF4-FFF2-40B4-BE49-F238E27FC236}">
-                <a16:creationId xmlns:a16="http://schemas.microsoft.com/office/drawing/2014/main" id="{9FC38623-D4B1-E2FF-6BA6-B423FA6F1473}"/>
-              </a:ext>
-            </a:extLst>
-          </p:cNvPr>
-          <p:cNvSpPr/>
-          <p:nvPr/>
-        </p:nvSpPr>
-        <p:spPr>
-          <a:xfrm>
-            <a:off x="393959" y="1934506"/>
-            <a:ext cx="1776927" cy="317241"/>
-          </a:xfrm>
-          <a:prstGeom prst="rect">
-            <a:avLst/>
-          </a:prstGeom>
-          <a:solidFill>
-            <a:schemeClr val="accent6">
-              <a:lumMod val="20000"/>
-              <a:lumOff val="80000"/>
-            </a:schemeClr>
-          </a:solidFill>
-          <a:ln>
-            <a:solidFill>
-              <a:schemeClr val="accent2">
-                <a:lumMod val="20000"/>
-                <a:lumOff val="80000"/>
-              </a:schemeClr>
-            </a:solidFill>
-          </a:ln>
-        </p:spPr>
-        <p:style>
-          <a:lnRef idx="2">
-            <a:schemeClr val="accent1">
-              <a:shade val="15000"/>
-            </a:schemeClr>
-          </a:lnRef>
-          <a:fillRef idx="1">
-            <a:schemeClr val="accent1"/>
-          </a:fillRef>
-          <a:effectRef idx="0">
-            <a:schemeClr val="accent1"/>
-          </a:effectRef>
-          <a:fontRef idx="minor">
-            <a:schemeClr val="lt1"/>
-          </a:fontRef>
-        </p:style>
-        <p:txBody>
-          <a:bodyPr rtlCol="0" anchor="ctr"/>
-          <a:lstStyle/>
-          <a:p>
-            <a:pPr algn="ctr"/>
-            <a:r>
-              <a:rPr lang="en-US" dirty="0">
+              <a:t>Deploy Intake </a:t>
+            </a:r>
+            <a:r>
+              <a:rPr lang="en-US" sz="1200" dirty="0">
                 <a:solidFill>
                   <a:schemeClr val="tx2"/>
                 </a:solidFill>
               </a:rPr>
-              <a:t>Extend Climber</a:t>
-            </a:r>
-          </a:p>
-        </p:txBody>
-      </p:sp>
-      <p:sp>
-        <p:nvSpPr>
-          <p:cNvPr id="25" name="Rectangle 24">
-            <a:extLst>
-              <a:ext uri="{FF2B5EF4-FFF2-40B4-BE49-F238E27FC236}">
-                <a16:creationId xmlns:a16="http://schemas.microsoft.com/office/drawing/2014/main" id="{652C7253-60E3-A184-4D6E-E07579E3A8CC}"/>
-              </a:ext>
-            </a:extLst>
-          </p:cNvPr>
-          <p:cNvSpPr/>
-          <p:nvPr/>
-        </p:nvSpPr>
-        <p:spPr>
-          <a:xfrm>
-            <a:off x="8905536" y="3874797"/>
-            <a:ext cx="1595535" cy="317241"/>
-          </a:xfrm>
-          <a:prstGeom prst="rect">
-            <a:avLst/>
-          </a:prstGeom>
-          <a:solidFill>
-            <a:schemeClr val="accent6">
-              <a:lumMod val="20000"/>
-              <a:lumOff val="80000"/>
-            </a:schemeClr>
-          </a:solidFill>
-          <a:ln>
-            <a:solidFill>
-              <a:schemeClr val="accent2">
-                <a:lumMod val="20000"/>
-                <a:lumOff val="80000"/>
-              </a:schemeClr>
-            </a:solidFill>
-          </a:ln>
-        </p:spPr>
-        <p:style>
-          <a:lnRef idx="2">
-            <a:schemeClr val="accent1">
-              <a:shade val="15000"/>
-            </a:schemeClr>
-          </a:lnRef>
-          <a:fillRef idx="1">
-            <a:schemeClr val="accent1"/>
-          </a:fillRef>
-          <a:effectRef idx="0">
-            <a:schemeClr val="accent1"/>
-          </a:effectRef>
-          <a:fontRef idx="minor">
-            <a:schemeClr val="lt1"/>
-          </a:fontRef>
-        </p:style>
-        <p:txBody>
-          <a:bodyPr rtlCol="0" anchor="ctr"/>
-          <a:lstStyle/>
-          <a:p>
-            <a:pPr algn="ctr"/>
+              <a:t>(down)</a:t>
+            </a:r>
             <a:endParaRPr lang="en-US" dirty="0">
               <a:solidFill>
                 <a:schemeClr val="tx2"/>
@@ -7117,268 +7914,310 @@
           </a:p>
         </p:txBody>
       </p:sp>
-      <p:sp>
-        <p:nvSpPr>
-          <p:cNvPr id="26" name="Rectangle 25">
-            <a:extLst>
-              <a:ext uri="{FF2B5EF4-FFF2-40B4-BE49-F238E27FC236}">
-                <a16:creationId xmlns:a16="http://schemas.microsoft.com/office/drawing/2014/main" id="{6B6E82EA-1AE1-CFB3-BE12-C33072D8CBE7}"/>
-              </a:ext>
-            </a:extLst>
-          </p:cNvPr>
-          <p:cNvSpPr/>
-          <p:nvPr/>
-        </p:nvSpPr>
-        <p:spPr>
-          <a:xfrm>
-            <a:off x="9057936" y="4027197"/>
-            <a:ext cx="1595535" cy="317241"/>
-          </a:xfrm>
-          <a:prstGeom prst="rect">
-            <a:avLst/>
-          </a:prstGeom>
-          <a:solidFill>
-            <a:schemeClr val="accent6">
-              <a:lumMod val="20000"/>
-              <a:lumOff val="80000"/>
-            </a:schemeClr>
-          </a:solidFill>
+      <p:cxnSp>
+        <p:nvCxnSpPr>
+          <p:cNvPr id="57" name="Straight Arrow Connector 56">
+            <a:extLst>
+              <a:ext uri="{FF2B5EF4-FFF2-40B4-BE49-F238E27FC236}">
+                <a16:creationId xmlns:a16="http://schemas.microsoft.com/office/drawing/2014/main" id="{47B6922E-B551-616F-95A0-C704B3DA611B}"/>
+              </a:ext>
+            </a:extLst>
+          </p:cNvPr>
+          <p:cNvCxnSpPr/>
+          <p:nvPr/>
+        </p:nvCxnSpPr>
+        <p:spPr>
+          <a:xfrm>
+            <a:off x="10881133" y="3859790"/>
+            <a:ext cx="400178" cy="829107"/>
+          </a:xfrm>
+          <a:prstGeom prst="straightConnector1">
+            <a:avLst/>
+          </a:prstGeom>
           <a:ln>
             <a:solidFill>
-              <a:schemeClr val="accent2">
-                <a:lumMod val="20000"/>
-                <a:lumOff val="80000"/>
-              </a:schemeClr>
+              <a:srgbClr val="FF0000"/>
             </a:solidFill>
+            <a:tailEnd type="triangle"/>
           </a:ln>
         </p:spPr>
         <p:style>
           <a:lnRef idx="2">
-            <a:schemeClr val="accent1">
-              <a:shade val="15000"/>
-            </a:schemeClr>
-          </a:lnRef>
-          <a:fillRef idx="1">
-            <a:schemeClr val="accent1"/>
-          </a:fillRef>
-          <a:effectRef idx="0">
-            <a:schemeClr val="accent1"/>
-          </a:effectRef>
-          <a:fontRef idx="minor">
-            <a:schemeClr val="lt1"/>
-          </a:fontRef>
-        </p:style>
-        <p:txBody>
-          <a:bodyPr rtlCol="0" anchor="ctr"/>
-          <a:lstStyle/>
-          <a:p>
-            <a:pPr algn="ctr"/>
-            <a:endParaRPr lang="en-US" dirty="0">
-              <a:solidFill>
-                <a:schemeClr val="tx2"/>
-              </a:solidFill>
-            </a:endParaRPr>
-          </a:p>
-        </p:txBody>
-      </p:sp>
-      <p:sp>
-        <p:nvSpPr>
-          <p:cNvPr id="27" name="Rectangle 26">
-            <a:extLst>
-              <a:ext uri="{FF2B5EF4-FFF2-40B4-BE49-F238E27FC236}">
-                <a16:creationId xmlns:a16="http://schemas.microsoft.com/office/drawing/2014/main" id="{536CB937-8976-AE7B-7FE7-929F24F3C592}"/>
-              </a:ext>
-            </a:extLst>
-          </p:cNvPr>
-          <p:cNvSpPr/>
-          <p:nvPr/>
-        </p:nvSpPr>
-        <p:spPr>
-          <a:xfrm>
-            <a:off x="9210336" y="4179597"/>
-            <a:ext cx="1595535" cy="317241"/>
-          </a:xfrm>
-          <a:prstGeom prst="rect">
-            <a:avLst/>
-          </a:prstGeom>
-          <a:solidFill>
-            <a:schemeClr val="accent6">
-              <a:lumMod val="20000"/>
-              <a:lumOff val="80000"/>
-            </a:schemeClr>
-          </a:solidFill>
+            <a:schemeClr val="accent1"/>
+          </a:lnRef>
+          <a:fillRef idx="0">
+            <a:schemeClr val="accent1"/>
+          </a:fillRef>
+          <a:effectRef idx="1">
+            <a:schemeClr val="accent1"/>
+          </a:effectRef>
+          <a:fontRef idx="minor">
+            <a:schemeClr val="tx1"/>
+          </a:fontRef>
+        </p:style>
+      </p:cxnSp>
+      <p:cxnSp>
+        <p:nvCxnSpPr>
+          <p:cNvPr id="58" name="Straight Arrow Connector 57">
+            <a:extLst>
+              <a:ext uri="{FF2B5EF4-FFF2-40B4-BE49-F238E27FC236}">
+                <a16:creationId xmlns:a16="http://schemas.microsoft.com/office/drawing/2014/main" id="{9D2BFB52-60A8-3EDA-BAB7-FAF1E5BB88C4}"/>
+              </a:ext>
+            </a:extLst>
+          </p:cNvPr>
+          <p:cNvCxnSpPr/>
+          <p:nvPr/>
+        </p:nvCxnSpPr>
+        <p:spPr>
+          <a:xfrm>
+            <a:off x="11033533" y="4012190"/>
+            <a:ext cx="400178" cy="829107"/>
+          </a:xfrm>
+          <a:prstGeom prst="straightConnector1">
+            <a:avLst/>
+          </a:prstGeom>
           <a:ln>
             <a:solidFill>
-              <a:schemeClr val="accent2">
-                <a:lumMod val="20000"/>
-                <a:lumOff val="80000"/>
-              </a:schemeClr>
+              <a:srgbClr val="FF0000"/>
             </a:solidFill>
+            <a:tailEnd type="triangle"/>
           </a:ln>
         </p:spPr>
         <p:style>
           <a:lnRef idx="2">
-            <a:schemeClr val="accent1">
-              <a:shade val="15000"/>
-            </a:schemeClr>
-          </a:lnRef>
-          <a:fillRef idx="1">
-            <a:schemeClr val="accent1"/>
-          </a:fillRef>
-          <a:effectRef idx="0">
-            <a:schemeClr val="accent1"/>
-          </a:effectRef>
-          <a:fontRef idx="minor">
-            <a:schemeClr val="lt1"/>
-          </a:fontRef>
-        </p:style>
-        <p:txBody>
-          <a:bodyPr rtlCol="0" anchor="ctr"/>
-          <a:lstStyle/>
-          <a:p>
-            <a:pPr algn="ctr"/>
-            <a:endParaRPr lang="en-US" dirty="0">
-              <a:solidFill>
-                <a:schemeClr val="tx2"/>
-              </a:solidFill>
-            </a:endParaRPr>
-          </a:p>
-        </p:txBody>
-      </p:sp>
-      <p:sp>
-        <p:nvSpPr>
-          <p:cNvPr id="28" name="Rectangle 27">
-            <a:extLst>
-              <a:ext uri="{FF2B5EF4-FFF2-40B4-BE49-F238E27FC236}">
-                <a16:creationId xmlns:a16="http://schemas.microsoft.com/office/drawing/2014/main" id="{2313DCAD-124D-5850-AD89-3AB6441F9862}"/>
-              </a:ext>
-            </a:extLst>
-          </p:cNvPr>
-          <p:cNvSpPr/>
-          <p:nvPr/>
-        </p:nvSpPr>
-        <p:spPr>
-          <a:xfrm>
-            <a:off x="9362736" y="4331997"/>
-            <a:ext cx="1595535" cy="317241"/>
-          </a:xfrm>
-          <a:prstGeom prst="rect">
-            <a:avLst/>
-          </a:prstGeom>
-          <a:solidFill>
-            <a:schemeClr val="accent6">
-              <a:lumMod val="20000"/>
-              <a:lumOff val="80000"/>
-            </a:schemeClr>
-          </a:solidFill>
+            <a:schemeClr val="accent1"/>
+          </a:lnRef>
+          <a:fillRef idx="0">
+            <a:schemeClr val="accent1"/>
+          </a:fillRef>
+          <a:effectRef idx="1">
+            <a:schemeClr val="accent1"/>
+          </a:effectRef>
+          <a:fontRef idx="minor">
+            <a:schemeClr val="tx1"/>
+          </a:fontRef>
+        </p:style>
+      </p:cxnSp>
+      <p:cxnSp>
+        <p:nvCxnSpPr>
+          <p:cNvPr id="59" name="Straight Arrow Connector 58">
+            <a:extLst>
+              <a:ext uri="{FF2B5EF4-FFF2-40B4-BE49-F238E27FC236}">
+                <a16:creationId xmlns:a16="http://schemas.microsoft.com/office/drawing/2014/main" id="{02DB378A-D1BC-64C7-3E13-6875826B9912}"/>
+              </a:ext>
+            </a:extLst>
+          </p:cNvPr>
+          <p:cNvCxnSpPr/>
+          <p:nvPr/>
+        </p:nvCxnSpPr>
+        <p:spPr>
+          <a:xfrm>
+            <a:off x="11185933" y="4164590"/>
+            <a:ext cx="400178" cy="829107"/>
+          </a:xfrm>
+          <a:prstGeom prst="straightConnector1">
+            <a:avLst/>
+          </a:prstGeom>
           <a:ln>
             <a:solidFill>
-              <a:schemeClr val="accent2">
-                <a:lumMod val="20000"/>
-                <a:lumOff val="80000"/>
-              </a:schemeClr>
+              <a:srgbClr val="FF0000"/>
             </a:solidFill>
+            <a:tailEnd type="triangle"/>
           </a:ln>
         </p:spPr>
         <p:style>
           <a:lnRef idx="2">
-            <a:schemeClr val="accent1">
-              <a:shade val="15000"/>
-            </a:schemeClr>
-          </a:lnRef>
-          <a:fillRef idx="1">
-            <a:schemeClr val="accent1"/>
-          </a:fillRef>
-          <a:effectRef idx="0">
-            <a:schemeClr val="accent1"/>
-          </a:effectRef>
-          <a:fontRef idx="minor">
-            <a:schemeClr val="lt1"/>
-          </a:fontRef>
-        </p:style>
-        <p:txBody>
-          <a:bodyPr rtlCol="0" anchor="ctr"/>
-          <a:lstStyle/>
-          <a:p>
-            <a:pPr algn="ctr"/>
-            <a:endParaRPr lang="en-US" dirty="0">
-              <a:solidFill>
-                <a:schemeClr val="tx2"/>
-              </a:solidFill>
-            </a:endParaRPr>
-          </a:p>
-        </p:txBody>
-      </p:sp>
-      <p:sp>
-        <p:nvSpPr>
-          <p:cNvPr id="29" name="Rectangle 28">
-            <a:extLst>
-              <a:ext uri="{FF2B5EF4-FFF2-40B4-BE49-F238E27FC236}">
-                <a16:creationId xmlns:a16="http://schemas.microsoft.com/office/drawing/2014/main" id="{530B3026-3929-68C0-D9CA-51C0578C6396}"/>
-              </a:ext>
-            </a:extLst>
-          </p:cNvPr>
-          <p:cNvSpPr/>
-          <p:nvPr/>
-        </p:nvSpPr>
-        <p:spPr>
-          <a:xfrm>
-            <a:off x="9515136" y="4484397"/>
-            <a:ext cx="1595535" cy="317241"/>
-          </a:xfrm>
-          <a:prstGeom prst="rect">
-            <a:avLst/>
-          </a:prstGeom>
-          <a:solidFill>
-            <a:schemeClr val="accent6">
-              <a:lumMod val="20000"/>
-              <a:lumOff val="80000"/>
-            </a:schemeClr>
-          </a:solidFill>
+            <a:schemeClr val="accent1"/>
+          </a:lnRef>
+          <a:fillRef idx="0">
+            <a:schemeClr val="accent1"/>
+          </a:fillRef>
+          <a:effectRef idx="1">
+            <a:schemeClr val="accent1"/>
+          </a:effectRef>
+          <a:fontRef idx="minor">
+            <a:schemeClr val="tx1"/>
+          </a:fontRef>
+        </p:style>
+      </p:cxnSp>
+      <p:cxnSp>
+        <p:nvCxnSpPr>
+          <p:cNvPr id="61" name="Straight Arrow Connector 60">
+            <a:extLst>
+              <a:ext uri="{FF2B5EF4-FFF2-40B4-BE49-F238E27FC236}">
+                <a16:creationId xmlns:a16="http://schemas.microsoft.com/office/drawing/2014/main" id="{A40DC03C-2D5E-A001-64E3-E19D2B3E612C}"/>
+              </a:ext>
+            </a:extLst>
+          </p:cNvPr>
+          <p:cNvCxnSpPr>
+            <a:cxnSpLocks/>
+            <a:stCxn id="13" idx="1"/>
+            <a:endCxn id="41" idx="3"/>
+          </p:cNvCxnSpPr>
+          <p:nvPr/>
+        </p:nvCxnSpPr>
+        <p:spPr>
+          <a:xfrm flipH="1">
+            <a:off x="8507779" y="1623952"/>
+            <a:ext cx="563636" cy="317240"/>
+          </a:xfrm>
+          <a:prstGeom prst="straightConnector1">
+            <a:avLst/>
+          </a:prstGeom>
           <a:ln>
             <a:solidFill>
-              <a:schemeClr val="accent2">
-                <a:lumMod val="20000"/>
-                <a:lumOff val="80000"/>
-              </a:schemeClr>
+              <a:srgbClr val="FF0000"/>
             </a:solidFill>
+            <a:tailEnd type="triangle"/>
           </a:ln>
         </p:spPr>
         <p:style>
           <a:lnRef idx="2">
-            <a:schemeClr val="accent1">
-              <a:shade val="15000"/>
-            </a:schemeClr>
-          </a:lnRef>
-          <a:fillRef idx="1">
-            <a:schemeClr val="accent1"/>
-          </a:fillRef>
-          <a:effectRef idx="0">
-            <a:schemeClr val="accent1"/>
-          </a:effectRef>
-          <a:fontRef idx="minor">
-            <a:schemeClr val="lt1"/>
-          </a:fontRef>
-        </p:style>
-        <p:txBody>
-          <a:bodyPr rtlCol="0" anchor="ctr"/>
-          <a:lstStyle/>
-          <a:p>
-            <a:pPr algn="ctr"/>
-            <a:endParaRPr lang="en-US" dirty="0">
-              <a:solidFill>
-                <a:schemeClr val="tx2"/>
-              </a:solidFill>
-            </a:endParaRPr>
-          </a:p>
-        </p:txBody>
-      </p:sp>
-      <p:sp>
-        <p:nvSpPr>
-          <p:cNvPr id="37" name="TextBox 36">
-            <a:extLst>
-              <a:ext uri="{FF2B5EF4-FFF2-40B4-BE49-F238E27FC236}">
-                <a16:creationId xmlns:a16="http://schemas.microsoft.com/office/drawing/2014/main" id="{DB13644A-9285-9111-3BBE-6AB488C981FF}"/>
+            <a:schemeClr val="accent1"/>
+          </a:lnRef>
+          <a:fillRef idx="0">
+            <a:schemeClr val="accent1"/>
+          </a:fillRef>
+          <a:effectRef idx="1">
+            <a:schemeClr val="accent1"/>
+          </a:effectRef>
+          <a:fontRef idx="minor">
+            <a:schemeClr val="tx1"/>
+          </a:fontRef>
+        </p:style>
+      </p:cxnSp>
+      <p:cxnSp>
+        <p:nvCxnSpPr>
+          <p:cNvPr id="62" name="Straight Arrow Connector 61">
+            <a:extLst>
+              <a:ext uri="{FF2B5EF4-FFF2-40B4-BE49-F238E27FC236}">
+                <a16:creationId xmlns:a16="http://schemas.microsoft.com/office/drawing/2014/main" id="{46CC430F-1C96-F7AF-802B-18DA56C6B849}"/>
+              </a:ext>
+            </a:extLst>
+          </p:cNvPr>
+          <p:cNvCxnSpPr/>
+          <p:nvPr/>
+        </p:nvCxnSpPr>
+        <p:spPr>
+          <a:xfrm>
+            <a:off x="10734261" y="4154321"/>
+            <a:ext cx="400178" cy="829107"/>
+          </a:xfrm>
+          <a:prstGeom prst="straightConnector1">
+            <a:avLst/>
+          </a:prstGeom>
+          <a:ln>
+            <a:solidFill>
+              <a:srgbClr val="FF0000"/>
+            </a:solidFill>
+            <a:tailEnd type="triangle"/>
+          </a:ln>
+        </p:spPr>
+        <p:style>
+          <a:lnRef idx="2">
+            <a:schemeClr val="accent1"/>
+          </a:lnRef>
+          <a:fillRef idx="0">
+            <a:schemeClr val="accent1"/>
+          </a:fillRef>
+          <a:effectRef idx="1">
+            <a:schemeClr val="accent1"/>
+          </a:effectRef>
+          <a:fontRef idx="minor">
+            <a:schemeClr val="tx1"/>
+          </a:fontRef>
+        </p:style>
+      </p:cxnSp>
+      <p:cxnSp>
+        <p:nvCxnSpPr>
+          <p:cNvPr id="63" name="Straight Arrow Connector 62">
+            <a:extLst>
+              <a:ext uri="{FF2B5EF4-FFF2-40B4-BE49-F238E27FC236}">
+                <a16:creationId xmlns:a16="http://schemas.microsoft.com/office/drawing/2014/main" id="{1397F8D8-E9D4-512A-2BA5-F56ACE47DAC8}"/>
+              </a:ext>
+            </a:extLst>
+          </p:cNvPr>
+          <p:cNvCxnSpPr/>
+          <p:nvPr/>
+        </p:nvCxnSpPr>
+        <p:spPr>
+          <a:xfrm>
+            <a:off x="10595539" y="4529394"/>
+            <a:ext cx="400178" cy="829107"/>
+          </a:xfrm>
+          <a:prstGeom prst="straightConnector1">
+            <a:avLst/>
+          </a:prstGeom>
+          <a:ln>
+            <a:solidFill>
+              <a:srgbClr val="FF0000"/>
+            </a:solidFill>
+            <a:tailEnd type="triangle"/>
+          </a:ln>
+        </p:spPr>
+        <p:style>
+          <a:lnRef idx="2">
+            <a:schemeClr val="accent1"/>
+          </a:lnRef>
+          <a:fillRef idx="0">
+            <a:schemeClr val="accent1"/>
+          </a:fillRef>
+          <a:effectRef idx="1">
+            <a:schemeClr val="accent1"/>
+          </a:effectRef>
+          <a:fontRef idx="minor">
+            <a:schemeClr val="tx1"/>
+          </a:fontRef>
+        </p:style>
+      </p:cxnSp>
+      <p:cxnSp>
+        <p:nvCxnSpPr>
+          <p:cNvPr id="64" name="Straight Arrow Connector 63">
+            <a:extLst>
+              <a:ext uri="{FF2B5EF4-FFF2-40B4-BE49-F238E27FC236}">
+                <a16:creationId xmlns:a16="http://schemas.microsoft.com/office/drawing/2014/main" id="{7C20C0ED-A4F3-F9CE-CA48-769B7B374086}"/>
+              </a:ext>
+            </a:extLst>
+          </p:cNvPr>
+          <p:cNvCxnSpPr/>
+          <p:nvPr/>
+        </p:nvCxnSpPr>
+        <p:spPr>
+          <a:xfrm>
+            <a:off x="11125784" y="4650568"/>
+            <a:ext cx="400178" cy="829107"/>
+          </a:xfrm>
+          <a:prstGeom prst="straightConnector1">
+            <a:avLst/>
+          </a:prstGeom>
+          <a:ln>
+            <a:solidFill>
+              <a:srgbClr val="FF0000"/>
+            </a:solidFill>
+            <a:tailEnd type="triangle"/>
+          </a:ln>
+        </p:spPr>
+        <p:style>
+          <a:lnRef idx="2">
+            <a:schemeClr val="accent1"/>
+          </a:lnRef>
+          <a:fillRef idx="0">
+            <a:schemeClr val="accent1"/>
+          </a:fillRef>
+          <a:effectRef idx="1">
+            <a:schemeClr val="accent1"/>
+          </a:effectRef>
+          <a:fontRef idx="minor">
+            <a:schemeClr val="tx1"/>
+          </a:fontRef>
+        </p:style>
+      </p:cxnSp>
+      <p:sp>
+        <p:nvSpPr>
+          <p:cNvPr id="86" name="TextBox 85">
+            <a:extLst>
+              <a:ext uri="{FF2B5EF4-FFF2-40B4-BE49-F238E27FC236}">
+                <a16:creationId xmlns:a16="http://schemas.microsoft.com/office/drawing/2014/main" id="{64FF40F8-86DB-E873-9B59-C8FF4F75FB8F}"/>
               </a:ext>
             </a:extLst>
           </p:cNvPr>
@@ -7387,8 +8226,8 @@
         </p:nvSpPr>
         <p:spPr>
           <a:xfrm>
-            <a:off x="4455776" y="3294796"/>
-            <a:ext cx="977220" cy="369332"/>
+            <a:off x="10764045" y="1040863"/>
+            <a:ext cx="1238289" cy="769441"/>
           </a:xfrm>
           <a:prstGeom prst="rect">
             <a:avLst/>
@@ -7396,32 +8235,24 @@
           <a:noFill/>
         </p:spPr>
         <p:txBody>
-          <a:bodyPr wrap="square">
+          <a:bodyPr wrap="square" rtlCol="0">
             <a:spAutoFit/>
           </a:bodyPr>
           <a:lstStyle/>
           <a:p>
-            <a:pPr algn="ctr"/>
-            <a:r>
-              <a:rPr lang="en-US" sz="1800" dirty="0">
-                <a:solidFill>
-                  <a:schemeClr val="accent2">
-                    <a:lumMod val="60000"/>
-                    <a:lumOff val="40000"/>
-                  </a:schemeClr>
-                </a:solidFill>
-              </a:rPr>
-              <a:t>Bumper</a:t>
-            </a:r>
-          </a:p>
-        </p:txBody>
-      </p:sp>
-      <p:sp>
-        <p:nvSpPr>
-          <p:cNvPr id="38" name="TextBox 37">
-            <a:extLst>
-              <a:ext uri="{FF2B5EF4-FFF2-40B4-BE49-F238E27FC236}">
-                <a16:creationId xmlns:a16="http://schemas.microsoft.com/office/drawing/2014/main" id="{663C2E0C-F6E9-C73C-F7F2-26D2724A3EC5}"/>
+            <a:r>
+              <a:rPr lang="en-US" sz="1100" dirty="0"/>
+              <a:t>Goto a good location, aim, engage brake, and shoot all fuel</a:t>
+            </a:r>
+          </a:p>
+        </p:txBody>
+      </p:sp>
+      <p:sp>
+        <p:nvSpPr>
+          <p:cNvPr id="93" name="TextBox 92">
+            <a:extLst>
+              <a:ext uri="{FF2B5EF4-FFF2-40B4-BE49-F238E27FC236}">
+                <a16:creationId xmlns:a16="http://schemas.microsoft.com/office/drawing/2014/main" id="{EA9B908C-C2A5-4AFB-330F-1619EF2A4E93}"/>
               </a:ext>
             </a:extLst>
           </p:cNvPr>
@@ -7430,8 +8261,8 @@
         </p:nvSpPr>
         <p:spPr>
           <a:xfrm>
-            <a:off x="6924656" y="3282792"/>
-            <a:ext cx="977220" cy="369332"/>
+            <a:off x="10745448" y="1886504"/>
+            <a:ext cx="1469585" cy="600164"/>
           </a:xfrm>
           <a:prstGeom prst="rect">
             <a:avLst/>
@@ -7439,188 +8270,14 @@
           <a:noFill/>
         </p:spPr>
         <p:txBody>
-          <a:bodyPr wrap="square">
+          <a:bodyPr wrap="square" rtlCol="0">
             <a:spAutoFit/>
           </a:bodyPr>
           <a:lstStyle/>
           <a:p>
-            <a:pPr algn="ctr"/>
-            <a:r>
-              <a:rPr lang="en-US" sz="1800" dirty="0">
-                <a:solidFill>
-                  <a:schemeClr val="accent2">
-                    <a:lumMod val="60000"/>
-                    <a:lumOff val="40000"/>
-                  </a:schemeClr>
-                </a:solidFill>
-              </a:rPr>
-              <a:t>Bumper</a:t>
-            </a:r>
-          </a:p>
-        </p:txBody>
-      </p:sp>
-      <p:sp>
-        <p:nvSpPr>
-          <p:cNvPr id="40" name="TextBox 39">
-            <a:extLst>
-              <a:ext uri="{FF2B5EF4-FFF2-40B4-BE49-F238E27FC236}">
-                <a16:creationId xmlns:a16="http://schemas.microsoft.com/office/drawing/2014/main" id="{5FC26886-D16D-E4C3-22DA-B6459CC232DD}"/>
-              </a:ext>
-            </a:extLst>
-          </p:cNvPr>
-          <p:cNvSpPr txBox="1"/>
-          <p:nvPr/>
-        </p:nvSpPr>
-        <p:spPr>
-          <a:xfrm>
-            <a:off x="3788677" y="3445315"/>
-            <a:ext cx="338554" cy="580800"/>
-          </a:xfrm>
-          <a:prstGeom prst="rect">
-            <a:avLst/>
-          </a:prstGeom>
-          <a:noFill/>
-        </p:spPr>
-        <p:txBody>
-          <a:bodyPr vert="vert270" wrap="none" lIns="0" tIns="0" rIns="91440" bIns="0" rtlCol="0">
-            <a:spAutoFit/>
-          </a:bodyPr>
-          <a:lstStyle/>
-          <a:p>
-            <a:pPr algn="ctr"/>
-            <a:r>
-              <a:rPr lang="en-US" sz="1600" dirty="0">
-                <a:solidFill>
-                  <a:schemeClr val="bg2"/>
-                </a:solidFill>
-              </a:rPr>
-              <a:t>Trigger</a:t>
-            </a:r>
-          </a:p>
-        </p:txBody>
-      </p:sp>
-      <p:sp>
-        <p:nvSpPr>
-          <p:cNvPr id="41" name="TextBox 40">
-            <a:extLst>
-              <a:ext uri="{FF2B5EF4-FFF2-40B4-BE49-F238E27FC236}">
-                <a16:creationId xmlns:a16="http://schemas.microsoft.com/office/drawing/2014/main" id="{4AAA1677-C84E-01A0-4838-DEC253AEDD33}"/>
-              </a:ext>
-            </a:extLst>
-          </p:cNvPr>
-          <p:cNvSpPr txBox="1"/>
-          <p:nvPr/>
-        </p:nvSpPr>
-        <p:spPr>
-          <a:xfrm>
-            <a:off x="8214641" y="3429000"/>
-            <a:ext cx="338554" cy="580800"/>
-          </a:xfrm>
-          <a:prstGeom prst="rect">
-            <a:avLst/>
-          </a:prstGeom>
-          <a:noFill/>
-        </p:spPr>
-        <p:txBody>
-          <a:bodyPr vert="vert270" wrap="none" lIns="0" tIns="0" rIns="91440" bIns="0" rtlCol="0">
-            <a:spAutoFit/>
-          </a:bodyPr>
-          <a:lstStyle/>
-          <a:p>
-            <a:pPr algn="ctr"/>
-            <a:r>
-              <a:rPr lang="en-US" sz="1600" dirty="0">
-                <a:solidFill>
-                  <a:schemeClr val="bg2"/>
-                </a:solidFill>
-              </a:rPr>
-              <a:t>Trigger</a:t>
-            </a:r>
-          </a:p>
-        </p:txBody>
-      </p:sp>
-      <p:sp>
-        <p:nvSpPr>
-          <p:cNvPr id="30" name="TextBox 29">
-            <a:extLst>
-              <a:ext uri="{FF2B5EF4-FFF2-40B4-BE49-F238E27FC236}">
-                <a16:creationId xmlns:a16="http://schemas.microsoft.com/office/drawing/2014/main" id="{4DD483E6-0944-EC88-9A25-F3839E12ED50}"/>
-              </a:ext>
-            </a:extLst>
-          </p:cNvPr>
-          <p:cNvSpPr txBox="1"/>
-          <p:nvPr/>
-        </p:nvSpPr>
-        <p:spPr>
-          <a:xfrm rot="5400000">
-            <a:off x="6456089" y="3957501"/>
-            <a:ext cx="276999" cy="306301"/>
-          </a:xfrm>
-          <a:prstGeom prst="rect">
-            <a:avLst/>
-          </a:prstGeom>
-          <a:noFill/>
-        </p:spPr>
-        <p:txBody>
-          <a:bodyPr vert="vert270" wrap="none" lIns="0" tIns="0" rIns="91440" bIns="0" rtlCol="0">
-            <a:spAutoFit/>
-          </a:bodyPr>
-          <a:lstStyle/>
-          <a:p>
-            <a:pPr algn="ctr"/>
-            <a:r>
-              <a:rPr lang="en-US" sz="1200" dirty="0">
-                <a:solidFill>
-                  <a:schemeClr val="accent2">
-                    <a:lumMod val="60000"/>
-                    <a:lumOff val="40000"/>
-                  </a:schemeClr>
-                </a:solidFill>
-              </a:rPr>
-              <a:t>start</a:t>
-            </a:r>
-          </a:p>
-        </p:txBody>
-      </p:sp>
-      <p:sp>
-        <p:nvSpPr>
-          <p:cNvPr id="31" name="TextBox 30">
-            <a:extLst>
-              <a:ext uri="{FF2B5EF4-FFF2-40B4-BE49-F238E27FC236}">
-                <a16:creationId xmlns:a16="http://schemas.microsoft.com/office/drawing/2014/main" id="{2E389938-BC74-9774-0C0E-5E96467866AF}"/>
-              </a:ext>
-            </a:extLst>
-          </p:cNvPr>
-          <p:cNvSpPr txBox="1"/>
-          <p:nvPr/>
-        </p:nvSpPr>
-        <p:spPr>
-          <a:xfrm rot="5400000">
-            <a:off x="5515841" y="3970089"/>
-            <a:ext cx="276999" cy="323808"/>
-          </a:xfrm>
-          <a:prstGeom prst="rect">
-            <a:avLst/>
-          </a:prstGeom>
-          <a:noFill/>
-        </p:spPr>
-        <p:txBody>
-          <a:bodyPr vert="vert270" wrap="none" lIns="0" tIns="0" rIns="91440" bIns="0" rtlCol="0">
-            <a:spAutoFit/>
-          </a:bodyPr>
-          <a:lstStyle/>
-          <a:p>
-            <a:pPr algn="ctr"/>
-            <a:r>
-              <a:rPr lang="en-US" sz="1200" dirty="0">
-                <a:solidFill>
-                  <a:schemeClr val="accent2">
-                    <a:lumMod val="60000"/>
-                    <a:lumOff val="40000"/>
-                  </a:schemeClr>
-                </a:solidFill>
-              </a:rPr>
-              <a:t>back</a:t>
+            <a:r>
+              <a:rPr lang="en-US" sz="1100" dirty="0"/>
+              <a:t>Maintains aim and shoot all fuel. Can be moving…</a:t>
             </a:r>
           </a:p>
         </p:txBody>

</xml_diff>

<commit_message>
Fixes after running on robot More work on driver controller commands
</commit_message>
<xml_diff>
--- a/docs/Controller Mappings & Paths.pptx
+++ b/docs/Controller Mappings & Paths.pptx
@@ -4,6 +4,9 @@
   <p:sldMasterIdLst>
     <p:sldMasterId id="2147483648" r:id="rId1"/>
   </p:sldMasterIdLst>
+  <p:notesMasterIdLst>
+    <p:notesMasterId r:id="rId11"/>
+  </p:notesMasterIdLst>
   <p:sldIdLst>
     <p:sldId id="257" r:id="rId2"/>
     <p:sldId id="256" r:id="rId3"/>
@@ -260,6 +263,439 @@
 </inkml:ink>
 </file>
 
+<file path=ppt/notesMasters/notesMaster1.xml><?xml version="1.0" encoding="utf-8"?>
+<p:notesMaster xmlns:a="http://schemas.openxmlformats.org/drawingml/2006/main" xmlns:r="http://schemas.openxmlformats.org/officeDocument/2006/relationships" xmlns:p="http://schemas.openxmlformats.org/presentationml/2006/main">
+  <p:cSld>
+    <p:bg>
+      <p:bgRef idx="1001">
+        <a:schemeClr val="bg1"/>
+      </p:bgRef>
+    </p:bg>
+    <p:spTree>
+      <p:nvGrpSpPr>
+        <p:cNvPr id="1" name=""/>
+        <p:cNvGrpSpPr/>
+        <p:nvPr/>
+      </p:nvGrpSpPr>
+      <p:grpSpPr>
+        <a:xfrm>
+          <a:off x="0" y="0"/>
+          <a:ext cx="0" cy="0"/>
+          <a:chOff x="0" y="0"/>
+          <a:chExt cx="0" cy="0"/>
+        </a:xfrm>
+      </p:grpSpPr>
+      <p:sp>
+        <p:nvSpPr>
+          <p:cNvPr id="2" name="Header Placeholder 1"/>
+          <p:cNvSpPr>
+            <a:spLocks noGrp="1"/>
+          </p:cNvSpPr>
+          <p:nvPr>
+            <p:ph type="hdr" sz="quarter"/>
+          </p:nvPr>
+        </p:nvSpPr>
+        <p:spPr>
+          <a:xfrm>
+            <a:off x="0" y="0"/>
+            <a:ext cx="2971800" cy="458788"/>
+          </a:xfrm>
+          <a:prstGeom prst="rect">
+            <a:avLst/>
+          </a:prstGeom>
+        </p:spPr>
+        <p:txBody>
+          <a:bodyPr vert="horz" lIns="91440" tIns="45720" rIns="91440" bIns="45720" rtlCol="0"/>
+          <a:lstStyle>
+            <a:lvl1pPr algn="l">
+              <a:defRPr sz="1200"/>
+            </a:lvl1pPr>
+          </a:lstStyle>
+          <a:p>
+            <a:endParaRPr lang="en-US"/>
+          </a:p>
+        </p:txBody>
+      </p:sp>
+      <p:sp>
+        <p:nvSpPr>
+          <p:cNvPr id="3" name="Date Placeholder 2"/>
+          <p:cNvSpPr>
+            <a:spLocks noGrp="1"/>
+          </p:cNvSpPr>
+          <p:nvPr>
+            <p:ph type="dt" idx="1"/>
+          </p:nvPr>
+        </p:nvSpPr>
+        <p:spPr>
+          <a:xfrm>
+            <a:off x="3884613" y="0"/>
+            <a:ext cx="2971800" cy="458788"/>
+          </a:xfrm>
+          <a:prstGeom prst="rect">
+            <a:avLst/>
+          </a:prstGeom>
+        </p:spPr>
+        <p:txBody>
+          <a:bodyPr vert="horz" lIns="91440" tIns="45720" rIns="91440" bIns="45720" rtlCol="0"/>
+          <a:lstStyle>
+            <a:lvl1pPr algn="r">
+              <a:defRPr sz="1200"/>
+            </a:lvl1pPr>
+          </a:lstStyle>
+          <a:p>
+            <a:fld id="{AE04D560-2BC0-4E9A-8DFC-A40971B69CDD}" type="datetimeFigureOut">
+              <a:rPr lang="en-US" smtClean="0"/>
+              <a:t>3/30/2026</a:t>
+            </a:fld>
+            <a:endParaRPr lang="en-US"/>
+          </a:p>
+        </p:txBody>
+      </p:sp>
+      <p:sp>
+        <p:nvSpPr>
+          <p:cNvPr id="4" name="Slide Image Placeholder 3"/>
+          <p:cNvSpPr>
+            <a:spLocks noGrp="1" noRot="1" noChangeAspect="1"/>
+          </p:cNvSpPr>
+          <p:nvPr>
+            <p:ph type="sldImg" idx="2"/>
+          </p:nvPr>
+        </p:nvSpPr>
+        <p:spPr>
+          <a:xfrm>
+            <a:off x="685800" y="1143000"/>
+            <a:ext cx="5486400" cy="3086100"/>
+          </a:xfrm>
+          <a:prstGeom prst="rect">
+            <a:avLst/>
+          </a:prstGeom>
+          <a:noFill/>
+          <a:ln w="12700">
+            <a:solidFill>
+              <a:prstClr val="black"/>
+            </a:solidFill>
+          </a:ln>
+        </p:spPr>
+        <p:txBody>
+          <a:bodyPr vert="horz" lIns="91440" tIns="45720" rIns="91440" bIns="45720" rtlCol="0" anchor="ctr"/>
+          <a:lstStyle/>
+          <a:p>
+            <a:endParaRPr lang="en-US"/>
+          </a:p>
+        </p:txBody>
+      </p:sp>
+      <p:sp>
+        <p:nvSpPr>
+          <p:cNvPr id="5" name="Notes Placeholder 4"/>
+          <p:cNvSpPr>
+            <a:spLocks noGrp="1"/>
+          </p:cNvSpPr>
+          <p:nvPr>
+            <p:ph type="body" sz="quarter" idx="3"/>
+          </p:nvPr>
+        </p:nvSpPr>
+        <p:spPr>
+          <a:xfrm>
+            <a:off x="685800" y="4400550"/>
+            <a:ext cx="5486400" cy="3600450"/>
+          </a:xfrm>
+          <a:prstGeom prst="rect">
+            <a:avLst/>
+          </a:prstGeom>
+        </p:spPr>
+        <p:txBody>
+          <a:bodyPr vert="horz" lIns="91440" tIns="45720" rIns="91440" bIns="45720" rtlCol="0"/>
+          <a:lstStyle/>
+          <a:p>
+            <a:pPr lvl="0"/>
+            <a:r>
+              <a:rPr lang="en-US"/>
+              <a:t>Click to edit Master text styles</a:t>
+            </a:r>
+          </a:p>
+          <a:p>
+            <a:pPr lvl="1"/>
+            <a:r>
+              <a:rPr lang="en-US"/>
+              <a:t>Second level</a:t>
+            </a:r>
+          </a:p>
+          <a:p>
+            <a:pPr lvl="2"/>
+            <a:r>
+              <a:rPr lang="en-US"/>
+              <a:t>Third level</a:t>
+            </a:r>
+          </a:p>
+          <a:p>
+            <a:pPr lvl="3"/>
+            <a:r>
+              <a:rPr lang="en-US"/>
+              <a:t>Fourth level</a:t>
+            </a:r>
+          </a:p>
+          <a:p>
+            <a:pPr lvl="4"/>
+            <a:r>
+              <a:rPr lang="en-US"/>
+              <a:t>Fifth level</a:t>
+            </a:r>
+          </a:p>
+        </p:txBody>
+      </p:sp>
+      <p:sp>
+        <p:nvSpPr>
+          <p:cNvPr id="6" name="Footer Placeholder 5"/>
+          <p:cNvSpPr>
+            <a:spLocks noGrp="1"/>
+          </p:cNvSpPr>
+          <p:nvPr>
+            <p:ph type="ftr" sz="quarter" idx="4"/>
+          </p:nvPr>
+        </p:nvSpPr>
+        <p:spPr>
+          <a:xfrm>
+            <a:off x="0" y="8685213"/>
+            <a:ext cx="2971800" cy="458787"/>
+          </a:xfrm>
+          <a:prstGeom prst="rect">
+            <a:avLst/>
+          </a:prstGeom>
+        </p:spPr>
+        <p:txBody>
+          <a:bodyPr vert="horz" lIns="91440" tIns="45720" rIns="91440" bIns="45720" rtlCol="0" anchor="b"/>
+          <a:lstStyle>
+            <a:lvl1pPr algn="l">
+              <a:defRPr sz="1200"/>
+            </a:lvl1pPr>
+          </a:lstStyle>
+          <a:p>
+            <a:endParaRPr lang="en-US"/>
+          </a:p>
+        </p:txBody>
+      </p:sp>
+      <p:sp>
+        <p:nvSpPr>
+          <p:cNvPr id="7" name="Slide Number Placeholder 6"/>
+          <p:cNvSpPr>
+            <a:spLocks noGrp="1"/>
+          </p:cNvSpPr>
+          <p:nvPr>
+            <p:ph type="sldNum" sz="quarter" idx="5"/>
+          </p:nvPr>
+        </p:nvSpPr>
+        <p:spPr>
+          <a:xfrm>
+            <a:off x="3884613" y="8685213"/>
+            <a:ext cx="2971800" cy="458787"/>
+          </a:xfrm>
+          <a:prstGeom prst="rect">
+            <a:avLst/>
+          </a:prstGeom>
+        </p:spPr>
+        <p:txBody>
+          <a:bodyPr vert="horz" lIns="91440" tIns="45720" rIns="91440" bIns="45720" rtlCol="0" anchor="b"/>
+          <a:lstStyle>
+            <a:lvl1pPr algn="r">
+              <a:defRPr sz="1200"/>
+            </a:lvl1pPr>
+          </a:lstStyle>
+          <a:p>
+            <a:fld id="{37E61306-F19D-474D-AFBE-997314930689}" type="slidenum">
+              <a:rPr lang="en-US" smtClean="0"/>
+              <a:t>‹#›</a:t>
+            </a:fld>
+            <a:endParaRPr lang="en-US"/>
+          </a:p>
+        </p:txBody>
+      </p:sp>
+    </p:spTree>
+    <p:extLst>
+      <p:ext uri="{BB962C8B-B14F-4D97-AF65-F5344CB8AC3E}">
+        <p14:creationId xmlns:p14="http://schemas.microsoft.com/office/powerpoint/2010/main" val="2258765506"/>
+      </p:ext>
+    </p:extLst>
+  </p:cSld>
+  <p:clrMap bg1="lt1" tx1="dk1" bg2="lt2" tx2="dk2" accent1="accent1" accent2="accent2" accent3="accent3" accent4="accent4" accent5="accent5" accent6="accent6" hlink="hlink" folHlink="folHlink"/>
+  <p:notesStyle>
+    <a:lvl1pPr marL="0" algn="l" defTabSz="914400" rtl="0" eaLnBrk="1" latinLnBrk="0" hangingPunct="1">
+      <a:defRPr sz="1200" kern="1200">
+        <a:solidFill>
+          <a:schemeClr val="tx1"/>
+        </a:solidFill>
+        <a:latin typeface="+mn-lt"/>
+        <a:ea typeface="+mn-ea"/>
+        <a:cs typeface="+mn-cs"/>
+      </a:defRPr>
+    </a:lvl1pPr>
+    <a:lvl2pPr marL="457200" algn="l" defTabSz="914400" rtl="0" eaLnBrk="1" latinLnBrk="0" hangingPunct="1">
+      <a:defRPr sz="1200" kern="1200">
+        <a:solidFill>
+          <a:schemeClr val="tx1"/>
+        </a:solidFill>
+        <a:latin typeface="+mn-lt"/>
+        <a:ea typeface="+mn-ea"/>
+        <a:cs typeface="+mn-cs"/>
+      </a:defRPr>
+    </a:lvl2pPr>
+    <a:lvl3pPr marL="914400" algn="l" defTabSz="914400" rtl="0" eaLnBrk="1" latinLnBrk="0" hangingPunct="1">
+      <a:defRPr sz="1200" kern="1200">
+        <a:solidFill>
+          <a:schemeClr val="tx1"/>
+        </a:solidFill>
+        <a:latin typeface="+mn-lt"/>
+        <a:ea typeface="+mn-ea"/>
+        <a:cs typeface="+mn-cs"/>
+      </a:defRPr>
+    </a:lvl3pPr>
+    <a:lvl4pPr marL="1371600" algn="l" defTabSz="914400" rtl="0" eaLnBrk="1" latinLnBrk="0" hangingPunct="1">
+      <a:defRPr sz="1200" kern="1200">
+        <a:solidFill>
+          <a:schemeClr val="tx1"/>
+        </a:solidFill>
+        <a:latin typeface="+mn-lt"/>
+        <a:ea typeface="+mn-ea"/>
+        <a:cs typeface="+mn-cs"/>
+      </a:defRPr>
+    </a:lvl4pPr>
+    <a:lvl5pPr marL="1828800" algn="l" defTabSz="914400" rtl="0" eaLnBrk="1" latinLnBrk="0" hangingPunct="1">
+      <a:defRPr sz="1200" kern="1200">
+        <a:solidFill>
+          <a:schemeClr val="tx1"/>
+        </a:solidFill>
+        <a:latin typeface="+mn-lt"/>
+        <a:ea typeface="+mn-ea"/>
+        <a:cs typeface="+mn-cs"/>
+      </a:defRPr>
+    </a:lvl5pPr>
+    <a:lvl6pPr marL="2286000" algn="l" defTabSz="914400" rtl="0" eaLnBrk="1" latinLnBrk="0" hangingPunct="1">
+      <a:defRPr sz="1200" kern="1200">
+        <a:solidFill>
+          <a:schemeClr val="tx1"/>
+        </a:solidFill>
+        <a:latin typeface="+mn-lt"/>
+        <a:ea typeface="+mn-ea"/>
+        <a:cs typeface="+mn-cs"/>
+      </a:defRPr>
+    </a:lvl6pPr>
+    <a:lvl7pPr marL="2743200" algn="l" defTabSz="914400" rtl="0" eaLnBrk="1" latinLnBrk="0" hangingPunct="1">
+      <a:defRPr sz="1200" kern="1200">
+        <a:solidFill>
+          <a:schemeClr val="tx1"/>
+        </a:solidFill>
+        <a:latin typeface="+mn-lt"/>
+        <a:ea typeface="+mn-ea"/>
+        <a:cs typeface="+mn-cs"/>
+      </a:defRPr>
+    </a:lvl7pPr>
+    <a:lvl8pPr marL="3200400" algn="l" defTabSz="914400" rtl="0" eaLnBrk="1" latinLnBrk="0" hangingPunct="1">
+      <a:defRPr sz="1200" kern="1200">
+        <a:solidFill>
+          <a:schemeClr val="tx1"/>
+        </a:solidFill>
+        <a:latin typeface="+mn-lt"/>
+        <a:ea typeface="+mn-ea"/>
+        <a:cs typeface="+mn-cs"/>
+      </a:defRPr>
+    </a:lvl8pPr>
+    <a:lvl9pPr marL="3657600" algn="l" defTabSz="914400" rtl="0" eaLnBrk="1" latinLnBrk="0" hangingPunct="1">
+      <a:defRPr sz="1200" kern="1200">
+        <a:solidFill>
+          <a:schemeClr val="tx1"/>
+        </a:solidFill>
+        <a:latin typeface="+mn-lt"/>
+        <a:ea typeface="+mn-ea"/>
+        <a:cs typeface="+mn-cs"/>
+      </a:defRPr>
+    </a:lvl9pPr>
+  </p:notesStyle>
+</p:notesMaster>
+</file>
+
+<file path=ppt/notesSlides/notesSlide1.xml><?xml version="1.0" encoding="utf-8"?>
+<p:notes xmlns:a="http://schemas.openxmlformats.org/drawingml/2006/main" xmlns:r="http://schemas.openxmlformats.org/officeDocument/2006/relationships" xmlns:p="http://schemas.openxmlformats.org/presentationml/2006/main">
+  <p:cSld>
+    <p:spTree>
+      <p:nvGrpSpPr>
+        <p:cNvPr id="1" name=""/>
+        <p:cNvGrpSpPr/>
+        <p:nvPr/>
+      </p:nvGrpSpPr>
+      <p:grpSpPr>
+        <a:xfrm>
+          <a:off x="0" y="0"/>
+          <a:ext cx="0" cy="0"/>
+          <a:chOff x="0" y="0"/>
+          <a:chExt cx="0" cy="0"/>
+        </a:xfrm>
+      </p:grpSpPr>
+      <p:sp>
+        <p:nvSpPr>
+          <p:cNvPr id="2" name="Slide Image Placeholder 1"/>
+          <p:cNvSpPr>
+            <a:spLocks noGrp="1" noRot="1" noChangeAspect="1"/>
+          </p:cNvSpPr>
+          <p:nvPr>
+            <p:ph type="sldImg"/>
+          </p:nvPr>
+        </p:nvSpPr>
+        <p:spPr/>
+      </p:sp>
+      <p:sp>
+        <p:nvSpPr>
+          <p:cNvPr id="3" name="Notes Placeholder 2"/>
+          <p:cNvSpPr>
+            <a:spLocks noGrp="1"/>
+          </p:cNvSpPr>
+          <p:nvPr>
+            <p:ph type="body" idx="1"/>
+          </p:nvPr>
+        </p:nvSpPr>
+        <p:spPr/>
+        <p:txBody>
+          <a:bodyPr/>
+          <a:lstStyle/>
+          <a:p>
+            <a:endParaRPr lang="en-US" dirty="0"/>
+          </a:p>
+        </p:txBody>
+      </p:sp>
+      <p:sp>
+        <p:nvSpPr>
+          <p:cNvPr id="4" name="Slide Number Placeholder 3"/>
+          <p:cNvSpPr>
+            <a:spLocks noGrp="1"/>
+          </p:cNvSpPr>
+          <p:nvPr>
+            <p:ph type="sldNum" sz="quarter" idx="5"/>
+          </p:nvPr>
+        </p:nvSpPr>
+        <p:spPr/>
+        <p:txBody>
+          <a:bodyPr/>
+          <a:lstStyle/>
+          <a:p>
+            <a:fld id="{37E61306-F19D-474D-AFBE-997314930689}" type="slidenum">
+              <a:rPr lang="en-US" smtClean="0"/>
+              <a:t>1</a:t>
+            </a:fld>
+            <a:endParaRPr lang="en-US"/>
+          </a:p>
+        </p:txBody>
+      </p:sp>
+    </p:spTree>
+    <p:extLst>
+      <p:ext uri="{BB962C8B-B14F-4D97-AF65-F5344CB8AC3E}">
+        <p14:creationId xmlns:p14="http://schemas.microsoft.com/office/powerpoint/2010/main" val="4190948989"/>
+      </p:ext>
+    </p:extLst>
+  </p:cSld>
+  <p:clrMapOvr>
+    <a:masterClrMapping/>
+  </p:clrMapOvr>
+</p:notes>
+</file>
+
 <file path=ppt/slideLayouts/slideLayout1.xml><?xml version="1.0" encoding="utf-8"?>
 <p:sldLayout xmlns:a="http://schemas.openxmlformats.org/drawingml/2006/main" xmlns:r="http://schemas.openxmlformats.org/officeDocument/2006/relationships" xmlns:p="http://schemas.openxmlformats.org/presentationml/2006/main" type="title" preserve="1">
   <p:cSld name="Title Slide">
@@ -407,7 +843,7 @@
           <a:p>
             <a:fld id="{B6000E93-69C7-4C90-931E-A5484B820028}" type="datetimeFigureOut">
               <a:rPr lang="en-US" smtClean="0"/>
-              <a:t>3/29/2026</a:t>
+              <a:t>3/30/2026</a:t>
             </a:fld>
             <a:endParaRPr lang="en-US"/>
           </a:p>
@@ -605,7 +1041,7 @@
           <a:p>
             <a:fld id="{B6000E93-69C7-4C90-931E-A5484B820028}" type="datetimeFigureOut">
               <a:rPr lang="en-US" smtClean="0"/>
-              <a:t>3/29/2026</a:t>
+              <a:t>3/30/2026</a:t>
             </a:fld>
             <a:endParaRPr lang="en-US"/>
           </a:p>
@@ -813,7 +1249,7 @@
           <a:p>
             <a:fld id="{B6000E93-69C7-4C90-931E-A5484B820028}" type="datetimeFigureOut">
               <a:rPr lang="en-US" smtClean="0"/>
-              <a:t>3/29/2026</a:t>
+              <a:t>3/30/2026</a:t>
             </a:fld>
             <a:endParaRPr lang="en-US"/>
           </a:p>
@@ -1011,7 +1447,7 @@
           <a:p>
             <a:fld id="{B6000E93-69C7-4C90-931E-A5484B820028}" type="datetimeFigureOut">
               <a:rPr lang="en-US" smtClean="0"/>
-              <a:t>3/29/2026</a:t>
+              <a:t>3/30/2026</a:t>
             </a:fld>
             <a:endParaRPr lang="en-US"/>
           </a:p>
@@ -1286,7 +1722,7 @@
           <a:p>
             <a:fld id="{B6000E93-69C7-4C90-931E-A5484B820028}" type="datetimeFigureOut">
               <a:rPr lang="en-US" smtClean="0"/>
-              <a:t>3/29/2026</a:t>
+              <a:t>3/30/2026</a:t>
             </a:fld>
             <a:endParaRPr lang="en-US"/>
           </a:p>
@@ -1551,7 +1987,7 @@
           <a:p>
             <a:fld id="{B6000E93-69C7-4C90-931E-A5484B820028}" type="datetimeFigureOut">
               <a:rPr lang="en-US" smtClean="0"/>
-              <a:t>3/29/2026</a:t>
+              <a:t>3/30/2026</a:t>
             </a:fld>
             <a:endParaRPr lang="en-US"/>
           </a:p>
@@ -1963,7 +2399,7 @@
           <a:p>
             <a:fld id="{B6000E93-69C7-4C90-931E-A5484B820028}" type="datetimeFigureOut">
               <a:rPr lang="en-US" smtClean="0"/>
-              <a:t>3/29/2026</a:t>
+              <a:t>3/30/2026</a:t>
             </a:fld>
             <a:endParaRPr lang="en-US"/>
           </a:p>
@@ -2104,7 +2540,7 @@
           <a:p>
             <a:fld id="{B6000E93-69C7-4C90-931E-A5484B820028}" type="datetimeFigureOut">
               <a:rPr lang="en-US" smtClean="0"/>
-              <a:t>3/29/2026</a:t>
+              <a:t>3/30/2026</a:t>
             </a:fld>
             <a:endParaRPr lang="en-US"/>
           </a:p>
@@ -2217,7 +2653,7 @@
           <a:p>
             <a:fld id="{B6000E93-69C7-4C90-931E-A5484B820028}" type="datetimeFigureOut">
               <a:rPr lang="en-US" smtClean="0"/>
-              <a:t>3/29/2026</a:t>
+              <a:t>3/30/2026</a:t>
             </a:fld>
             <a:endParaRPr lang="en-US"/>
           </a:p>
@@ -2528,7 +2964,7 @@
           <a:p>
             <a:fld id="{B6000E93-69C7-4C90-931E-A5484B820028}" type="datetimeFigureOut">
               <a:rPr lang="en-US" smtClean="0"/>
-              <a:t>3/29/2026</a:t>
+              <a:t>3/30/2026</a:t>
             </a:fld>
             <a:endParaRPr lang="en-US"/>
           </a:p>
@@ -2816,7 +3252,7 @@
           <a:p>
             <a:fld id="{B6000E93-69C7-4C90-931E-A5484B820028}" type="datetimeFigureOut">
               <a:rPr lang="en-US" smtClean="0"/>
-              <a:t>3/29/2026</a:t>
+              <a:t>3/30/2026</a:t>
             </a:fld>
             <a:endParaRPr lang="en-US"/>
           </a:p>
@@ -3057,7 +3493,7 @@
           <a:p>
             <a:fld id="{B6000E93-69C7-4C90-931E-A5484B820028}" type="datetimeFigureOut">
               <a:rPr lang="en-US" smtClean="0"/>
-              <a:t>3/29/2026</a:t>
+              <a:t>3/30/2026</a:t>
             </a:fld>
             <a:endParaRPr lang="en-US"/>
           </a:p>
@@ -3476,6 +3912,86 @@
       </p:grpSpPr>
       <p:sp>
         <p:nvSpPr>
+          <p:cNvPr id="9" name="Rectangle 8">
+            <a:extLst>
+              <a:ext uri="{FF2B5EF4-FFF2-40B4-BE49-F238E27FC236}">
+                <a16:creationId xmlns:a16="http://schemas.microsoft.com/office/drawing/2014/main" id="{DC93AF2D-73A4-E0FD-7B3D-B2A7BC89594C}"/>
+              </a:ext>
+            </a:extLst>
+          </p:cNvPr>
+          <p:cNvSpPr/>
+          <p:nvPr/>
+        </p:nvSpPr>
+        <p:spPr>
+          <a:xfrm>
+            <a:off x="5771507" y="5561137"/>
+            <a:ext cx="1595535" cy="553140"/>
+          </a:xfrm>
+          <a:prstGeom prst="rect">
+            <a:avLst/>
+          </a:prstGeom>
+          <a:solidFill>
+            <a:schemeClr val="accent6">
+              <a:lumMod val="20000"/>
+              <a:lumOff val="80000"/>
+            </a:schemeClr>
+          </a:solidFill>
+          <a:ln>
+            <a:solidFill>
+              <a:schemeClr val="accent2">
+                <a:lumMod val="20000"/>
+                <a:lumOff val="80000"/>
+              </a:schemeClr>
+            </a:solidFill>
+          </a:ln>
+        </p:spPr>
+        <p:style>
+          <a:lnRef idx="2">
+            <a:schemeClr val="accent1">
+              <a:shade val="15000"/>
+            </a:schemeClr>
+          </a:lnRef>
+          <a:fillRef idx="1">
+            <a:schemeClr val="accent1"/>
+          </a:fillRef>
+          <a:effectRef idx="0">
+            <a:schemeClr val="accent1"/>
+          </a:effectRef>
+          <a:fontRef idx="minor">
+            <a:schemeClr val="lt1"/>
+          </a:fontRef>
+        </p:style>
+        <p:txBody>
+          <a:bodyPr rtlCol="0" anchor="ctr"/>
+          <a:lstStyle/>
+          <a:p>
+            <a:pPr algn="ctr"/>
+            <a:r>
+              <a:rPr lang="en-US" sz="1600" dirty="0">
+                <a:solidFill>
+                  <a:schemeClr val="tx2"/>
+                </a:solidFill>
+              </a:rPr>
+              <a:t>Climber</a:t>
+            </a:r>
+            <a:r>
+              <a:rPr lang="en-US" sz="1400" dirty="0">
+                <a:solidFill>
+                  <a:schemeClr val="tx2"/>
+                </a:solidFill>
+              </a:rPr>
+              <a:t>(Tweak Down)</a:t>
+            </a:r>
+            <a:endParaRPr lang="en-US" sz="1600" dirty="0">
+              <a:solidFill>
+                <a:schemeClr val="tx2"/>
+              </a:solidFill>
+            </a:endParaRPr>
+          </a:p>
+        </p:txBody>
+      </p:sp>
+      <p:sp>
+        <p:nvSpPr>
           <p:cNvPr id="2" name="TextBox 1">
             <a:extLst>
               <a:ext uri="{FF2B5EF4-FFF2-40B4-BE49-F238E27FC236}">
@@ -3523,7 +4039,7 @@
         </p:nvSpPr>
         <p:spPr>
           <a:xfrm>
-            <a:off x="9855703" y="1286788"/>
+            <a:off x="8814310" y="5910286"/>
             <a:ext cx="1595535" cy="317241"/>
           </a:xfrm>
           <a:prstGeom prst="rect">
@@ -3657,7 +4173,7 @@
         </p:nvSpPr>
         <p:spPr>
           <a:xfrm>
-            <a:off x="9139825" y="2632710"/>
+            <a:off x="9074697" y="1717161"/>
             <a:ext cx="2078544" cy="317241"/>
           </a:xfrm>
           <a:prstGeom prst="rect">
@@ -3941,7 +4457,7 @@
         </p:nvSpPr>
         <p:spPr>
           <a:xfrm>
-            <a:off x="9855703" y="914454"/>
+            <a:off x="9850900" y="742561"/>
             <a:ext cx="1595535" cy="317241"/>
           </a:xfrm>
           <a:prstGeom prst="rect">
@@ -4075,7 +4591,7 @@
         </p:nvSpPr>
         <p:spPr>
           <a:xfrm>
-            <a:off x="10352397" y="1783041"/>
+            <a:off x="10355474" y="5480548"/>
             <a:ext cx="1595535" cy="317241"/>
           </a:xfrm>
           <a:prstGeom prst="rect">
@@ -4142,7 +4658,7 @@
         </p:nvSpPr>
         <p:spPr>
           <a:xfrm>
-            <a:off x="9855703" y="444813"/>
+            <a:off x="9011561" y="3286873"/>
             <a:ext cx="1595535" cy="317241"/>
           </a:xfrm>
           <a:prstGeom prst="rect">
@@ -4185,12 +4701,12 @@
           <a:p>
             <a:pPr algn="ctr"/>
             <a:r>
-              <a:rPr lang="en-US" dirty="0">
+              <a:rPr lang="en-US" sz="1600" dirty="0">
                 <a:solidFill>
                   <a:schemeClr val="tx2"/>
                 </a:solidFill>
               </a:rPr>
-              <a:t>Reset Position</a:t>
+              <a:t>Reset Telemetry</a:t>
             </a:r>
           </a:p>
         </p:txBody>
@@ -4276,135 +4792,7 @@
         </p:nvSpPr>
         <p:spPr>
           <a:xfrm>
-            <a:off x="9756775" y="6030259"/>
-            <a:ext cx="1595535" cy="317241"/>
-          </a:xfrm>
-          <a:prstGeom prst="rect">
-            <a:avLst/>
-          </a:prstGeom>
-          <a:solidFill>
-            <a:schemeClr val="accent6">
-              <a:lumMod val="20000"/>
-              <a:lumOff val="80000"/>
-            </a:schemeClr>
-          </a:solidFill>
-          <a:ln>
-            <a:solidFill>
-              <a:schemeClr val="accent2">
-                <a:lumMod val="20000"/>
-                <a:lumOff val="80000"/>
-              </a:schemeClr>
-            </a:solidFill>
-          </a:ln>
-        </p:spPr>
-        <p:style>
-          <a:lnRef idx="2">
-            <a:schemeClr val="accent1">
-              <a:shade val="15000"/>
-            </a:schemeClr>
-          </a:lnRef>
-          <a:fillRef idx="1">
-            <a:schemeClr val="accent1"/>
-          </a:fillRef>
-          <a:effectRef idx="0">
-            <a:schemeClr val="accent1"/>
-          </a:effectRef>
-          <a:fontRef idx="minor">
-            <a:schemeClr val="lt1"/>
-          </a:fontRef>
-        </p:style>
-        <p:txBody>
-          <a:bodyPr rtlCol="0" anchor="ctr"/>
-          <a:lstStyle/>
-          <a:p>
-            <a:pPr algn="ctr"/>
-            <a:endParaRPr lang="en-US" dirty="0">
-              <a:solidFill>
-                <a:schemeClr val="tx2"/>
-              </a:solidFill>
-            </a:endParaRPr>
-          </a:p>
-        </p:txBody>
-      </p:sp>
-      <p:sp>
-        <p:nvSpPr>
-          <p:cNvPr id="28" name="Rectangle 27">
-            <a:extLst>
-              <a:ext uri="{FF2B5EF4-FFF2-40B4-BE49-F238E27FC236}">
-                <a16:creationId xmlns:a16="http://schemas.microsoft.com/office/drawing/2014/main" id="{4995BC81-9903-6C07-5912-D3957C575183}"/>
-              </a:ext>
-            </a:extLst>
-          </p:cNvPr>
-          <p:cNvSpPr/>
-          <p:nvPr/>
-        </p:nvSpPr>
-        <p:spPr>
-          <a:xfrm>
-            <a:off x="9909175" y="6182659"/>
-            <a:ext cx="1595535" cy="317241"/>
-          </a:xfrm>
-          <a:prstGeom prst="rect">
-            <a:avLst/>
-          </a:prstGeom>
-          <a:solidFill>
-            <a:schemeClr val="accent6">
-              <a:lumMod val="20000"/>
-              <a:lumOff val="80000"/>
-            </a:schemeClr>
-          </a:solidFill>
-          <a:ln>
-            <a:solidFill>
-              <a:schemeClr val="accent2">
-                <a:lumMod val="20000"/>
-                <a:lumOff val="80000"/>
-              </a:schemeClr>
-            </a:solidFill>
-          </a:ln>
-        </p:spPr>
-        <p:style>
-          <a:lnRef idx="2">
-            <a:schemeClr val="accent1">
-              <a:shade val="15000"/>
-            </a:schemeClr>
-          </a:lnRef>
-          <a:fillRef idx="1">
-            <a:schemeClr val="accent1"/>
-          </a:fillRef>
-          <a:effectRef idx="0">
-            <a:schemeClr val="accent1"/>
-          </a:effectRef>
-          <a:fontRef idx="minor">
-            <a:schemeClr val="lt1"/>
-          </a:fontRef>
-        </p:style>
-        <p:txBody>
-          <a:bodyPr rtlCol="0" anchor="ctr"/>
-          <a:lstStyle/>
-          <a:p>
-            <a:pPr algn="ctr"/>
-            <a:endParaRPr lang="en-US" dirty="0">
-              <a:solidFill>
-                <a:schemeClr val="tx2"/>
-              </a:solidFill>
-            </a:endParaRPr>
-          </a:p>
-        </p:txBody>
-      </p:sp>
-      <p:sp>
-        <p:nvSpPr>
-          <p:cNvPr id="29" name="Rectangle 28">
-            <a:extLst>
-              <a:ext uri="{FF2B5EF4-FFF2-40B4-BE49-F238E27FC236}">
-                <a16:creationId xmlns:a16="http://schemas.microsoft.com/office/drawing/2014/main" id="{3D7A8DB9-C713-AA15-2812-CCC07794A7F1}"/>
-              </a:ext>
-            </a:extLst>
-          </p:cNvPr>
-          <p:cNvSpPr/>
-          <p:nvPr/>
-        </p:nvSpPr>
-        <p:spPr>
-          <a:xfrm>
-            <a:off x="10061575" y="6335059"/>
+            <a:off x="8071505" y="6291489"/>
             <a:ext cx="1595535" cy="317241"/>
           </a:xfrm>
           <a:prstGeom prst="rect">
@@ -4556,7 +4944,7 @@
             <p:nvPr/>
           </p:nvPicPr>
           <p:blipFill>
-            <a:blip r:embed="rId2">
+            <a:blip r:embed="rId3">
               <a:extLst>
                 <a:ext uri="{28A0092B-C50C-407E-A947-70E740481C1C}">
                   <a14:useLocalDpi xmlns:a14="http://schemas.microsoft.com/office/drawing/2010/main" val="0"/>
@@ -4577,46 +4965,6 @@
             </a:prstGeom>
           </p:spPr>
         </p:pic>
-        <p:sp>
-          <p:nvSpPr>
-            <p:cNvPr id="31" name="TextBox 30">
-              <a:extLst>
-                <a:ext uri="{FF2B5EF4-FFF2-40B4-BE49-F238E27FC236}">
-                  <a16:creationId xmlns:a16="http://schemas.microsoft.com/office/drawing/2014/main" id="{1651F236-D3FE-6452-481B-09721FBE1382}"/>
-                </a:ext>
-              </a:extLst>
-            </p:cNvPr>
-            <p:cNvSpPr txBox="1"/>
-            <p:nvPr/>
-          </p:nvSpPr>
-          <p:spPr>
-            <a:xfrm>
-              <a:off x="8085485" y="3460782"/>
-              <a:ext cx="338554" cy="580800"/>
-            </a:xfrm>
-            <a:prstGeom prst="rect">
-              <a:avLst/>
-            </a:prstGeom>
-            <a:noFill/>
-          </p:spPr>
-          <p:txBody>
-            <a:bodyPr vert="vert270" wrap="none" lIns="0" tIns="0" rIns="91440" bIns="0" rtlCol="0">
-              <a:spAutoFit/>
-            </a:bodyPr>
-            <a:lstStyle/>
-            <a:p>
-              <a:pPr algn="ctr"/>
-              <a:r>
-                <a:rPr lang="en-US" sz="1600" dirty="0">
-                  <a:solidFill>
-                    <a:schemeClr val="bg2"/>
-                  </a:solidFill>
-                </a:rPr>
-                <a:t>Trigger</a:t>
-              </a:r>
-            </a:p>
-          </p:txBody>
-        </p:sp>
         <p:sp>
           <p:nvSpPr>
             <p:cNvPr id="32" name="TextBox 31">
@@ -4743,6 +5091,46 @@
             </a:p>
           </p:txBody>
         </p:sp>
+        <p:sp>
+          <p:nvSpPr>
+            <p:cNvPr id="31" name="TextBox 30">
+              <a:extLst>
+                <a:ext uri="{FF2B5EF4-FFF2-40B4-BE49-F238E27FC236}">
+                  <a16:creationId xmlns:a16="http://schemas.microsoft.com/office/drawing/2014/main" id="{1651F236-D3FE-6452-481B-09721FBE1382}"/>
+                </a:ext>
+              </a:extLst>
+            </p:cNvPr>
+            <p:cNvSpPr txBox="1"/>
+            <p:nvPr/>
+          </p:nvSpPr>
+          <p:spPr>
+            <a:xfrm>
+              <a:off x="8085485" y="3460782"/>
+              <a:ext cx="338554" cy="580800"/>
+            </a:xfrm>
+            <a:prstGeom prst="rect">
+              <a:avLst/>
+            </a:prstGeom>
+            <a:noFill/>
+          </p:spPr>
+          <p:txBody>
+            <a:bodyPr vert="vert270" wrap="none" lIns="0" tIns="0" rIns="91440" bIns="0" rtlCol="0">
+              <a:spAutoFit/>
+            </a:bodyPr>
+            <a:lstStyle/>
+            <a:p>
+              <a:pPr algn="ctr"/>
+              <a:r>
+                <a:rPr lang="en-US" sz="1600" dirty="0">
+                  <a:solidFill>
+                    <a:schemeClr val="bg2"/>
+                  </a:solidFill>
+                </a:rPr>
+                <a:t>Trigger</a:t>
+              </a:r>
+            </a:p>
+          </p:txBody>
+        </p:sp>
       </p:grpSp>
       <p:sp>
         <p:nvSpPr>
@@ -4955,7 +5343,7 @@
         </p:nvCxnSpPr>
         <p:spPr>
           <a:xfrm>
-            <a:off x="5087469" y="5037559"/>
+            <a:off x="2070037" y="4935000"/>
             <a:ext cx="400178" cy="829107"/>
           </a:xfrm>
           <a:prstGeom prst="straightConnector1">
@@ -4997,7 +5385,7 @@
         </p:nvCxnSpPr>
         <p:spPr>
           <a:xfrm>
-            <a:off x="5239869" y="5189959"/>
+            <a:off x="2222437" y="5087400"/>
             <a:ext cx="400178" cy="829107"/>
           </a:xfrm>
           <a:prstGeom prst="straightConnector1">
@@ -5039,7 +5427,7 @@
         </p:nvCxnSpPr>
         <p:spPr>
           <a:xfrm>
-            <a:off x="5392269" y="5342359"/>
+            <a:off x="2374837" y="5239800"/>
             <a:ext cx="400178" cy="829107"/>
           </a:xfrm>
           <a:prstGeom prst="straightConnector1">
@@ -5081,7 +5469,7 @@
         </p:nvCxnSpPr>
         <p:spPr>
           <a:xfrm>
-            <a:off x="5544669" y="5494759"/>
+            <a:off x="2527237" y="5392200"/>
             <a:ext cx="400178" cy="829107"/>
           </a:xfrm>
           <a:prstGeom prst="straightConnector1">
@@ -5118,13 +5506,16 @@
               </a:ext>
             </a:extLst>
           </p:cNvPr>
-          <p:cNvCxnSpPr/>
+          <p:cNvCxnSpPr>
+            <a:cxnSpLocks/>
+            <a:stCxn id="19" idx="1"/>
+          </p:cNvCxnSpPr>
           <p:nvPr/>
         </p:nvCxnSpPr>
         <p:spPr>
-          <a:xfrm>
-            <a:off x="5697069" y="5647159"/>
-            <a:ext cx="400178" cy="829107"/>
+          <a:xfrm flipH="1" flipV="1">
+            <a:off x="7364371" y="2850851"/>
+            <a:ext cx="1647190" cy="594643"/>
           </a:xfrm>
           <a:prstGeom prst="straightConnector1">
             <a:avLst/>
@@ -5160,13 +5551,16 @@
               </a:ext>
             </a:extLst>
           </p:cNvPr>
-          <p:cNvCxnSpPr/>
+          <p:cNvCxnSpPr>
+            <a:cxnSpLocks/>
+            <a:stCxn id="41" idx="0"/>
+          </p:cNvCxnSpPr>
           <p:nvPr/>
         </p:nvCxnSpPr>
         <p:spPr>
-          <a:xfrm>
-            <a:off x="5849469" y="5799559"/>
-            <a:ext cx="400178" cy="829107"/>
+          <a:xfrm flipV="1">
+            <a:off x="4545336" y="3908309"/>
+            <a:ext cx="698314" cy="1694491"/>
           </a:xfrm>
           <a:prstGeom prst="straightConnector1">
             <a:avLst/>
@@ -5202,13 +5596,16 @@
               </a:ext>
             </a:extLst>
           </p:cNvPr>
-          <p:cNvCxnSpPr/>
+          <p:cNvCxnSpPr>
+            <a:cxnSpLocks/>
+            <a:stCxn id="9" idx="0"/>
+          </p:cNvCxnSpPr>
           <p:nvPr/>
         </p:nvCxnSpPr>
         <p:spPr>
-          <a:xfrm>
-            <a:off x="6001869" y="5951959"/>
-            <a:ext cx="400178" cy="829107"/>
+          <a:xfrm flipH="1" flipV="1">
+            <a:off x="5741241" y="4006276"/>
+            <a:ext cx="828034" cy="1554861"/>
           </a:xfrm>
           <a:prstGeom prst="straightConnector1">
             <a:avLst/>
@@ -5434,9 +5831,9 @@
           <p:nvPr/>
         </p:nvCxnSpPr>
         <p:spPr>
-          <a:xfrm flipH="1" flipV="1">
-            <a:off x="8410059" y="2601682"/>
-            <a:ext cx="729766" cy="189649"/>
+          <a:xfrm flipH="1">
+            <a:off x="8410059" y="1875782"/>
+            <a:ext cx="664638" cy="725900"/>
           </a:xfrm>
           <a:prstGeom prst="straightConnector1">
             <a:avLst/>
@@ -5480,8 +5877,8 @@
         </p:nvCxnSpPr>
         <p:spPr>
           <a:xfrm flipH="1" flipV="1">
-            <a:off x="7482254" y="3562318"/>
-            <a:ext cx="1387057" cy="675492"/>
+            <a:off x="7367042" y="3538582"/>
+            <a:ext cx="1502269" cy="699228"/>
           </a:xfrm>
           <a:prstGeom prst="straightConnector1">
             <a:avLst/>
@@ -6046,6 +6443,97 @@
           </p:txBody>
         </p:sp>
       </p:grpSp>
+      <p:sp>
+        <p:nvSpPr>
+          <p:cNvPr id="41" name="Rectangle 40">
+            <a:extLst>
+              <a:ext uri="{FF2B5EF4-FFF2-40B4-BE49-F238E27FC236}">
+                <a16:creationId xmlns:a16="http://schemas.microsoft.com/office/drawing/2014/main" id="{56711DA7-35AB-95FE-610A-BD889E3BA019}"/>
+              </a:ext>
+            </a:extLst>
+          </p:cNvPr>
+          <p:cNvSpPr/>
+          <p:nvPr/>
+        </p:nvSpPr>
+        <p:spPr>
+          <a:xfrm>
+            <a:off x="3811490" y="5602800"/>
+            <a:ext cx="1467692" cy="553140"/>
+          </a:xfrm>
+          <a:prstGeom prst="rect">
+            <a:avLst/>
+          </a:prstGeom>
+          <a:solidFill>
+            <a:schemeClr val="accent6">
+              <a:lumMod val="20000"/>
+              <a:lumOff val="80000"/>
+            </a:schemeClr>
+          </a:solidFill>
+          <a:ln>
+            <a:solidFill>
+              <a:schemeClr val="accent2">
+                <a:lumMod val="20000"/>
+                <a:lumOff val="80000"/>
+              </a:schemeClr>
+            </a:solidFill>
+          </a:ln>
+        </p:spPr>
+        <p:style>
+          <a:lnRef idx="2">
+            <a:schemeClr val="accent1">
+              <a:shade val="15000"/>
+            </a:schemeClr>
+          </a:lnRef>
+          <a:fillRef idx="1">
+            <a:schemeClr val="accent1"/>
+          </a:fillRef>
+          <a:effectRef idx="0">
+            <a:schemeClr val="accent1"/>
+          </a:effectRef>
+          <a:fontRef idx="minor">
+            <a:schemeClr val="lt1"/>
+          </a:fontRef>
+        </p:style>
+        <p:txBody>
+          <a:bodyPr rtlCol="0" anchor="ctr"/>
+          <a:lstStyle/>
+          <a:p>
+            <a:pPr algn="ctr"/>
+            <a:r>
+              <a:rPr lang="en-US" sz="1600" dirty="0">
+                <a:solidFill>
+                  <a:schemeClr val="tx2"/>
+                </a:solidFill>
+              </a:rPr>
+              <a:t>Climber</a:t>
+            </a:r>
+          </a:p>
+          <a:p>
+            <a:pPr algn="ctr"/>
+            <a:r>
+              <a:rPr lang="en-US" sz="1600" dirty="0">
+                <a:solidFill>
+                  <a:schemeClr val="tx2"/>
+                </a:solidFill>
+              </a:rPr>
+              <a:t> </a:t>
+            </a:r>
+            <a:r>
+              <a:rPr lang="en-US" sz="1400" dirty="0">
+                <a:solidFill>
+                  <a:schemeClr val="tx2"/>
+                </a:solidFill>
+              </a:rPr>
+              <a:t>(Tweak Up)</a:t>
+            </a:r>
+            <a:endParaRPr lang="en-US" sz="1600" dirty="0">
+              <a:solidFill>
+                <a:schemeClr val="tx2"/>
+              </a:solidFill>
+            </a:endParaRPr>
+          </a:p>
+        </p:txBody>
+      </p:sp>
     </p:spTree>
     <p:extLst>
       <p:ext uri="{BB962C8B-B14F-4D97-AF65-F5344CB8AC3E}">
@@ -17196,4 +17684,319 @@
     </a:ext>
   </a:extLst>
 </a:theme>
+</file>
+
+<file path=ppt/theme/theme2.xml><?xml version="1.0" encoding="utf-8"?>
+<a:theme xmlns:a="http://schemas.openxmlformats.org/drawingml/2006/main" name="Office Theme">
+  <a:themeElements>
+    <a:clrScheme name="Office">
+      <a:dk1>
+        <a:sysClr val="windowText" lastClr="000000"/>
+      </a:dk1>
+      <a:lt1>
+        <a:sysClr val="window" lastClr="FFFFFF"/>
+      </a:lt1>
+      <a:dk2>
+        <a:srgbClr val="0E2841"/>
+      </a:dk2>
+      <a:lt2>
+        <a:srgbClr val="E8E8E8"/>
+      </a:lt2>
+      <a:accent1>
+        <a:srgbClr val="156082"/>
+      </a:accent1>
+      <a:accent2>
+        <a:srgbClr val="E97132"/>
+      </a:accent2>
+      <a:accent3>
+        <a:srgbClr val="196B24"/>
+      </a:accent3>
+      <a:accent4>
+        <a:srgbClr val="0F9ED5"/>
+      </a:accent4>
+      <a:accent5>
+        <a:srgbClr val="A02B93"/>
+      </a:accent5>
+      <a:accent6>
+        <a:srgbClr val="4EA72E"/>
+      </a:accent6>
+      <a:hlink>
+        <a:srgbClr val="467886"/>
+      </a:hlink>
+      <a:folHlink>
+        <a:srgbClr val="96607D"/>
+      </a:folHlink>
+    </a:clrScheme>
+    <a:fontScheme name="Office">
+      <a:majorFont>
+        <a:latin typeface="Aptos Display" panose="02110004020202020204"/>
+        <a:ea typeface=""/>
+        <a:cs typeface=""/>
+        <a:font script="Jpan" typeface="游ゴシック Light"/>
+        <a:font script="Hang" typeface="맑은 고딕"/>
+        <a:font script="Hans" typeface="等线 Light"/>
+        <a:font script="Hant" typeface="新細明體"/>
+        <a:font script="Arab" typeface="Times New Roman"/>
+        <a:font script="Hebr" typeface="Times New Roman"/>
+        <a:font script="Thai" typeface="Angsana New"/>
+        <a:font script="Ethi" typeface="Nyala"/>
+        <a:font script="Beng" typeface="Vrinda"/>
+        <a:font script="Gujr" typeface="Shruti"/>
+        <a:font script="Khmr" typeface="MoolBoran"/>
+        <a:font script="Knda" typeface="Tunga"/>
+        <a:font script="Guru" typeface="Raavi"/>
+        <a:font script="Cans" typeface="Euphemia"/>
+        <a:font script="Cher" typeface="Plantagenet Cherokee"/>
+        <a:font script="Yiii" typeface="Microsoft Yi Baiti"/>
+        <a:font script="Tibt" typeface="Microsoft Himalaya"/>
+        <a:font script="Thaa" typeface="MV Boli"/>
+        <a:font script="Deva" typeface="Mangal"/>
+        <a:font script="Telu" typeface="Gautami"/>
+        <a:font script="Taml" typeface="Latha"/>
+        <a:font script="Syrc" typeface="Estrangelo Edessa"/>
+        <a:font script="Orya" typeface="Kalinga"/>
+        <a:font script="Mlym" typeface="Kartika"/>
+        <a:font script="Laoo" typeface="DokChampa"/>
+        <a:font script="Sinh" typeface="Iskoola Pota"/>
+        <a:font script="Mong" typeface="Mongolian Baiti"/>
+        <a:font script="Viet" typeface="Times New Roman"/>
+        <a:font script="Uigh" typeface="Microsoft Uighur"/>
+        <a:font script="Geor" typeface="Sylfaen"/>
+        <a:font script="Armn" typeface="Arial"/>
+        <a:font script="Bugi" typeface="Leelawadee UI"/>
+        <a:font script="Bopo" typeface="Microsoft JhengHei"/>
+        <a:font script="Java" typeface="Javanese Text"/>
+        <a:font script="Lisu" typeface="Segoe UI"/>
+        <a:font script="Mymr" typeface="Myanmar Text"/>
+        <a:font script="Nkoo" typeface="Ebrima"/>
+        <a:font script="Olck" typeface="Nirmala UI"/>
+        <a:font script="Osma" typeface="Ebrima"/>
+        <a:font script="Phag" typeface="Phagspa"/>
+        <a:font script="Syrn" typeface="Estrangelo Edessa"/>
+        <a:font script="Syrj" typeface="Estrangelo Edessa"/>
+        <a:font script="Syre" typeface="Estrangelo Edessa"/>
+        <a:font script="Sora" typeface="Nirmala UI"/>
+        <a:font script="Tale" typeface="Microsoft Tai Le"/>
+        <a:font script="Talu" typeface="Microsoft New Tai Lue"/>
+        <a:font script="Tfng" typeface="Ebrima"/>
+      </a:majorFont>
+      <a:minorFont>
+        <a:latin typeface="Aptos" panose="02110004020202020204"/>
+        <a:ea typeface=""/>
+        <a:cs typeface=""/>
+        <a:font script="Jpan" typeface="游ゴシック"/>
+        <a:font script="Hang" typeface="맑은 고딕"/>
+        <a:font script="Hans" typeface="等线"/>
+        <a:font script="Hant" typeface="新細明體"/>
+        <a:font script="Arab" typeface="Arial"/>
+        <a:font script="Hebr" typeface="Arial"/>
+        <a:font script="Thai" typeface="Cordia New"/>
+        <a:font script="Ethi" typeface="Nyala"/>
+        <a:font script="Beng" typeface="Vrinda"/>
+        <a:font script="Gujr" typeface="Shruti"/>
+        <a:font script="Khmr" typeface="DaunPenh"/>
+        <a:font script="Knda" typeface="Tunga"/>
+        <a:font script="Guru" typeface="Raavi"/>
+        <a:font script="Cans" typeface="Euphemia"/>
+        <a:font script="Cher" typeface="Plantagenet Cherokee"/>
+        <a:font script="Yiii" typeface="Microsoft Yi Baiti"/>
+        <a:font script="Tibt" typeface="Microsoft Himalaya"/>
+        <a:font script="Thaa" typeface="MV Boli"/>
+        <a:font script="Deva" typeface="Mangal"/>
+        <a:font script="Telu" typeface="Gautami"/>
+        <a:font script="Taml" typeface="Latha"/>
+        <a:font script="Syrc" typeface="Estrangelo Edessa"/>
+        <a:font script="Orya" typeface="Kalinga"/>
+        <a:font script="Mlym" typeface="Kartika"/>
+        <a:font script="Laoo" typeface="DokChampa"/>
+        <a:font script="Sinh" typeface="Iskoola Pota"/>
+        <a:font script="Mong" typeface="Mongolian Baiti"/>
+        <a:font script="Viet" typeface="Arial"/>
+        <a:font script="Uigh" typeface="Microsoft Uighur"/>
+        <a:font script="Geor" typeface="Sylfaen"/>
+        <a:font script="Armn" typeface="Arial"/>
+        <a:font script="Bugi" typeface="Leelawadee UI"/>
+        <a:font script="Bopo" typeface="Microsoft JhengHei"/>
+        <a:font script="Java" typeface="Javanese Text"/>
+        <a:font script="Lisu" typeface="Segoe UI"/>
+        <a:font script="Mymr" typeface="Myanmar Text"/>
+        <a:font script="Nkoo" typeface="Ebrima"/>
+        <a:font script="Olck" typeface="Nirmala UI"/>
+        <a:font script="Osma" typeface="Ebrima"/>
+        <a:font script="Phag" typeface="Phagspa"/>
+        <a:font script="Syrn" typeface="Estrangelo Edessa"/>
+        <a:font script="Syrj" typeface="Estrangelo Edessa"/>
+        <a:font script="Syre" typeface="Estrangelo Edessa"/>
+        <a:font script="Sora" typeface="Nirmala UI"/>
+        <a:font script="Tale" typeface="Microsoft Tai Le"/>
+        <a:font script="Talu" typeface="Microsoft New Tai Lue"/>
+        <a:font script="Tfng" typeface="Ebrima"/>
+      </a:minorFont>
+    </a:fontScheme>
+    <a:fmtScheme name="Office">
+      <a:fillStyleLst>
+        <a:solidFill>
+          <a:schemeClr val="phClr"/>
+        </a:solidFill>
+        <a:gradFill rotWithShape="1">
+          <a:gsLst>
+            <a:gs pos="0">
+              <a:schemeClr val="phClr">
+                <a:lumMod val="110000"/>
+                <a:satMod val="105000"/>
+                <a:tint val="67000"/>
+              </a:schemeClr>
+            </a:gs>
+            <a:gs pos="50000">
+              <a:schemeClr val="phClr">
+                <a:lumMod val="105000"/>
+                <a:satMod val="103000"/>
+                <a:tint val="73000"/>
+              </a:schemeClr>
+            </a:gs>
+            <a:gs pos="100000">
+              <a:schemeClr val="phClr">
+                <a:lumMod val="105000"/>
+                <a:satMod val="109000"/>
+                <a:tint val="81000"/>
+              </a:schemeClr>
+            </a:gs>
+          </a:gsLst>
+          <a:lin ang="5400000" scaled="0"/>
+        </a:gradFill>
+        <a:gradFill rotWithShape="1">
+          <a:gsLst>
+            <a:gs pos="0">
+              <a:schemeClr val="phClr">
+                <a:satMod val="103000"/>
+                <a:lumMod val="102000"/>
+                <a:tint val="94000"/>
+              </a:schemeClr>
+            </a:gs>
+            <a:gs pos="50000">
+              <a:schemeClr val="phClr">
+                <a:satMod val="110000"/>
+                <a:lumMod val="100000"/>
+                <a:shade val="100000"/>
+              </a:schemeClr>
+            </a:gs>
+            <a:gs pos="100000">
+              <a:schemeClr val="phClr">
+                <a:lumMod val="99000"/>
+                <a:satMod val="120000"/>
+                <a:shade val="78000"/>
+              </a:schemeClr>
+            </a:gs>
+          </a:gsLst>
+          <a:lin ang="5400000" scaled="0"/>
+        </a:gradFill>
+      </a:fillStyleLst>
+      <a:lnStyleLst>
+        <a:ln w="12700" cap="flat" cmpd="sng" algn="ctr">
+          <a:solidFill>
+            <a:schemeClr val="phClr"/>
+          </a:solidFill>
+          <a:prstDash val="solid"/>
+          <a:miter lim="800000"/>
+        </a:ln>
+        <a:ln w="19050" cap="flat" cmpd="sng" algn="ctr">
+          <a:solidFill>
+            <a:schemeClr val="phClr"/>
+          </a:solidFill>
+          <a:prstDash val="solid"/>
+          <a:miter lim="800000"/>
+        </a:ln>
+        <a:ln w="25400" cap="flat" cmpd="sng" algn="ctr">
+          <a:solidFill>
+            <a:schemeClr val="phClr"/>
+          </a:solidFill>
+          <a:prstDash val="solid"/>
+          <a:miter lim="800000"/>
+        </a:ln>
+      </a:lnStyleLst>
+      <a:effectStyleLst>
+        <a:effectStyle>
+          <a:effectLst/>
+        </a:effectStyle>
+        <a:effectStyle>
+          <a:effectLst/>
+        </a:effectStyle>
+        <a:effectStyle>
+          <a:effectLst>
+            <a:outerShdw blurRad="57150" dist="19050" dir="5400000" algn="ctr" rotWithShape="0">
+              <a:srgbClr val="000000">
+                <a:alpha val="63000"/>
+              </a:srgbClr>
+            </a:outerShdw>
+          </a:effectLst>
+        </a:effectStyle>
+      </a:effectStyleLst>
+      <a:bgFillStyleLst>
+        <a:solidFill>
+          <a:schemeClr val="phClr"/>
+        </a:solidFill>
+        <a:solidFill>
+          <a:schemeClr val="phClr">
+            <a:tint val="95000"/>
+            <a:satMod val="170000"/>
+          </a:schemeClr>
+        </a:solidFill>
+        <a:gradFill rotWithShape="1">
+          <a:gsLst>
+            <a:gs pos="0">
+              <a:schemeClr val="phClr">
+                <a:tint val="93000"/>
+                <a:satMod val="150000"/>
+                <a:shade val="98000"/>
+                <a:lumMod val="102000"/>
+              </a:schemeClr>
+            </a:gs>
+            <a:gs pos="50000">
+              <a:schemeClr val="phClr">
+                <a:tint val="98000"/>
+                <a:satMod val="130000"/>
+                <a:shade val="90000"/>
+                <a:lumMod val="103000"/>
+              </a:schemeClr>
+            </a:gs>
+            <a:gs pos="100000">
+              <a:schemeClr val="phClr">
+                <a:shade val="63000"/>
+                <a:satMod val="120000"/>
+              </a:schemeClr>
+            </a:gs>
+          </a:gsLst>
+          <a:lin ang="5400000" scaled="0"/>
+        </a:gradFill>
+      </a:bgFillStyleLst>
+    </a:fmtScheme>
+  </a:themeElements>
+  <a:objectDefaults>
+    <a:lnDef>
+      <a:spPr/>
+      <a:bodyPr/>
+      <a:lstStyle/>
+      <a:style>
+        <a:lnRef idx="2">
+          <a:schemeClr val="accent1"/>
+        </a:lnRef>
+        <a:fillRef idx="0">
+          <a:schemeClr val="accent1"/>
+        </a:fillRef>
+        <a:effectRef idx="1">
+          <a:schemeClr val="accent1"/>
+        </a:effectRef>
+        <a:fontRef idx="minor">
+          <a:schemeClr val="tx1"/>
+        </a:fontRef>
+      </a:style>
+    </a:lnDef>
+  </a:objectDefaults>
+  <a:extraClrSchemeLst/>
+  <a:extLst>
+    <a:ext uri="{05A4C25C-085E-4340-85A3-A5531E510DB2}">
+      <thm15:themeFamily xmlns:thm15="http://schemas.microsoft.com/office/thememl/2012/main" name="Office Theme" id="{2E142A2C-CD16-42D6-873A-C26D2A0506FA}" vid="{1BDDFF52-6CD6-40A5-AB3C-68EB2F1E4D0A}"/>
+    </a:ext>
+  </a:extLst>
+</a:theme>
 </file>
</xml_diff>